<commit_message>
Retira 'em operação' dos sistemas DF na apresentação e nos relatórios
Co-Authored-By: Claude Opus 5.5 <noreply@anthropic.com>
Claude-Session: https://claude.ai/code/session_01EsMNgjuF6bLvLuQZ87HmRr
</commit_message>
<xml_diff>
--- a/entregas/apresentacao-13-10/DF_Apresentacao_Einstein_13-10.pptx
+++ b/entregas/apresentacao-13-10/DF_Apresentacao_Einstein_13-10.pptx
@@ -129,19 +129,19 @@
   <p:extLst>
     <p:ext uri="{521415D9-36F7-43E2-AB2F-B90AF26B5E84}">
       <p14:sectionLst xmlns:p14="http://schemas.microsoft.com/office/powerpoint/2010/main">
-        <p14:section name="Abertura" id="{d22293f7-6e42-a9ca-299e-968f896258a2}">
+        <p14:section name="Abertura" id="{35790ced-f017-4c6a-a533-330e1ff4659f}">
           <p14:sldIdLst>
             <p14:sldId id="256"/>
             <p14:sldId id="257"/>
           </p14:sldIdLst>
         </p14:section>
-        <p14:section name="O que entendemos" id="{68520128-8902-a286-62fa-ea472af668a0}">
+        <p14:section name="O que entendemos" id="{a5506870-f752-314e-c560-fad4030725a5}">
           <p14:sldIdLst>
             <p14:sldId id="258"/>
             <p14:sldId id="259"/>
           </p14:sldIdLst>
         </p14:section>
-        <p14:section name="Quem é a DF" id="{76f1d299-85e7-f8a1-4532-2d29fa01afed}">
+        <p14:section name="Quem é a DF" id="{ff33c136-fea3-89c3-c535-5c8d7fbd856f}">
           <p14:sldIdLst>
             <p14:sldId id="260"/>
             <p14:sldId id="261"/>
@@ -149,7 +149,7 @@
             <p14:sldId id="263"/>
           </p14:sldIdLst>
         </p14:section>
-        <p14:section name="Como vamos atuar" id="{087a4820-b903-d3ca-f83f-c88210ccef35}">
+        <p14:section name="Como vamos atuar" id="{c4e231ec-b1bc-c551-d386-9e0ecf2a8f0f}">
           <p14:sldIdLst>
             <p14:sldId id="264"/>
             <p14:sldId id="265"/>
@@ -157,28 +157,28 @@
             <p14:sldId id="267"/>
           </p14:sldIdLst>
         </p14:section>
-        <p14:section name="O que o Einstein recebe" id="{e303e1f8-d744-8b93-2a6b-0968bea5f325}">
+        <p14:section name="O que o Einstein recebe" id="{33ffae1d-2f59-2cad-cb24-b58a4029fff3}">
           <p14:sldIdLst>
             <p14:sldId id="268"/>
             <p14:sldId id="269"/>
             <p14:sldId id="270"/>
           </p14:sldIdLst>
         </p14:section>
-        <p14:section name="Como a DF controla" id="{0624dbdb-d90a-366f-9bd8-a239e2b6c20d}">
+        <p14:section name="Como a DF controla" id="{66b03f3f-c7e6-ca6f-9791-186d56a24c8d}">
           <p14:sldIdLst>
             <p14:sldId id="271"/>
             <p14:sldId id="272"/>
             <p14:sldId id="273"/>
           </p14:sldIdLst>
         </p14:section>
-        <p14:section name="Escopo e premissas" id="{5daf3c12-f14a-0451-854b-28d9d34c599f}">
+        <p14:section name="Escopo e premissas" id="{8fb0dc75-fc00-491b-4b2b-3bc798a8b31d}">
           <p14:sldIdLst>
             <p14:sldId id="274"/>
             <p14:sldId id="275"/>
             <p14:sldId id="276"/>
           </p14:sldIdLst>
         </p14:section>
-        <p14:section name="Apoio para perguntas" id="{5fa9b54b-bfed-7a74-02f4-f7d422343411}">
+        <p14:section name="Apoio para perguntas" id="{5efe36a8-cf5e-b960-471f-328751e5d79e}">
           <p14:sldIdLst>
             <p14:sldId id="277"/>
             <p14:sldId id="278"/>
@@ -2092,7 +2092,7 @@
           <a:p>
             <a:r>
               <a:rPr lang="en-US" dirty="0"/>
-              <a:t>CAIO: sistema desenvolvido pela DF e em operação. Mostrar que a fiscalização da administradora é feita com dados. Não é um sistema que o Einstein precisa usar — é a ferramenta da DF que alimenta os relatórios. Se perguntarem sobre LGPD: dados nos ambientes autorizados, acesso por usuário.</a:t>
+              <a:t>CAIO: sistema desenvolvido pela DF. Mostrar que a fiscalização da administradora é feita com dados. Não é um sistema que o Einstein precisa usar — é a ferramenta da DF que alimenta os relatórios. Se perguntarem sobre LGPD: dados nos ambientes autorizados, acesso por usuário.</a:t>
             </a:r>
             <a:endParaRPr lang="en-US" dirty="0"/>
           </a:p>
@@ -2180,7 +2180,7 @@
           <a:p>
             <a:r>
               <a:rPr lang="en-US" dirty="0"/>
-              <a:t>CAIO: duas automações da DF em operação. A triagem diária garante que nenhuma demanda se perca entre e-mails; a cobrança semanal mantém a documentação legal dos prédios em dia. Ligar com o slide de SLA.</a:t>
+              <a:t>CAIO: duas automações da DF. A triagem diária garante que nenhuma demanda se perca entre e-mails; a cobrança semanal mantém a documentação legal dos prédios em dia. Ligar com o slide de SLA.</a:t>
             </a:r>
             <a:endParaRPr lang="en-US" dirty="0"/>
           </a:p>
@@ -12226,70 +12226,7 @@
       </p:sp>
       <p:sp>
         <p:nvSpPr>
-          <p:cNvPr id="4" name="etiqueta-operacao"/>
-          <p:cNvSpPr/>
-          <p:nvPr/>
-        </p:nvSpPr>
-        <p:spPr>
-          <a:xfrm>
-            <a:off x="10241280" y="1024128"/>
-            <a:ext cx="1417320" cy="347472"/>
-          </a:xfrm>
-          <a:prstGeom prst="roundRect">
-            <a:avLst>
-              <a:gd name="adj" fmla="val 50000"/>
-            </a:avLst>
-          </a:prstGeom>
-          <a:solidFill>
-            <a:srgbClr val="2E7D5C"/>
-          </a:solidFill>
-          <a:ln w="12700">
-            <a:solidFill>
-              <a:srgbClr val="2E7D5C"/>
-            </a:solidFill>
-            <a:prstDash val="solid"/>
-          </a:ln>
-        </p:spPr>
-      </p:sp>
-      <p:sp>
-        <p:nvSpPr>
-          <p:cNvPr id="5" name="Text 3"/>
-          <p:cNvSpPr txBox="1"/>
-          <p:nvPr/>
-        </p:nvSpPr>
-        <p:spPr>
-          <a:xfrm>
-            <a:off x="10241280" y="1024128"/>
-            <a:ext cx="1417320" cy="347472"/>
-          </a:xfrm>
-          <a:prstGeom prst="rect">
-            <a:avLst/>
-          </a:prstGeom>
-          <a:noFill/>
-          <a:ln/>
-        </p:spPr>
-        <p:txBody>
-          <a:bodyPr wrap="square" lIns="0" tIns="0" rIns="0" bIns="0" rtlCol="0" anchor="ctr"/>
-          <a:lstStyle/>
-          <a:p>
-            <a:pPr algn="ctr" indent="0" marL="0">
-              <a:buNone/>
-            </a:pPr>
-            <a:r>
-              <a:rPr lang="en-US" sz="1050" b="1" spc="100" kern="0" dirty="0">
-                <a:solidFill>
-                  <a:srgbClr val="FFFFFF"/>
-                </a:solidFill>
-              </a:rPr>
-              <a:t>EM OPERAÇÃO</a:t>
-            </a:r>
-            <a:endParaRPr lang="en-US" sz="1050" dirty="0"/>
-          </a:p>
-        </p:txBody>
-      </p:sp>
-      <p:sp>
-        <p:nvSpPr>
-          <p:cNvPr id="6" name="celular"/>
+          <p:cNvPr id="4" name="celular"/>
           <p:cNvSpPr/>
           <p:nvPr/>
         </p:nvSpPr>
@@ -12316,7 +12253,7 @@
       </p:sp>
       <p:sp>
         <p:nvSpPr>
-          <p:cNvPr id="7" name="tela"/>
+          <p:cNvPr id="5" name="tela"/>
           <p:cNvSpPr/>
           <p:nvPr/>
         </p:nvSpPr>
@@ -12343,7 +12280,7 @@
       </p:sp>
       <p:sp>
         <p:nvSpPr>
-          <p:cNvPr id="8" name="Text 6"/>
+          <p:cNvPr id="6" name="Text 4"/>
           <p:cNvSpPr txBox="1"/>
           <p:nvPr/>
         </p:nvSpPr>
@@ -12379,7 +12316,7 @@
       </p:sp>
       <p:sp>
         <p:nvSpPr>
-          <p:cNvPr id="9" name="item-check"/>
+          <p:cNvPr id="7" name="item-check"/>
           <p:cNvSpPr/>
           <p:nvPr/>
         </p:nvSpPr>
@@ -12406,7 +12343,7 @@
       </p:sp>
       <p:pic>
         <p:nvPicPr>
-          <p:cNvPr id="10" name="status" descr="preencoded.png">    </p:cNvPr>
+          <p:cNvPr id="8" name="status" descr="preencoded.png">    </p:cNvPr>
           <p:cNvPicPr>
             <a:picLocks noChangeAspect="1"/>
           </p:cNvPicPr>
@@ -12430,7 +12367,7 @@
       </p:pic>
       <p:sp>
         <p:nvSpPr>
-          <p:cNvPr id="11" name="Text 8"/>
+          <p:cNvPr id="9" name="Text 6"/>
           <p:cNvSpPr txBox="1"/>
           <p:nvPr/>
         </p:nvSpPr>
@@ -12466,7 +12403,7 @@
       </p:sp>
       <p:sp>
         <p:nvSpPr>
-          <p:cNvPr id="12" name="item-check"/>
+          <p:cNvPr id="10" name="item-check"/>
           <p:cNvSpPr/>
           <p:nvPr/>
         </p:nvSpPr>
@@ -12493,7 +12430,7 @@
       </p:sp>
       <p:pic>
         <p:nvPicPr>
-          <p:cNvPr id="13" name="status" descr="preencoded.png">    </p:cNvPr>
+          <p:cNvPr id="11" name="status" descr="preencoded.png">    </p:cNvPr>
           <p:cNvPicPr>
             <a:picLocks noChangeAspect="1"/>
           </p:cNvPicPr>
@@ -12517,7 +12454,7 @@
       </p:pic>
       <p:sp>
         <p:nvSpPr>
-          <p:cNvPr id="14" name="Text 10"/>
+          <p:cNvPr id="12" name="Text 8"/>
           <p:cNvSpPr txBox="1"/>
           <p:nvPr/>
         </p:nvSpPr>
@@ -12553,7 +12490,7 @@
       </p:sp>
       <p:sp>
         <p:nvSpPr>
-          <p:cNvPr id="15" name="item-check"/>
+          <p:cNvPr id="13" name="item-check"/>
           <p:cNvSpPr/>
           <p:nvPr/>
         </p:nvSpPr>
@@ -12580,7 +12517,7 @@
       </p:sp>
       <p:pic>
         <p:nvPicPr>
-          <p:cNvPr id="16" name="status" descr="preencoded.png">    </p:cNvPr>
+          <p:cNvPr id="14" name="status" descr="preencoded.png">    </p:cNvPr>
           <p:cNvPicPr>
             <a:picLocks noChangeAspect="1"/>
           </p:cNvPicPr>
@@ -12604,7 +12541,7 @@
       </p:pic>
       <p:sp>
         <p:nvSpPr>
-          <p:cNvPr id="17" name="Text 12"/>
+          <p:cNvPr id="15" name="Text 10"/>
           <p:cNvSpPr txBox="1"/>
           <p:nvPr/>
         </p:nvSpPr>
@@ -12640,7 +12577,7 @@
       </p:sp>
       <p:sp>
         <p:nvSpPr>
-          <p:cNvPr id="18" name="item-check"/>
+          <p:cNvPr id="16" name="item-check"/>
           <p:cNvSpPr/>
           <p:nvPr/>
         </p:nvSpPr>
@@ -12667,7 +12604,7 @@
       </p:sp>
       <p:pic>
         <p:nvPicPr>
-          <p:cNvPr id="19" name="status" descr="preencoded.png">    </p:cNvPr>
+          <p:cNvPr id="17" name="status" descr="preencoded.png">    </p:cNvPr>
           <p:cNvPicPr>
             <a:picLocks noChangeAspect="1"/>
           </p:cNvPicPr>
@@ -12691,7 +12628,7 @@
       </p:pic>
       <p:sp>
         <p:nvSpPr>
-          <p:cNvPr id="20" name="Text 14"/>
+          <p:cNvPr id="18" name="Text 12"/>
           <p:cNvSpPr txBox="1"/>
           <p:nvPr/>
         </p:nvSpPr>
@@ -12727,7 +12664,7 @@
       </p:sp>
       <p:sp>
         <p:nvSpPr>
-          <p:cNvPr id="21" name="item-check"/>
+          <p:cNvPr id="19" name="item-check"/>
           <p:cNvSpPr/>
           <p:nvPr/>
         </p:nvSpPr>
@@ -12754,7 +12691,7 @@
       </p:sp>
       <p:pic>
         <p:nvPicPr>
-          <p:cNvPr id="22" name="status" descr="preencoded.png">    </p:cNvPr>
+          <p:cNvPr id="20" name="status" descr="preencoded.png">    </p:cNvPr>
           <p:cNvPicPr>
             <a:picLocks noChangeAspect="1"/>
           </p:cNvPicPr>
@@ -12778,7 +12715,7 @@
       </p:pic>
       <p:sp>
         <p:nvSpPr>
-          <p:cNvPr id="23" name="Text 16"/>
+          <p:cNvPr id="21" name="Text 14"/>
           <p:cNvSpPr txBox="1"/>
           <p:nvPr/>
         </p:nvSpPr>
@@ -12814,7 +12751,7 @@
       </p:sp>
       <p:sp>
         <p:nvSpPr>
-          <p:cNvPr id="24" name="item-check"/>
+          <p:cNvPr id="22" name="item-check"/>
           <p:cNvSpPr/>
           <p:nvPr/>
         </p:nvSpPr>
@@ -12841,7 +12778,7 @@
       </p:sp>
       <p:pic>
         <p:nvPicPr>
-          <p:cNvPr id="25" name="status" descr="preencoded.png">    </p:cNvPr>
+          <p:cNvPr id="23" name="status" descr="preencoded.png">    </p:cNvPr>
           <p:cNvPicPr>
             <a:picLocks noChangeAspect="1"/>
           </p:cNvPicPr>
@@ -12865,7 +12802,7 @@
       </p:pic>
       <p:sp>
         <p:nvSpPr>
-          <p:cNvPr id="26" name="Text 18"/>
+          <p:cNvPr id="24" name="Text 16"/>
           <p:cNvSpPr txBox="1"/>
           <p:nvPr/>
         </p:nvSpPr>
@@ -12901,7 +12838,7 @@
       </p:sp>
       <p:sp>
         <p:nvSpPr>
-          <p:cNvPr id="27" name="botao"/>
+          <p:cNvPr id="25" name="botao"/>
           <p:cNvSpPr/>
           <p:nvPr/>
         </p:nvSpPr>
@@ -12928,7 +12865,7 @@
       </p:sp>
       <p:sp>
         <p:nvSpPr>
-          <p:cNvPr id="28" name="Text 20"/>
+          <p:cNvPr id="26" name="Text 18"/>
           <p:cNvSpPr txBox="1"/>
           <p:nvPr/>
         </p:nvSpPr>
@@ -12964,7 +12901,7 @@
       </p:sp>
       <p:sp>
         <p:nvSpPr>
-          <p:cNvPr id="29" name="Text 21"/>
+          <p:cNvPr id="27" name="Text 19"/>
           <p:cNvSpPr txBox="1"/>
           <p:nvPr/>
         </p:nvSpPr>
@@ -13000,7 +12937,7 @@
       </p:sp>
       <p:sp>
         <p:nvSpPr>
-          <p:cNvPr id="30" name="boletim-0"/>
+          <p:cNvPr id="28" name="boletim-0"/>
           <p:cNvSpPr/>
           <p:nvPr/>
         </p:nvSpPr>
@@ -13027,7 +12964,7 @@
       </p:sp>
       <p:sp>
         <p:nvSpPr>
-          <p:cNvPr id="31" name="icone-fundo"/>
+          <p:cNvPr id="29" name="icone-fundo"/>
           <p:cNvSpPr/>
           <p:nvPr/>
         </p:nvSpPr>
@@ -13052,7 +12989,7 @@
       </p:sp>
       <p:pic>
         <p:nvPicPr>
-          <p:cNvPr id="32" name="icone" descr="preencoded.png">    </p:cNvPr>
+          <p:cNvPr id="30" name="icone" descr="preencoded.png">    </p:cNvPr>
           <p:cNvPicPr>
             <a:picLocks noChangeAspect="1"/>
           </p:cNvPicPr>
@@ -13076,7 +13013,7 @@
       </p:pic>
       <p:sp>
         <p:nvSpPr>
-          <p:cNvPr id="33" name="Text 24"/>
+          <p:cNvPr id="31" name="Text 22"/>
           <p:cNvSpPr txBox="1"/>
           <p:nvPr/>
         </p:nvSpPr>
@@ -13112,7 +13049,7 @@
       </p:sp>
       <p:sp>
         <p:nvSpPr>
-          <p:cNvPr id="34" name="Text 25"/>
+          <p:cNvPr id="32" name="Text 23"/>
           <p:cNvSpPr txBox="1"/>
           <p:nvPr/>
         </p:nvSpPr>
@@ -13148,7 +13085,7 @@
       </p:sp>
       <p:sp>
         <p:nvSpPr>
-          <p:cNvPr id="35" name="boletim-1"/>
+          <p:cNvPr id="33" name="boletim-1"/>
           <p:cNvSpPr/>
           <p:nvPr/>
         </p:nvSpPr>
@@ -13175,7 +13112,7 @@
       </p:sp>
       <p:sp>
         <p:nvSpPr>
-          <p:cNvPr id="36" name="icone-fundo"/>
+          <p:cNvPr id="34" name="icone-fundo"/>
           <p:cNvSpPr/>
           <p:nvPr/>
         </p:nvSpPr>
@@ -13200,7 +13137,7 @@
       </p:sp>
       <p:pic>
         <p:nvPicPr>
-          <p:cNvPr id="37" name="icone" descr="preencoded.png">    </p:cNvPr>
+          <p:cNvPr id="35" name="icone" descr="preencoded.png">    </p:cNvPr>
           <p:cNvPicPr>
             <a:picLocks noChangeAspect="1"/>
           </p:cNvPicPr>
@@ -13224,7 +13161,7 @@
       </p:pic>
       <p:sp>
         <p:nvSpPr>
-          <p:cNvPr id="38" name="Text 28"/>
+          <p:cNvPr id="36" name="Text 26"/>
           <p:cNvSpPr txBox="1"/>
           <p:nvPr/>
         </p:nvSpPr>
@@ -13260,7 +13197,7 @@
       </p:sp>
       <p:sp>
         <p:nvSpPr>
-          <p:cNvPr id="39" name="Text 29"/>
+          <p:cNvPr id="37" name="Text 27"/>
           <p:cNvSpPr txBox="1"/>
           <p:nvPr/>
         </p:nvSpPr>
@@ -13296,7 +13233,7 @@
       </p:sp>
       <p:sp>
         <p:nvSpPr>
-          <p:cNvPr id="40" name="boletim-2"/>
+          <p:cNvPr id="38" name="boletim-2"/>
           <p:cNvSpPr/>
           <p:nvPr/>
         </p:nvSpPr>
@@ -13323,7 +13260,7 @@
       </p:sp>
       <p:sp>
         <p:nvSpPr>
-          <p:cNvPr id="41" name="icone-fundo"/>
+          <p:cNvPr id="39" name="icone-fundo"/>
           <p:cNvSpPr/>
           <p:nvPr/>
         </p:nvSpPr>
@@ -13348,7 +13285,7 @@
       </p:sp>
       <p:pic>
         <p:nvPicPr>
-          <p:cNvPr id="42" name="icone" descr="preencoded.png">    </p:cNvPr>
+          <p:cNvPr id="40" name="icone" descr="preencoded.png">    </p:cNvPr>
           <p:cNvPicPr>
             <a:picLocks noChangeAspect="1"/>
           </p:cNvPicPr>
@@ -13372,7 +13309,7 @@
       </p:pic>
       <p:sp>
         <p:nvSpPr>
-          <p:cNvPr id="43" name="Text 32"/>
+          <p:cNvPr id="41" name="Text 30"/>
           <p:cNvSpPr txBox="1"/>
           <p:nvPr/>
         </p:nvSpPr>
@@ -13408,7 +13345,7 @@
       </p:sp>
       <p:sp>
         <p:nvSpPr>
-          <p:cNvPr id="44" name="Text 33"/>
+          <p:cNvPr id="42" name="Text 31"/>
           <p:cNvSpPr txBox="1"/>
           <p:nvPr/>
         </p:nvSpPr>
@@ -13444,7 +13381,7 @@
       </p:sp>
       <p:sp>
         <p:nvSpPr>
-          <p:cNvPr id="45" name="boletim-3"/>
+          <p:cNvPr id="43" name="boletim-3"/>
           <p:cNvSpPr/>
           <p:nvPr/>
         </p:nvSpPr>
@@ -13471,7 +13408,7 @@
       </p:sp>
       <p:sp>
         <p:nvSpPr>
-          <p:cNvPr id="46" name="icone-fundo"/>
+          <p:cNvPr id="44" name="icone-fundo"/>
           <p:cNvSpPr/>
           <p:nvPr/>
         </p:nvSpPr>
@@ -13496,7 +13433,7 @@
       </p:sp>
       <p:pic>
         <p:nvPicPr>
-          <p:cNvPr id="47" name="icone" descr="preencoded.png">    </p:cNvPr>
+          <p:cNvPr id="45" name="icone" descr="preencoded.png">    </p:cNvPr>
           <p:cNvPicPr>
             <a:picLocks noChangeAspect="1"/>
           </p:cNvPicPr>
@@ -13520,7 +13457,7 @@
       </p:pic>
       <p:sp>
         <p:nvSpPr>
-          <p:cNvPr id="48" name="Text 36"/>
+          <p:cNvPr id="46" name="Text 34"/>
           <p:cNvSpPr txBox="1"/>
           <p:nvPr/>
         </p:nvSpPr>
@@ -13556,7 +13493,7 @@
       </p:sp>
       <p:sp>
         <p:nvSpPr>
-          <p:cNvPr id="49" name="Text 37"/>
+          <p:cNvPr id="47" name="Text 35"/>
           <p:cNvSpPr txBox="1"/>
           <p:nvPr/>
         </p:nvSpPr>
@@ -13592,7 +13529,7 @@
       </p:sp>
       <p:sp>
         <p:nvSpPr>
-          <p:cNvPr id="50" name="beneficio-boletim"/>
+          <p:cNvPr id="48" name="beneficio-boletim"/>
           <p:cNvSpPr/>
           <p:nvPr/>
         </p:nvSpPr>
@@ -13619,7 +13556,7 @@
       </p:sp>
       <p:sp>
         <p:nvSpPr>
-          <p:cNvPr id="51" name="Text 39"/>
+          <p:cNvPr id="49" name="Text 37"/>
           <p:cNvSpPr txBox="1"/>
           <p:nvPr/>
         </p:nvSpPr>
@@ -13817,11 +13754,11 @@
         <p:spPr>
           <a:xfrm>
             <a:off x="548640" y="1600200"/>
-            <a:ext cx="5394960" cy="3657600"/>
+            <a:ext cx="5394960" cy="3429000"/>
           </a:xfrm>
           <a:prstGeom prst="roundRect">
             <a:avLst>
-              <a:gd name="adj" fmla="val 2000"/>
+              <a:gd name="adj" fmla="val 2133"/>
             </a:avLst>
           </a:prstGeom>
           <a:solidFill>
@@ -14247,80 +14184,20 @@
           </a:p>
         </p:txBody>
       </p:sp>
-      <p:pic>
-        <p:nvPicPr>
-          <p:cNvPr id="18" name="ok" descr="preencoded.png">    </p:cNvPr>
-          <p:cNvPicPr>
-            <a:picLocks noChangeAspect="1"/>
-          </p:cNvPicPr>
-          <p:nvPr/>
-        </p:nvPicPr>
-        <p:blipFill>
-          <a:blip r:embed="rId2"/>
-          <a:stretch>
-            <a:fillRect/>
-          </a:stretch>
-        </p:blipFill>
-        <p:spPr>
-          <a:xfrm>
-            <a:off x="868680" y="4773168"/>
-            <a:ext cx="256032" cy="256032"/>
-          </a:xfrm>
-          <a:prstGeom prst="rect">
-            <a:avLst/>
-          </a:prstGeom>
-        </p:spPr>
-      </p:pic>
-      <p:sp>
-        <p:nvSpPr>
-          <p:cNvPr id="19" name="Text 15"/>
-          <p:cNvSpPr txBox="1"/>
-          <p:nvPr/>
-        </p:nvSpPr>
-        <p:spPr>
-          <a:xfrm>
-            <a:off x="1234440" y="4727448"/>
-            <a:ext cx="4480560" cy="347472"/>
-          </a:xfrm>
-          <a:prstGeom prst="rect">
-            <a:avLst/>
-          </a:prstGeom>
-          <a:noFill/>
-          <a:ln/>
-        </p:spPr>
-        <p:txBody>
-          <a:bodyPr wrap="square" lIns="0" tIns="0" rIns="0" bIns="0" rtlCol="0" anchor="ctr"/>
-          <a:lstStyle/>
-          <a:p>
-            <a:pPr indent="0" marL="0">
-              <a:buNone/>
-            </a:pPr>
-            <a:r>
-              <a:rPr lang="en-US" sz="1300" b="1" dirty="0">
-                <a:solidFill>
-                  <a:schemeClr val="accent6"/>
-                </a:solidFill>
-              </a:rPr>
-              <a:t>Em operação desde agosto de 2026</a:t>
-            </a:r>
-            <a:endParaRPr lang="en-US" sz="1300" dirty="0"/>
-          </a:p>
-        </p:txBody>
-      </p:sp>
-      <p:sp>
-        <p:nvSpPr>
-          <p:cNvPr id="20" name="rotina-1"/>
+      <p:sp>
+        <p:nvSpPr>
+          <p:cNvPr id="18" name="rotina-1"/>
           <p:cNvSpPr/>
           <p:nvPr/>
         </p:nvSpPr>
         <p:spPr>
           <a:xfrm>
             <a:off x="6172200" y="1600200"/>
-            <a:ext cx="5394960" cy="3657600"/>
+            <a:ext cx="5394960" cy="3429000"/>
           </a:xfrm>
           <a:prstGeom prst="roundRect">
             <a:avLst>
-              <a:gd name="adj" fmla="val 2000"/>
+              <a:gd name="adj" fmla="val 2133"/>
             </a:avLst>
           </a:prstGeom>
           <a:solidFill>
@@ -14336,7 +14213,7 @@
       </p:sp>
       <p:sp>
         <p:nvSpPr>
-          <p:cNvPr id="21" name="icone-fundo"/>
+          <p:cNvPr id="19" name="icone-fundo"/>
           <p:cNvSpPr/>
           <p:nvPr/>
         </p:nvSpPr>
@@ -14361,14 +14238,14 @@
       </p:sp>
       <p:pic>
         <p:nvPicPr>
-          <p:cNvPr id="22" name="icone" descr="preencoded.png">    </p:cNvPr>
+          <p:cNvPr id="20" name="icone" descr="preencoded.png">    </p:cNvPr>
           <p:cNvPicPr>
             <a:picLocks noChangeAspect="1"/>
           </p:cNvPicPr>
           <p:nvPr/>
         </p:nvPicPr>
         <p:blipFill>
-          <a:blip r:embed="rId3"/>
+          <a:blip r:embed="rId2"/>
           <a:stretch>
             <a:fillRect/>
           </a:stretch>
@@ -14385,7 +14262,7 @@
       </p:pic>
       <p:sp>
         <p:nvSpPr>
-          <p:cNvPr id="23" name="Text 18"/>
+          <p:cNvPr id="21" name="Text 17"/>
           <p:cNvSpPr txBox="1"/>
           <p:nvPr/>
         </p:nvSpPr>
@@ -14421,7 +14298,7 @@
       </p:sp>
       <p:sp>
         <p:nvSpPr>
-          <p:cNvPr id="24" name="Text 19"/>
+          <p:cNvPr id="22" name="Text 18"/>
           <p:cNvSpPr txBox="1"/>
           <p:nvPr/>
         </p:nvSpPr>
@@ -14457,7 +14334,7 @@
       </p:sp>
       <p:sp>
         <p:nvSpPr>
-          <p:cNvPr id="25" name="passo"/>
+          <p:cNvPr id="23" name="passo"/>
           <p:cNvSpPr/>
           <p:nvPr/>
         </p:nvSpPr>
@@ -14482,7 +14359,7 @@
       </p:sp>
       <p:sp>
         <p:nvSpPr>
-          <p:cNvPr id="26" name="Text 21"/>
+          <p:cNvPr id="24" name="Text 20"/>
           <p:cNvSpPr txBox="1"/>
           <p:nvPr/>
         </p:nvSpPr>
@@ -14518,7 +14395,7 @@
       </p:sp>
       <p:sp>
         <p:nvSpPr>
-          <p:cNvPr id="27" name="Text 22"/>
+          <p:cNvPr id="25" name="Text 21"/>
           <p:cNvSpPr txBox="1"/>
           <p:nvPr/>
         </p:nvSpPr>
@@ -14554,7 +14431,7 @@
       </p:sp>
       <p:sp>
         <p:nvSpPr>
-          <p:cNvPr id="28" name="passo"/>
+          <p:cNvPr id="26" name="passo"/>
           <p:cNvSpPr/>
           <p:nvPr/>
         </p:nvSpPr>
@@ -14579,7 +14456,7 @@
       </p:sp>
       <p:sp>
         <p:nvSpPr>
-          <p:cNvPr id="29" name="Text 24"/>
+          <p:cNvPr id="27" name="Text 23"/>
           <p:cNvSpPr txBox="1"/>
           <p:nvPr/>
         </p:nvSpPr>
@@ -14615,7 +14492,7 @@
       </p:sp>
       <p:sp>
         <p:nvSpPr>
-          <p:cNvPr id="30" name="Text 25"/>
+          <p:cNvPr id="28" name="Text 24"/>
           <p:cNvSpPr txBox="1"/>
           <p:nvPr/>
         </p:nvSpPr>
@@ -14651,7 +14528,7 @@
       </p:sp>
       <p:sp>
         <p:nvSpPr>
-          <p:cNvPr id="31" name="passo"/>
+          <p:cNvPr id="29" name="passo"/>
           <p:cNvSpPr/>
           <p:nvPr/>
         </p:nvSpPr>
@@ -14676,7 +14553,7 @@
       </p:sp>
       <p:sp>
         <p:nvSpPr>
-          <p:cNvPr id="32" name="Text 27"/>
+          <p:cNvPr id="30" name="Text 26"/>
           <p:cNvSpPr txBox="1"/>
           <p:nvPr/>
         </p:nvSpPr>
@@ -14712,7 +14589,7 @@
       </p:sp>
       <p:sp>
         <p:nvSpPr>
-          <p:cNvPr id="33" name="Text 28"/>
+          <p:cNvPr id="31" name="Text 27"/>
           <p:cNvSpPr txBox="1"/>
           <p:nvPr/>
         </p:nvSpPr>
@@ -14746,69 +14623,9 @@
           </a:p>
         </p:txBody>
       </p:sp>
-      <p:pic>
-        <p:nvPicPr>
-          <p:cNvPr id="34" name="ok" descr="preencoded.png">    </p:cNvPr>
-          <p:cNvPicPr>
-            <a:picLocks noChangeAspect="1"/>
-          </p:cNvPicPr>
-          <p:nvPr/>
-        </p:nvPicPr>
-        <p:blipFill>
-          <a:blip r:embed="rId4"/>
-          <a:stretch>
-            <a:fillRect/>
-          </a:stretch>
-        </p:blipFill>
-        <p:spPr>
-          <a:xfrm>
-            <a:off x="6492240" y="4773168"/>
-            <a:ext cx="256032" cy="256032"/>
-          </a:xfrm>
-          <a:prstGeom prst="rect">
-            <a:avLst/>
-          </a:prstGeom>
-        </p:spPr>
-      </p:pic>
-      <p:sp>
-        <p:nvSpPr>
-          <p:cNvPr id="35" name="Text 29"/>
-          <p:cNvSpPr txBox="1"/>
-          <p:nvPr/>
-        </p:nvSpPr>
-        <p:spPr>
-          <a:xfrm>
-            <a:off x="6858000" y="4727448"/>
-            <a:ext cx="4480560" cy="347472"/>
-          </a:xfrm>
-          <a:prstGeom prst="rect">
-            <a:avLst/>
-          </a:prstGeom>
-          <a:noFill/>
-          <a:ln/>
-        </p:spPr>
-        <p:txBody>
-          <a:bodyPr wrap="square" lIns="0" tIns="0" rIns="0" bIns="0" rtlCol="0" anchor="ctr"/>
-          <a:lstStyle/>
-          <a:p>
-            <a:pPr indent="0" marL="0">
-              <a:buNone/>
-            </a:pPr>
-            <a:r>
-              <a:rPr lang="en-US" sz="1300" b="1" dirty="0">
-                <a:solidFill>
-                  <a:schemeClr val="accent6"/>
-                </a:solidFill>
-              </a:rPr>
-              <a:t>9 semanas consecutivas de execução</a:t>
-            </a:r>
-            <a:endParaRPr lang="en-US" sz="1300" dirty="0"/>
-          </a:p>
-        </p:txBody>
-      </p:sp>
-      <p:sp>
-        <p:nvSpPr>
-          <p:cNvPr id="36" name="beneficio-rotinas"/>
+      <p:sp>
+        <p:nvSpPr>
+          <p:cNvPr id="32" name="beneficio-rotinas"/>
           <p:cNvSpPr/>
           <p:nvPr/>
         </p:nvSpPr>
@@ -14835,7 +14652,7 @@
       </p:sp>
       <p:sp>
         <p:nvSpPr>
-          <p:cNvPr id="37" name="Text 31"/>
+          <p:cNvPr id="33" name="Text 29"/>
           <p:cNvSpPr txBox="1"/>
           <p:nvPr/>
         </p:nvSpPr>

</xml_diff>

<commit_message>
Troca 'Por que a DF' por três slides: comparativo de modelos, três respostas e ganhos em 90 dias
Co-Authored-By: Claude Opus 5.5 <noreply@anthropic.com>
Claude-Session: https://claude.ai/code/session_01EsMNgjuF6bLvLuQZ87HmRr
</commit_message>
<xml_diff>
--- a/entregas/apresentacao-13-10/DF_Apresentacao_Einstein_13-10.pptx
+++ b/entregas/apresentacao-13-10/DF_Apresentacao_Einstein_13-10.pptx
@@ -28,9 +28,11 @@
     <p:sldId id="276" r:id="rId22"/>
     <p:sldId id="277" r:id="rId23"/>
     <p:sldId id="278" r:id="rId24"/>
+    <p:sldId id="279" r:id="rId25"/>
+    <p:sldId id="280" r:id="rId26"/>
   </p:sldIdLst>
   <p:notesMasterIdLst>
-    <p:notesMasterId r:id="rId25"/>
+    <p:notesMasterId r:id="rId27"/>
   </p:notesMasterIdLst>
   <p:sldSz cx="12192000" cy="6858000"/>
   <p:notesSz cx="6858000" cy="12192000"/>
@@ -129,19 +131,19 @@
   <p:extLst>
     <p:ext uri="{521415D9-36F7-43E2-AB2F-B90AF26B5E84}">
       <p14:sectionLst xmlns:p14="http://schemas.microsoft.com/office/powerpoint/2010/main">
-        <p14:section name="Abertura" id="{35790ced-f017-4c6a-a533-330e1ff4659f}">
+        <p14:section name="Abertura" id="{312f535a-66a9-ed7b-2ce5-7c486e7353e3}">
           <p14:sldIdLst>
             <p14:sldId id="256"/>
             <p14:sldId id="257"/>
           </p14:sldIdLst>
         </p14:section>
-        <p14:section name="O que entendemos" id="{a5506870-f752-314e-c560-fad4030725a5}">
+        <p14:section name="O que entendemos" id="{f7044d15-94da-7371-b0bb-d992e531699d}">
           <p14:sldIdLst>
             <p14:sldId id="258"/>
             <p14:sldId id="259"/>
           </p14:sldIdLst>
         </p14:section>
-        <p14:section name="Quem é a DF" id="{ff33c136-fea3-89c3-c535-5c8d7fbd856f}">
+        <p14:section name="Quem é a DF" id="{967ef707-b011-67bf-23c5-e9ee32c25ff1}">
           <p14:sldIdLst>
             <p14:sldId id="260"/>
             <p14:sldId id="261"/>
@@ -149,7 +151,7 @@
             <p14:sldId id="263"/>
           </p14:sldIdLst>
         </p14:section>
-        <p14:section name="Como vamos atuar" id="{c4e231ec-b1bc-c551-d386-9e0ecf2a8f0f}">
+        <p14:section name="Como vamos atuar" id="{561ee022-8b98-e7f9-1458-ae6a16cbad09}">
           <p14:sldIdLst>
             <p14:sldId id="264"/>
             <p14:sldId id="265"/>
@@ -157,31 +159,37 @@
             <p14:sldId id="267"/>
           </p14:sldIdLst>
         </p14:section>
-        <p14:section name="O que o Einstein recebe" id="{33ffae1d-2f59-2cad-cb24-b58a4029fff3}">
+        <p14:section name="O que o Einstein recebe" id="{ead0b95e-8355-0041-43e4-b44cbae539b0}">
           <p14:sldIdLst>
             <p14:sldId id="268"/>
             <p14:sldId id="269"/>
             <p14:sldId id="270"/>
           </p14:sldIdLst>
         </p14:section>
-        <p14:section name="Como a DF controla" id="{66b03f3f-c7e6-ca6f-9791-186d56a24c8d}">
+        <p14:section name="Como a DF controla" id="{fb5c1a72-b0ec-c0be-2a11-908962388cb0}">
           <p14:sldIdLst>
             <p14:sldId id="271"/>
             <p14:sldId id="272"/>
             <p14:sldId id="273"/>
           </p14:sldIdLst>
         </p14:section>
-        <p14:section name="Escopo e premissas" id="{8fb0dc75-fc00-491b-4b2b-3bc798a8b31d}">
+        <p14:section name="Escopo e premissas" id="{03b16d79-7360-f065-72eb-24b103b40db5}">
           <p14:sldIdLst>
             <p14:sldId id="274"/>
+          </p14:sldIdLst>
+        </p14:section>
+        <p14:section name="Por que a DF" id="{12862717-9865-20a4-6931-2327d27d7756}">
+          <p14:sldIdLst>
             <p14:sldId id="275"/>
             <p14:sldId id="276"/>
+            <p14:sldId id="277"/>
+            <p14:sldId id="278"/>
           </p14:sldIdLst>
         </p14:section>
-        <p14:section name="Apoio para perguntas" id="{5efe36a8-cf5e-b960-471f-328751e5d79e}">
+        <p14:section name="Apoio para perguntas" id="{3a23210f-34e5-3385-a83f-45f3f3222b9b}">
           <p14:sldIdLst>
-            <p14:sldId id="277"/>
-            <p14:sldId id="278"/>
+            <p14:sldId id="279"/>
+            <p14:sldId id="280"/>
           </p14:sldIdLst>
         </p14:section>
       </p14:sectionLst>
@@ -2532,7 +2540,7 @@
           <a:p>
             <a:r>
               <a:rPr lang="en-US" dirty="0"/>
-              <a:t>DENISE fecha a parte expositiva com os quatro motivos. Pausa e passa para as perguntas.</a:t>
+              <a:t>DENISE: comparar MODELOS, nunca empresas — não citar nenhum concorrente nem administradora. Tom de explicação, não de ataque: 'quem executa não deve fiscalizar a si mesmo'. A RFP diz que o subsíndico deve acompanhar a atuação da administradora e avaliar processos e controles.</a:t>
             </a:r>
             <a:endParaRPr lang="en-US" dirty="0"/>
           </a:p>
@@ -2620,7 +2628,7 @@
           <a:p>
             <a:r>
               <a:rPr lang="en-US" dirty="0"/>
-              <a:t>DENISE encerra e abre para perguntas. Usar os slides de apoio (anexo) conforme as perguntas.</a:t>
+              <a:t>CAIO: fecha o raciocínio aberto no slide 3. Para cada unidade, o desafio, a resposta e um caso real em que a DF já fez isso.</a:t>
             </a:r>
             <a:endParaRPr lang="en-US" dirty="0"/>
           </a:p>
@@ -2708,7 +2716,7 @@
           <a:p>
             <a:r>
               <a:rPr lang="en-US" dirty="0"/>
-              <a:t>Usar se perguntarem como a DF classifica as demandas.</a:t>
+              <a:t>DENISE fecha a exposição com o resultado: o que o Einstein tem em mãos em 90 dias. Pausa e passa para o slide de encerramento e as perguntas.</a:t>
             </a:r>
             <a:endParaRPr lang="en-US" dirty="0"/>
           </a:p>
@@ -2796,7 +2804,7 @@
           <a:p>
             <a:r>
               <a:rPr lang="en-US" dirty="0"/>
-              <a:t>Usar se perguntarem o que a DF precisa para começar.</a:t>
+              <a:t>DENISE encerra e abre para perguntas. Usar os slides de apoio (anexo) conforme as perguntas.</a:t>
             </a:r>
             <a:endParaRPr lang="en-US" dirty="0"/>
           </a:p>
@@ -2820,6 +2828,182 @@
             <a:fld id="{F7021451-1387-4CA6-816F-3879F97B5CBC}" type="slidenum">
               <a:rPr lang="en-US"/>
               <a:t>23</a:t>
+            </a:fld>
+            <a:endParaRPr lang="en-US"/>
+          </a:p>
+        </p:txBody>
+      </p:sp>
+    </p:spTree>
+    <p:extLst>
+      <p:ext uri="{BB962C8B-B14F-4D97-AF65-F5344CB8AC3E}">
+        <p14:creationId xmlns:p14="http://schemas.microsoft.com/office/powerpoint/2010/main" val="1024086991"/>
+      </p:ext>
+    </p:extLst>
+  </p:cSld>
+  <p:clrMapOvr>
+    <a:masterClrMapping/>
+  </p:clrMapOvr>
+</p:notes>
+</file>
+
+<file path=ppt/notesSlides/notesSlide24.xml><?xml version="1.0" encoding="utf-8"?>
+<p:notes xmlns:a="http://schemas.openxmlformats.org/drawingml/2006/main" xmlns:r="http://schemas.openxmlformats.org/officeDocument/2006/relationships" xmlns:p="http://schemas.openxmlformats.org/presentationml/2006/main">
+  <p:cSld>
+    <p:spTree>
+      <p:nvGrpSpPr>
+        <p:cNvPr id="1" name=""/>
+        <p:cNvGrpSpPr/>
+        <p:nvPr/>
+      </p:nvGrpSpPr>
+      <p:grpSpPr>
+        <a:xfrm>
+          <a:off x="0" y="0"/>
+          <a:ext cx="0" cy="0"/>
+          <a:chOff x="0" y="0"/>
+          <a:chExt cx="0" cy="0"/>
+        </a:xfrm>
+      </p:grpSpPr>
+      <p:sp>
+        <p:nvSpPr>
+          <p:cNvPr id="2" name="Slide Image Placeholder 1"/>
+          <p:cNvSpPr>
+            <a:spLocks noGrp="1" noRot="1" noChangeAspect="1"/>
+          </p:cNvSpPr>
+          <p:nvPr>
+            <p:ph type="sldImg"/>
+          </p:nvPr>
+        </p:nvSpPr>
+        <p:spPr/>
+      </p:sp>
+      <p:sp>
+        <p:nvSpPr>
+          <p:cNvPr id="3" name="Notes Placeholder 2"/>
+          <p:cNvSpPr>
+            <a:spLocks noGrp="1"/>
+          </p:cNvSpPr>
+          <p:nvPr>
+            <p:ph type="body" idx="1"/>
+          </p:nvPr>
+        </p:nvSpPr>
+        <p:spPr/>
+        <p:txBody>
+          <a:bodyPr/>
+          <a:lstStyle/>
+          <a:p>
+            <a:r>
+              <a:rPr lang="en-US" dirty="0"/>
+              <a:t>Usar se perguntarem como a DF classifica as demandas.</a:t>
+            </a:r>
+            <a:endParaRPr lang="en-US" dirty="0"/>
+          </a:p>
+        </p:txBody>
+      </p:sp>
+      <p:sp>
+        <p:nvSpPr>
+          <p:cNvPr id="4" name="Slide Number Placeholder 3"/>
+          <p:cNvSpPr>
+            <a:spLocks noGrp="1"/>
+          </p:cNvSpPr>
+          <p:nvPr>
+            <p:ph type="sldNum" sz="quarter" idx="10"/>
+          </p:nvPr>
+        </p:nvSpPr>
+        <p:spPr/>
+        <p:txBody>
+          <a:bodyPr/>
+          <a:lstStyle/>
+          <a:p>
+            <a:fld id="{F7021451-1387-4CA6-816F-3879F97B5CBC}" type="slidenum">
+              <a:rPr lang="en-US"/>
+              <a:t>24</a:t>
+            </a:fld>
+            <a:endParaRPr lang="en-US"/>
+          </a:p>
+        </p:txBody>
+      </p:sp>
+    </p:spTree>
+    <p:extLst>
+      <p:ext uri="{BB962C8B-B14F-4D97-AF65-F5344CB8AC3E}">
+        <p14:creationId xmlns:p14="http://schemas.microsoft.com/office/powerpoint/2010/main" val="1024086991"/>
+      </p:ext>
+    </p:extLst>
+  </p:cSld>
+  <p:clrMapOvr>
+    <a:masterClrMapping/>
+  </p:clrMapOvr>
+</p:notes>
+</file>
+
+<file path=ppt/notesSlides/notesSlide25.xml><?xml version="1.0" encoding="utf-8"?>
+<p:notes xmlns:a="http://schemas.openxmlformats.org/drawingml/2006/main" xmlns:r="http://schemas.openxmlformats.org/officeDocument/2006/relationships" xmlns:p="http://schemas.openxmlformats.org/presentationml/2006/main">
+  <p:cSld>
+    <p:spTree>
+      <p:nvGrpSpPr>
+        <p:cNvPr id="1" name=""/>
+        <p:cNvGrpSpPr/>
+        <p:nvPr/>
+      </p:nvGrpSpPr>
+      <p:grpSpPr>
+        <a:xfrm>
+          <a:off x="0" y="0"/>
+          <a:ext cx="0" cy="0"/>
+          <a:chOff x="0" y="0"/>
+          <a:chExt cx="0" cy="0"/>
+        </a:xfrm>
+      </p:grpSpPr>
+      <p:sp>
+        <p:nvSpPr>
+          <p:cNvPr id="2" name="Slide Image Placeholder 1"/>
+          <p:cNvSpPr>
+            <a:spLocks noGrp="1" noRot="1" noChangeAspect="1"/>
+          </p:cNvSpPr>
+          <p:nvPr>
+            <p:ph type="sldImg"/>
+          </p:nvPr>
+        </p:nvSpPr>
+        <p:spPr/>
+      </p:sp>
+      <p:sp>
+        <p:nvSpPr>
+          <p:cNvPr id="3" name="Notes Placeholder 2"/>
+          <p:cNvSpPr>
+            <a:spLocks noGrp="1"/>
+          </p:cNvSpPr>
+          <p:nvPr>
+            <p:ph type="body" idx="1"/>
+          </p:nvPr>
+        </p:nvSpPr>
+        <p:spPr/>
+        <p:txBody>
+          <a:bodyPr/>
+          <a:lstStyle/>
+          <a:p>
+            <a:r>
+              <a:rPr lang="en-US" dirty="0"/>
+              <a:t>Usar se perguntarem o que a DF precisa para começar.</a:t>
+            </a:r>
+            <a:endParaRPr lang="en-US" dirty="0"/>
+          </a:p>
+        </p:txBody>
+      </p:sp>
+      <p:sp>
+        <p:nvSpPr>
+          <p:cNvPr id="4" name="Slide Number Placeholder 3"/>
+          <p:cNvSpPr>
+            <a:spLocks noGrp="1"/>
+          </p:cNvSpPr>
+          <p:nvPr>
+            <p:ph type="sldNum" sz="quarter" idx="10"/>
+          </p:nvPr>
+        </p:nvSpPr>
+        <p:spPr/>
+        <p:txBody>
+          <a:bodyPr/>
+          <a:lstStyle/>
+          <a:p>
+            <a:fld id="{F7021451-1387-4CA6-816F-3879F97B5CBC}" type="slidenum">
+              <a:rPr lang="en-US"/>
+              <a:t>25</a:t>
             </a:fld>
             <a:endParaRPr lang="en-US"/>
           </a:p>
@@ -17160,7 +17344,7 @@
                   <a:schemeClr val="tx2"/>
                 </a:solidFill>
               </a:rPr>
-              <a:t>Por que a DF</a:t>
+              <a:t>Por que um subsíndico independente</a:t>
             </a:r>
             <a:endParaRPr lang="en-US" sz="3000" dirty="0"/>
           </a:p>
@@ -17168,26 +17352,1112 @@
       </p:sp>
       <p:sp>
         <p:nvSpPr>
-          <p:cNvPr id="3" name="porque-0"/>
+          <p:cNvPr id="3" name="subtitulo"/>
+          <p:cNvSpPr txBox="1"/>
+          <p:nvPr/>
+        </p:nvSpPr>
+        <p:spPr>
+          <a:xfrm>
+            <a:off x="548640" y="1024128"/>
+            <a:ext cx="10515600" cy="365760"/>
+          </a:xfrm>
+          <a:prstGeom prst="rect">
+            <a:avLst/>
+          </a:prstGeom>
+          <a:noFill/>
+          <a:ln/>
+        </p:spPr>
+        <p:txBody>
+          <a:bodyPr wrap="square" lIns="0" tIns="0" rIns="0" bIns="0" rtlCol="0" anchor="ctr"/>
+          <a:lstStyle/>
+          <a:p>
+            <a:pPr indent="0" marL="0">
+              <a:buNone/>
+            </a:pPr>
+            <a:r>
+              <a:rPr lang="en-US" sz="1500" dirty="0">
+                <a:solidFill>
+                  <a:schemeClr val="accent3"/>
+                </a:solidFill>
+              </a:rPr>
+              <a:t>A diferença entre ter quem fiscalize a operação e deixar a operação se fiscalizar</a:t>
+            </a:r>
+            <a:endParaRPr lang="en-US" sz="1500" dirty="0"/>
+          </a:p>
+        </p:txBody>
+      </p:sp>
+      <p:graphicFrame>
+        <p:nvGraphicFramePr>
+          <p:cNvPr id="21" name="tabela-comparativo"/>
+          <p:cNvGraphicFramePr>
+            <a:graphicFrameLocks noGrp="1"/>
+          </p:cNvGraphicFramePr>
+          <p:nvPr>
+            <p:extLst>
+              <p:ext uri="{D42A27DB-BD31-4B8C-83A1-F6EECF244321}">
+                <p14:modId xmlns:p14="http://schemas.microsoft.com/office/powerpoint/2010/main" val="1579011935"/>
+              </p:ext>
+            </p:extLst>
+          </p:nvPr>
+        </p:nvGraphicFramePr>
+        <p:xfrm>
+          <a:off x="548640" y="1600200"/>
+          <a:ext cx="11109960" cy="914400"/>
+        </p:xfrm>
+        <a:graphic>
+          <a:graphicData uri="http://schemas.openxmlformats.org/drawingml/2006/table">
+            <a:tbl>
+              <a:tblPr/>
+              <a:tblGrid>
+                <a:gridCol w="3246120"/>
+                <a:gridCol w="3931920"/>
+                <a:gridCol w="3931920"/>
+              </a:tblGrid>
+              <a:tr h="594360">
+                <a:tc>
+                  <a:txBody>
+                    <a:bodyPr/>
+                    <a:lstStyle/>
+                    <a:p>
+                      <a:pPr algn="ctr" indent="0" marL="0">
+                        <a:buNone/>
+                      </a:pPr>
+                      <a:endParaRPr lang="en-US" sz="1500" dirty="0">
+                        <a:latin typeface="Calibri" charset="0"/>
+                        <a:ea typeface="Calibri" charset="0"/>
+                        <a:cs typeface="Calibri" charset="0"/>
+                      </a:endParaRPr>
+                    </a:p>
+                  </a:txBody>
+                  <a:tcPr marL="109728" marR="109728" marT="109728" marB="109728" anchor="ctr">
+                    <a:lnL w="9525" cap="flat" cmpd="sng" algn="ctr">
+                      <a:solidFill>
+                        <a:srgbClr val="E5E7EB"/>
+                      </a:solidFill>
+                      <a:prstDash val="solid"/>
+                      <a:round/>
+                      <a:headEnd type="none" w="med" len="med"/>
+                      <a:tailEnd type="none" w="med" len="med"/>
+                    </a:lnL>
+                    <a:lnR w="9525" cap="flat" cmpd="sng" algn="ctr">
+                      <a:solidFill>
+                        <a:srgbClr val="E5E7EB"/>
+                      </a:solidFill>
+                      <a:prstDash val="solid"/>
+                      <a:round/>
+                      <a:headEnd type="none" w="med" len="med"/>
+                      <a:tailEnd type="none" w="med" len="med"/>
+                    </a:lnR>
+                    <a:lnT w="9525" cap="flat" cmpd="sng" algn="ctr">
+                      <a:solidFill>
+                        <a:srgbClr val="E5E7EB"/>
+                      </a:solidFill>
+                      <a:prstDash val="solid"/>
+                      <a:round/>
+                      <a:headEnd type="none" w="med" len="med"/>
+                      <a:tailEnd type="none" w="med" len="med"/>
+                    </a:lnT>
+                    <a:lnB w="9525" cap="flat" cmpd="sng" algn="ctr">
+                      <a:solidFill>
+                        <a:srgbClr val="E5E7EB"/>
+                      </a:solidFill>
+                      <a:prstDash val="solid"/>
+                      <a:round/>
+                      <a:headEnd type="none" w="med" len="med"/>
+                      <a:tailEnd type="none" w="med" len="med"/>
+                    </a:lnB>
+                    <a:solidFill>
+                      <a:srgbClr val="FFFFFF"/>
+                    </a:solidFill>
+                  </a:tcPr>
+                </a:tc>
+                <a:tc>
+                  <a:txBody>
+                    <a:bodyPr/>
+                    <a:lstStyle/>
+                    <a:p>
+                      <a:pPr algn="ctr" indent="0" marL="0">
+                        <a:buNone/>
+                      </a:pPr>
+                      <a:r>
+                        <a:rPr lang="en-US" sz="1500" b="1" dirty="0">
+                          <a:solidFill>
+                            <a:srgbClr val="FFFFFF"/>
+                          </a:solidFill>
+                          <a:latin typeface="Calibri" pitchFamily="34" charset="0"/>
+                          <a:ea typeface="Calibri" pitchFamily="34" charset="-122"/>
+                          <a:cs typeface="Calibri" pitchFamily="34" charset="-120"/>
+                        </a:rPr>
+                        <a:t>Subsíndico independente (DF)</a:t>
+                      </a:r>
+                      <a:endParaRPr lang="en-US" sz="1500" dirty="0">
+                        <a:latin typeface="Calibri" charset="0"/>
+                        <a:ea typeface="Calibri" charset="0"/>
+                        <a:cs typeface="Calibri" charset="0"/>
+                      </a:endParaRPr>
+                    </a:p>
+                  </a:txBody>
+                  <a:tcPr marL="109728" marR="109728" marT="109728" marB="109728" anchor="ctr">
+                    <a:lnL w="9525" cap="flat" cmpd="sng" algn="ctr">
+                      <a:solidFill>
+                        <a:srgbClr val="E5E7EB"/>
+                      </a:solidFill>
+                      <a:prstDash val="solid"/>
+                      <a:round/>
+                      <a:headEnd type="none" w="med" len="med"/>
+                      <a:tailEnd type="none" w="med" len="med"/>
+                    </a:lnL>
+                    <a:lnR w="9525" cap="flat" cmpd="sng" algn="ctr">
+                      <a:solidFill>
+                        <a:srgbClr val="E5E7EB"/>
+                      </a:solidFill>
+                      <a:prstDash val="solid"/>
+                      <a:round/>
+                      <a:headEnd type="none" w="med" len="med"/>
+                      <a:tailEnd type="none" w="med" len="med"/>
+                    </a:lnR>
+                    <a:lnT w="9525" cap="flat" cmpd="sng" algn="ctr">
+                      <a:solidFill>
+                        <a:srgbClr val="E5E7EB"/>
+                      </a:solidFill>
+                      <a:prstDash val="solid"/>
+                      <a:round/>
+                      <a:headEnd type="none" w="med" len="med"/>
+                      <a:tailEnd type="none" w="med" len="med"/>
+                    </a:lnT>
+                    <a:lnB w="9525" cap="flat" cmpd="sng" algn="ctr">
+                      <a:solidFill>
+                        <a:srgbClr val="E5E7EB"/>
+                      </a:solidFill>
+                      <a:prstDash val="solid"/>
+                      <a:round/>
+                      <a:headEnd type="none" w="med" len="med"/>
+                      <a:tailEnd type="none" w="med" len="med"/>
+                    </a:lnB>
+                    <a:solidFill>
+                      <a:srgbClr val="2F4162"/>
+                    </a:solidFill>
+                  </a:tcPr>
+                </a:tc>
+                <a:tc>
+                  <a:txBody>
+                    <a:bodyPr/>
+                    <a:lstStyle/>
+                    <a:p>
+                      <a:pPr algn="ctr" indent="0" marL="0">
+                        <a:buNone/>
+                      </a:pPr>
+                      <a:r>
+                        <a:rPr lang="en-US" sz="1500" b="1" dirty="0">
+                          <a:solidFill>
+                            <a:srgbClr val="1F2A37"/>
+                          </a:solidFill>
+                          <a:latin typeface="Calibri" pitchFamily="34" charset="0"/>
+                          <a:ea typeface="Calibri" pitchFamily="34" charset="-122"/>
+                          <a:cs typeface="Calibri" pitchFamily="34" charset="-120"/>
+                        </a:rPr>
+                        <a:t>Administradora acumulando a função</a:t>
+                      </a:r>
+                      <a:endParaRPr lang="en-US" sz="1500" dirty="0">
+                        <a:latin typeface="Calibri" charset="0"/>
+                        <a:ea typeface="Calibri" charset="0"/>
+                        <a:cs typeface="Calibri" charset="0"/>
+                      </a:endParaRPr>
+                    </a:p>
+                  </a:txBody>
+                  <a:tcPr marL="109728" marR="109728" marT="109728" marB="109728" anchor="ctr">
+                    <a:lnL w="9525" cap="flat" cmpd="sng" algn="ctr">
+                      <a:solidFill>
+                        <a:srgbClr val="E5E7EB"/>
+                      </a:solidFill>
+                      <a:prstDash val="solid"/>
+                      <a:round/>
+                      <a:headEnd type="none" w="med" len="med"/>
+                      <a:tailEnd type="none" w="med" len="med"/>
+                    </a:lnL>
+                    <a:lnR w="9525" cap="flat" cmpd="sng" algn="ctr">
+                      <a:solidFill>
+                        <a:srgbClr val="E5E7EB"/>
+                      </a:solidFill>
+                      <a:prstDash val="solid"/>
+                      <a:round/>
+                      <a:headEnd type="none" w="med" len="med"/>
+                      <a:tailEnd type="none" w="med" len="med"/>
+                    </a:lnR>
+                    <a:lnT w="9525" cap="flat" cmpd="sng" algn="ctr">
+                      <a:solidFill>
+                        <a:srgbClr val="E5E7EB"/>
+                      </a:solidFill>
+                      <a:prstDash val="solid"/>
+                      <a:round/>
+                      <a:headEnd type="none" w="med" len="med"/>
+                      <a:tailEnd type="none" w="med" len="med"/>
+                    </a:lnT>
+                    <a:lnB w="9525" cap="flat" cmpd="sng" algn="ctr">
+                      <a:solidFill>
+                        <a:srgbClr val="E5E7EB"/>
+                      </a:solidFill>
+                      <a:prstDash val="solid"/>
+                      <a:round/>
+                      <a:headEnd type="none" w="med" len="med"/>
+                      <a:tailEnd type="none" w="med" len="med"/>
+                    </a:lnB>
+                    <a:solidFill>
+                      <a:srgbClr val="E5E7EB"/>
+                    </a:solidFill>
+                  </a:tcPr>
+                </a:tc>
+              </a:tr>
+              <a:tr h="777240">
+                <a:tc>
+                  <a:txBody>
+                    <a:bodyPr/>
+                    <a:lstStyle/>
+                    <a:p>
+                      <a:pPr indent="0" marL="0">
+                        <a:buNone/>
+                      </a:pPr>
+                      <a:r>
+                        <a:rPr lang="en-US" sz="1500" b="1" dirty="0">
+                          <a:solidFill>
+                            <a:srgbClr val="2F4162"/>
+                          </a:solidFill>
+                          <a:latin typeface="Calibri" pitchFamily="34" charset="0"/>
+                          <a:ea typeface="Calibri" pitchFamily="34" charset="-122"/>
+                          <a:cs typeface="Calibri" pitchFamily="34" charset="-120"/>
+                        </a:rPr>
+                        <a:t>Quem fiscaliza a administradora</a:t>
+                      </a:r>
+                      <a:endParaRPr lang="en-US" sz="1500" dirty="0">
+                        <a:latin typeface="Calibri" charset="0"/>
+                        <a:ea typeface="Calibri" charset="0"/>
+                        <a:cs typeface="Calibri" charset="0"/>
+                      </a:endParaRPr>
+                    </a:p>
+                  </a:txBody>
+                  <a:tcPr marL="109728" marR="109728" marT="109728" marB="109728" anchor="ctr">
+                    <a:lnL w="9525" cap="flat" cmpd="sng" algn="ctr">
+                      <a:solidFill>
+                        <a:srgbClr val="E5E7EB"/>
+                      </a:solidFill>
+                      <a:prstDash val="solid"/>
+                      <a:round/>
+                      <a:headEnd type="none" w="med" len="med"/>
+                      <a:tailEnd type="none" w="med" len="med"/>
+                    </a:lnL>
+                    <a:lnR w="9525" cap="flat" cmpd="sng" algn="ctr">
+                      <a:solidFill>
+                        <a:srgbClr val="E5E7EB"/>
+                      </a:solidFill>
+                      <a:prstDash val="solid"/>
+                      <a:round/>
+                      <a:headEnd type="none" w="med" len="med"/>
+                      <a:tailEnd type="none" w="med" len="med"/>
+                    </a:lnR>
+                    <a:lnT w="9525" cap="flat" cmpd="sng" algn="ctr">
+                      <a:solidFill>
+                        <a:srgbClr val="E5E7EB"/>
+                      </a:solidFill>
+                      <a:prstDash val="solid"/>
+                      <a:round/>
+                      <a:headEnd type="none" w="med" len="med"/>
+                      <a:tailEnd type="none" w="med" len="med"/>
+                    </a:lnT>
+                    <a:lnB w="9525" cap="flat" cmpd="sng" algn="ctr">
+                      <a:solidFill>
+                        <a:srgbClr val="E5E7EB"/>
+                      </a:solidFill>
+                      <a:prstDash val="solid"/>
+                      <a:round/>
+                      <a:headEnd type="none" w="med" len="med"/>
+                      <a:tailEnd type="none" w="med" len="med"/>
+                    </a:lnB>
+                    <a:solidFill>
+                      <a:srgbClr val="FFFFFF"/>
+                    </a:solidFill>
+                  </a:tcPr>
+                </a:tc>
+                <a:tc>
+                  <a:txBody>
+                    <a:bodyPr/>
+                    <a:lstStyle/>
+                    <a:p>
+                      <a:pPr indent="0" marL="0">
+                        <a:buNone/>
+                      </a:pPr>
+                      <a:r>
+                        <a:rPr lang="en-US" sz="1500" b="1" dirty="0">
+                          <a:solidFill>
+                            <a:srgbClr val="1F2A37"/>
+                          </a:solidFill>
+                          <a:latin typeface="Calibri" pitchFamily="34" charset="0"/>
+                          <a:ea typeface="Calibri" pitchFamily="34" charset="-122"/>
+                          <a:cs typeface="Calibri" pitchFamily="34" charset="-120"/>
+                        </a:rPr>
+                        <a:t>A DF, em nome do Einstein</a:t>
+                      </a:r>
+                      <a:endParaRPr lang="en-US" sz="1500" dirty="0">
+                        <a:latin typeface="Calibri" charset="0"/>
+                        <a:ea typeface="Calibri" charset="0"/>
+                        <a:cs typeface="Calibri" charset="0"/>
+                      </a:endParaRPr>
+                    </a:p>
+                  </a:txBody>
+                  <a:tcPr marL="109728" marR="109728" marT="109728" marB="109728" anchor="ctr">
+                    <a:lnL w="9525" cap="flat" cmpd="sng" algn="ctr">
+                      <a:solidFill>
+                        <a:srgbClr val="E5E7EB"/>
+                      </a:solidFill>
+                      <a:prstDash val="solid"/>
+                      <a:round/>
+                      <a:headEnd type="none" w="med" len="med"/>
+                      <a:tailEnd type="none" w="med" len="med"/>
+                    </a:lnL>
+                    <a:lnR w="9525" cap="flat" cmpd="sng" algn="ctr">
+                      <a:solidFill>
+                        <a:srgbClr val="E5E7EB"/>
+                      </a:solidFill>
+                      <a:prstDash val="solid"/>
+                      <a:round/>
+                      <a:headEnd type="none" w="med" len="med"/>
+                      <a:tailEnd type="none" w="med" len="med"/>
+                    </a:lnR>
+                    <a:lnT w="9525" cap="flat" cmpd="sng" algn="ctr">
+                      <a:solidFill>
+                        <a:srgbClr val="E5E7EB"/>
+                      </a:solidFill>
+                      <a:prstDash val="solid"/>
+                      <a:round/>
+                      <a:headEnd type="none" w="med" len="med"/>
+                      <a:tailEnd type="none" w="med" len="med"/>
+                    </a:lnT>
+                    <a:lnB w="9525" cap="flat" cmpd="sng" algn="ctr">
+                      <a:solidFill>
+                        <a:srgbClr val="E5E7EB"/>
+                      </a:solidFill>
+                      <a:prstDash val="solid"/>
+                      <a:round/>
+                      <a:headEnd type="none" w="med" len="med"/>
+                      <a:tailEnd type="none" w="med" len="med"/>
+                    </a:lnB>
+                    <a:solidFill>
+                      <a:srgbClr val="EEF1F6"/>
+                    </a:solidFill>
+                  </a:tcPr>
+                </a:tc>
+                <a:tc>
+                  <a:txBody>
+                    <a:bodyPr/>
+                    <a:lstStyle/>
+                    <a:p>
+                      <a:pPr indent="0" marL="0">
+                        <a:buNone/>
+                      </a:pPr>
+                      <a:r>
+                        <a:rPr lang="en-US" sz="1500" dirty="0">
+                          <a:solidFill>
+                            <a:srgbClr val="5B6470"/>
+                          </a:solidFill>
+                          <a:latin typeface="Calibri" pitchFamily="34" charset="0"/>
+                          <a:ea typeface="Calibri" pitchFamily="34" charset="-122"/>
+                          <a:cs typeface="Calibri" pitchFamily="34" charset="-120"/>
+                        </a:rPr>
+                        <a:t>Fica sem fiscalização independente</a:t>
+                      </a:r>
+                      <a:endParaRPr lang="en-US" sz="1500" dirty="0">
+                        <a:latin typeface="Calibri" charset="0"/>
+                        <a:ea typeface="Calibri" charset="0"/>
+                        <a:cs typeface="Calibri" charset="0"/>
+                      </a:endParaRPr>
+                    </a:p>
+                  </a:txBody>
+                  <a:tcPr marL="109728" marR="109728" marT="109728" marB="109728" anchor="ctr">
+                    <a:lnL w="9525" cap="flat" cmpd="sng" algn="ctr">
+                      <a:solidFill>
+                        <a:srgbClr val="E5E7EB"/>
+                      </a:solidFill>
+                      <a:prstDash val="solid"/>
+                      <a:round/>
+                      <a:headEnd type="none" w="med" len="med"/>
+                      <a:tailEnd type="none" w="med" len="med"/>
+                    </a:lnL>
+                    <a:lnR w="9525" cap="flat" cmpd="sng" algn="ctr">
+                      <a:solidFill>
+                        <a:srgbClr val="E5E7EB"/>
+                      </a:solidFill>
+                      <a:prstDash val="solid"/>
+                      <a:round/>
+                      <a:headEnd type="none" w="med" len="med"/>
+                      <a:tailEnd type="none" w="med" len="med"/>
+                    </a:lnR>
+                    <a:lnT w="9525" cap="flat" cmpd="sng" algn="ctr">
+                      <a:solidFill>
+                        <a:srgbClr val="E5E7EB"/>
+                      </a:solidFill>
+                      <a:prstDash val="solid"/>
+                      <a:round/>
+                      <a:headEnd type="none" w="med" len="med"/>
+                      <a:tailEnd type="none" w="med" len="med"/>
+                    </a:lnT>
+                    <a:lnB w="9525" cap="flat" cmpd="sng" algn="ctr">
+                      <a:solidFill>
+                        <a:srgbClr val="E5E7EB"/>
+                      </a:solidFill>
+                      <a:prstDash val="solid"/>
+                      <a:round/>
+                      <a:headEnd type="none" w="med" len="med"/>
+                      <a:tailEnd type="none" w="med" len="med"/>
+                    </a:lnB>
+                    <a:solidFill>
+                      <a:srgbClr val="FFFFFF"/>
+                    </a:solidFill>
+                  </a:tcPr>
+                </a:tc>
+              </a:tr>
+              <a:tr h="777240">
+                <a:tc>
+                  <a:txBody>
+                    <a:bodyPr/>
+                    <a:lstStyle/>
+                    <a:p>
+                      <a:pPr indent="0" marL="0">
+                        <a:buNone/>
+                      </a:pPr>
+                      <a:r>
+                        <a:rPr lang="en-US" sz="1500" b="1" dirty="0">
+                          <a:solidFill>
+                            <a:srgbClr val="2F4162"/>
+                          </a:solidFill>
+                          <a:latin typeface="Calibri" pitchFamily="34" charset="0"/>
+                          <a:ea typeface="Calibri" pitchFamily="34" charset="-122"/>
+                          <a:cs typeface="Calibri" pitchFamily="34" charset="-120"/>
+                        </a:rPr>
+                        <a:t>Conflito de interesse</a:t>
+                      </a:r>
+                      <a:endParaRPr lang="en-US" sz="1500" dirty="0">
+                        <a:latin typeface="Calibri" charset="0"/>
+                        <a:ea typeface="Calibri" charset="0"/>
+                        <a:cs typeface="Calibri" charset="0"/>
+                      </a:endParaRPr>
+                    </a:p>
+                  </a:txBody>
+                  <a:tcPr marL="109728" marR="109728" marT="109728" marB="109728" anchor="ctr">
+                    <a:lnL w="9525" cap="flat" cmpd="sng" algn="ctr">
+                      <a:solidFill>
+                        <a:srgbClr val="E5E7EB"/>
+                      </a:solidFill>
+                      <a:prstDash val="solid"/>
+                      <a:round/>
+                      <a:headEnd type="none" w="med" len="med"/>
+                      <a:tailEnd type="none" w="med" len="med"/>
+                    </a:lnL>
+                    <a:lnR w="9525" cap="flat" cmpd="sng" algn="ctr">
+                      <a:solidFill>
+                        <a:srgbClr val="E5E7EB"/>
+                      </a:solidFill>
+                      <a:prstDash val="solid"/>
+                      <a:round/>
+                      <a:headEnd type="none" w="med" len="med"/>
+                      <a:tailEnd type="none" w="med" len="med"/>
+                    </a:lnR>
+                    <a:lnT w="9525" cap="flat" cmpd="sng" algn="ctr">
+                      <a:solidFill>
+                        <a:srgbClr val="E5E7EB"/>
+                      </a:solidFill>
+                      <a:prstDash val="solid"/>
+                      <a:round/>
+                      <a:headEnd type="none" w="med" len="med"/>
+                      <a:tailEnd type="none" w="med" len="med"/>
+                    </a:lnT>
+                    <a:lnB w="9525" cap="flat" cmpd="sng" algn="ctr">
+                      <a:solidFill>
+                        <a:srgbClr val="E5E7EB"/>
+                      </a:solidFill>
+                      <a:prstDash val="solid"/>
+                      <a:round/>
+                      <a:headEnd type="none" w="med" len="med"/>
+                      <a:tailEnd type="none" w="med" len="med"/>
+                    </a:lnB>
+                    <a:solidFill>
+                      <a:srgbClr val="F6F7F9"/>
+                    </a:solidFill>
+                  </a:tcPr>
+                </a:tc>
+                <a:tc>
+                  <a:txBody>
+                    <a:bodyPr/>
+                    <a:lstStyle/>
+                    <a:p>
+                      <a:pPr indent="0" marL="0">
+                        <a:buNone/>
+                      </a:pPr>
+                      <a:r>
+                        <a:rPr lang="en-US" sz="1500" b="1" dirty="0">
+                          <a:solidFill>
+                            <a:srgbClr val="1F2A37"/>
+                          </a:solidFill>
+                          <a:latin typeface="Calibri" pitchFamily="34" charset="0"/>
+                          <a:ea typeface="Calibri" pitchFamily="34" charset="-122"/>
+                          <a:cs typeface="Calibri" pitchFamily="34" charset="-120"/>
+                        </a:rPr>
+                        <a:t>Nenhum — declarado por escrito</a:t>
+                      </a:r>
+                      <a:endParaRPr lang="en-US" sz="1500" dirty="0">
+                        <a:latin typeface="Calibri" charset="0"/>
+                        <a:ea typeface="Calibri" charset="0"/>
+                        <a:cs typeface="Calibri" charset="0"/>
+                      </a:endParaRPr>
+                    </a:p>
+                  </a:txBody>
+                  <a:tcPr marL="109728" marR="109728" marT="109728" marB="109728" anchor="ctr">
+                    <a:lnL w="9525" cap="flat" cmpd="sng" algn="ctr">
+                      <a:solidFill>
+                        <a:srgbClr val="E5E7EB"/>
+                      </a:solidFill>
+                      <a:prstDash val="solid"/>
+                      <a:round/>
+                      <a:headEnd type="none" w="med" len="med"/>
+                      <a:tailEnd type="none" w="med" len="med"/>
+                    </a:lnL>
+                    <a:lnR w="9525" cap="flat" cmpd="sng" algn="ctr">
+                      <a:solidFill>
+                        <a:srgbClr val="E5E7EB"/>
+                      </a:solidFill>
+                      <a:prstDash val="solid"/>
+                      <a:round/>
+                      <a:headEnd type="none" w="med" len="med"/>
+                      <a:tailEnd type="none" w="med" len="med"/>
+                    </a:lnR>
+                    <a:lnT w="9525" cap="flat" cmpd="sng" algn="ctr">
+                      <a:solidFill>
+                        <a:srgbClr val="E5E7EB"/>
+                      </a:solidFill>
+                      <a:prstDash val="solid"/>
+                      <a:round/>
+                      <a:headEnd type="none" w="med" len="med"/>
+                      <a:tailEnd type="none" w="med" len="med"/>
+                    </a:lnT>
+                    <a:lnB w="9525" cap="flat" cmpd="sng" algn="ctr">
+                      <a:solidFill>
+                        <a:srgbClr val="E5E7EB"/>
+                      </a:solidFill>
+                      <a:prstDash val="solid"/>
+                      <a:round/>
+                      <a:headEnd type="none" w="med" len="med"/>
+                      <a:tailEnd type="none" w="med" len="med"/>
+                    </a:lnB>
+                    <a:solidFill>
+                      <a:srgbClr val="EEF1F6"/>
+                    </a:solidFill>
+                  </a:tcPr>
+                </a:tc>
+                <a:tc>
+                  <a:txBody>
+                    <a:bodyPr/>
+                    <a:lstStyle/>
+                    <a:p>
+                      <a:pPr indent="0" marL="0">
+                        <a:buNone/>
+                      </a:pPr>
+                      <a:r>
+                        <a:rPr lang="en-US" sz="1500" dirty="0">
+                          <a:solidFill>
+                            <a:srgbClr val="5B6470"/>
+                          </a:solidFill>
+                          <a:latin typeface="Calibri" pitchFamily="34" charset="0"/>
+                          <a:ea typeface="Calibri" pitchFamily="34" charset="-122"/>
+                          <a:cs typeface="Calibri" pitchFamily="34" charset="-120"/>
+                        </a:rPr>
+                        <a:t>A mesma empresa executa e avalia o próprio trabalho</a:t>
+                      </a:r>
+                      <a:endParaRPr lang="en-US" sz="1500" dirty="0">
+                        <a:latin typeface="Calibri" charset="0"/>
+                        <a:ea typeface="Calibri" charset="0"/>
+                        <a:cs typeface="Calibri" charset="0"/>
+                      </a:endParaRPr>
+                    </a:p>
+                  </a:txBody>
+                  <a:tcPr marL="109728" marR="109728" marT="109728" marB="109728" anchor="ctr">
+                    <a:lnL w="9525" cap="flat" cmpd="sng" algn="ctr">
+                      <a:solidFill>
+                        <a:srgbClr val="E5E7EB"/>
+                      </a:solidFill>
+                      <a:prstDash val="solid"/>
+                      <a:round/>
+                      <a:headEnd type="none" w="med" len="med"/>
+                      <a:tailEnd type="none" w="med" len="med"/>
+                    </a:lnL>
+                    <a:lnR w="9525" cap="flat" cmpd="sng" algn="ctr">
+                      <a:solidFill>
+                        <a:srgbClr val="E5E7EB"/>
+                      </a:solidFill>
+                      <a:prstDash val="solid"/>
+                      <a:round/>
+                      <a:headEnd type="none" w="med" len="med"/>
+                      <a:tailEnd type="none" w="med" len="med"/>
+                    </a:lnR>
+                    <a:lnT w="9525" cap="flat" cmpd="sng" algn="ctr">
+                      <a:solidFill>
+                        <a:srgbClr val="E5E7EB"/>
+                      </a:solidFill>
+                      <a:prstDash val="solid"/>
+                      <a:round/>
+                      <a:headEnd type="none" w="med" len="med"/>
+                      <a:tailEnd type="none" w="med" len="med"/>
+                    </a:lnT>
+                    <a:lnB w="9525" cap="flat" cmpd="sng" algn="ctr">
+                      <a:solidFill>
+                        <a:srgbClr val="E5E7EB"/>
+                      </a:solidFill>
+                      <a:prstDash val="solid"/>
+                      <a:round/>
+                      <a:headEnd type="none" w="med" len="med"/>
+                      <a:tailEnd type="none" w="med" len="med"/>
+                    </a:lnB>
+                    <a:solidFill>
+                      <a:srgbClr val="F6F7F9"/>
+                    </a:solidFill>
+                  </a:tcPr>
+                </a:tc>
+              </a:tr>
+              <a:tr h="777240">
+                <a:tc>
+                  <a:txBody>
+                    <a:bodyPr/>
+                    <a:lstStyle/>
+                    <a:p>
+                      <a:pPr indent="0" marL="0">
+                        <a:buNone/>
+                      </a:pPr>
+                      <a:r>
+                        <a:rPr lang="en-US" sz="1500" b="1" dirty="0">
+                          <a:solidFill>
+                            <a:srgbClr val="2F4162"/>
+                          </a:solidFill>
+                          <a:latin typeface="Calibri" pitchFamily="34" charset="0"/>
+                          <a:ea typeface="Calibri" pitchFamily="34" charset="-122"/>
+                          <a:cs typeface="Calibri" pitchFamily="34" charset="-120"/>
+                        </a:rPr>
+                        <a:t>A quem a análise de rateio e contratos serve</a:t>
+                      </a:r>
+                      <a:endParaRPr lang="en-US" sz="1500" dirty="0">
+                        <a:latin typeface="Calibri" charset="0"/>
+                        <a:ea typeface="Calibri" charset="0"/>
+                        <a:cs typeface="Calibri" charset="0"/>
+                      </a:endParaRPr>
+                    </a:p>
+                  </a:txBody>
+                  <a:tcPr marL="109728" marR="109728" marT="109728" marB="109728" anchor="ctr">
+                    <a:lnL w="9525" cap="flat" cmpd="sng" algn="ctr">
+                      <a:solidFill>
+                        <a:srgbClr val="E5E7EB"/>
+                      </a:solidFill>
+                      <a:prstDash val="solid"/>
+                      <a:round/>
+                      <a:headEnd type="none" w="med" len="med"/>
+                      <a:tailEnd type="none" w="med" len="med"/>
+                    </a:lnL>
+                    <a:lnR w="9525" cap="flat" cmpd="sng" algn="ctr">
+                      <a:solidFill>
+                        <a:srgbClr val="E5E7EB"/>
+                      </a:solidFill>
+                      <a:prstDash val="solid"/>
+                      <a:round/>
+                      <a:headEnd type="none" w="med" len="med"/>
+                      <a:tailEnd type="none" w="med" len="med"/>
+                    </a:lnR>
+                    <a:lnT w="9525" cap="flat" cmpd="sng" algn="ctr">
+                      <a:solidFill>
+                        <a:srgbClr val="E5E7EB"/>
+                      </a:solidFill>
+                      <a:prstDash val="solid"/>
+                      <a:round/>
+                      <a:headEnd type="none" w="med" len="med"/>
+                      <a:tailEnd type="none" w="med" len="med"/>
+                    </a:lnT>
+                    <a:lnB w="9525" cap="flat" cmpd="sng" algn="ctr">
+                      <a:solidFill>
+                        <a:srgbClr val="E5E7EB"/>
+                      </a:solidFill>
+                      <a:prstDash val="solid"/>
+                      <a:round/>
+                      <a:headEnd type="none" w="med" len="med"/>
+                      <a:tailEnd type="none" w="med" len="med"/>
+                    </a:lnB>
+                    <a:solidFill>
+                      <a:srgbClr val="FFFFFF"/>
+                    </a:solidFill>
+                  </a:tcPr>
+                </a:tc>
+                <a:tc>
+                  <a:txBody>
+                    <a:bodyPr/>
+                    <a:lstStyle/>
+                    <a:p>
+                      <a:pPr indent="0" marL="0">
+                        <a:buNone/>
+                      </a:pPr>
+                      <a:r>
+                        <a:rPr lang="en-US" sz="1500" b="1" dirty="0">
+                          <a:solidFill>
+                            <a:srgbClr val="1F2A37"/>
+                          </a:solidFill>
+                          <a:latin typeface="Calibri" pitchFamily="34" charset="0"/>
+                          <a:ea typeface="Calibri" pitchFamily="34" charset="-122"/>
+                          <a:cs typeface="Calibri" pitchFamily="34" charset="-120"/>
+                        </a:rPr>
+                        <a:t>Exclusivamente ao Einstein</a:t>
+                      </a:r>
+                      <a:endParaRPr lang="en-US" sz="1500" dirty="0">
+                        <a:latin typeface="Calibri" charset="0"/>
+                        <a:ea typeface="Calibri" charset="0"/>
+                        <a:cs typeface="Calibri" charset="0"/>
+                      </a:endParaRPr>
+                    </a:p>
+                  </a:txBody>
+                  <a:tcPr marL="109728" marR="109728" marT="109728" marB="109728" anchor="ctr">
+                    <a:lnL w="9525" cap="flat" cmpd="sng" algn="ctr">
+                      <a:solidFill>
+                        <a:srgbClr val="E5E7EB"/>
+                      </a:solidFill>
+                      <a:prstDash val="solid"/>
+                      <a:round/>
+                      <a:headEnd type="none" w="med" len="med"/>
+                      <a:tailEnd type="none" w="med" len="med"/>
+                    </a:lnL>
+                    <a:lnR w="9525" cap="flat" cmpd="sng" algn="ctr">
+                      <a:solidFill>
+                        <a:srgbClr val="E5E7EB"/>
+                      </a:solidFill>
+                      <a:prstDash val="solid"/>
+                      <a:round/>
+                      <a:headEnd type="none" w="med" len="med"/>
+                      <a:tailEnd type="none" w="med" len="med"/>
+                    </a:lnR>
+                    <a:lnT w="9525" cap="flat" cmpd="sng" algn="ctr">
+                      <a:solidFill>
+                        <a:srgbClr val="E5E7EB"/>
+                      </a:solidFill>
+                      <a:prstDash val="solid"/>
+                      <a:round/>
+                      <a:headEnd type="none" w="med" len="med"/>
+                      <a:tailEnd type="none" w="med" len="med"/>
+                    </a:lnT>
+                    <a:lnB w="9525" cap="flat" cmpd="sng" algn="ctr">
+                      <a:solidFill>
+                        <a:srgbClr val="E5E7EB"/>
+                      </a:solidFill>
+                      <a:prstDash val="solid"/>
+                      <a:round/>
+                      <a:headEnd type="none" w="med" len="med"/>
+                      <a:tailEnd type="none" w="med" len="med"/>
+                    </a:lnB>
+                    <a:solidFill>
+                      <a:srgbClr val="EEF1F6"/>
+                    </a:solidFill>
+                  </a:tcPr>
+                </a:tc>
+                <a:tc>
+                  <a:txBody>
+                    <a:bodyPr/>
+                    <a:lstStyle/>
+                    <a:p>
+                      <a:pPr indent="0" marL="0">
+                        <a:buNone/>
+                      </a:pPr>
+                      <a:r>
+                        <a:rPr lang="en-US" sz="1500" dirty="0">
+                          <a:solidFill>
+                            <a:srgbClr val="5B6470"/>
+                          </a:solidFill>
+                          <a:latin typeface="Calibri" pitchFamily="34" charset="0"/>
+                          <a:ea typeface="Calibri" pitchFamily="34" charset="-122"/>
+                          <a:cs typeface="Calibri" pitchFamily="34" charset="-120"/>
+                        </a:rPr>
+                        <a:t>Também ao contrato da própria administradora</a:t>
+                      </a:r>
+                      <a:endParaRPr lang="en-US" sz="1500" dirty="0">
+                        <a:latin typeface="Calibri" charset="0"/>
+                        <a:ea typeface="Calibri" charset="0"/>
+                        <a:cs typeface="Calibri" charset="0"/>
+                      </a:endParaRPr>
+                    </a:p>
+                  </a:txBody>
+                  <a:tcPr marL="109728" marR="109728" marT="109728" marB="109728" anchor="ctr">
+                    <a:lnL w="9525" cap="flat" cmpd="sng" algn="ctr">
+                      <a:solidFill>
+                        <a:srgbClr val="E5E7EB"/>
+                      </a:solidFill>
+                      <a:prstDash val="solid"/>
+                      <a:round/>
+                      <a:headEnd type="none" w="med" len="med"/>
+                      <a:tailEnd type="none" w="med" len="med"/>
+                    </a:lnL>
+                    <a:lnR w="9525" cap="flat" cmpd="sng" algn="ctr">
+                      <a:solidFill>
+                        <a:srgbClr val="E5E7EB"/>
+                      </a:solidFill>
+                      <a:prstDash val="solid"/>
+                      <a:round/>
+                      <a:headEnd type="none" w="med" len="med"/>
+                      <a:tailEnd type="none" w="med" len="med"/>
+                    </a:lnR>
+                    <a:lnT w="9525" cap="flat" cmpd="sng" algn="ctr">
+                      <a:solidFill>
+                        <a:srgbClr val="E5E7EB"/>
+                      </a:solidFill>
+                      <a:prstDash val="solid"/>
+                      <a:round/>
+                      <a:headEnd type="none" w="med" len="med"/>
+                      <a:tailEnd type="none" w="med" len="med"/>
+                    </a:lnT>
+                    <a:lnB w="9525" cap="flat" cmpd="sng" algn="ctr">
+                      <a:solidFill>
+                        <a:srgbClr val="E5E7EB"/>
+                      </a:solidFill>
+                      <a:prstDash val="solid"/>
+                      <a:round/>
+                      <a:headEnd type="none" w="med" len="med"/>
+                      <a:tailEnd type="none" w="med" len="med"/>
+                    </a:lnB>
+                    <a:solidFill>
+                      <a:srgbClr val="FFFFFF"/>
+                    </a:solidFill>
+                  </a:tcPr>
+                </a:tc>
+              </a:tr>
+              <a:tr h="777240">
+                <a:tc>
+                  <a:txBody>
+                    <a:bodyPr/>
+                    <a:lstStyle/>
+                    <a:p>
+                      <a:pPr indent="0" marL="0">
+                        <a:buNone/>
+                      </a:pPr>
+                      <a:r>
+                        <a:rPr lang="en-US" sz="1500" b="1" dirty="0">
+                          <a:solidFill>
+                            <a:srgbClr val="2F4162"/>
+                          </a:solidFill>
+                          <a:latin typeface="Calibri" pitchFamily="34" charset="0"/>
+                          <a:ea typeface="Calibri" pitchFamily="34" charset="-122"/>
+                          <a:cs typeface="Calibri" pitchFamily="34" charset="-120"/>
+                        </a:rPr>
+                        <a:t>Voto e posicionamento</a:t>
+                      </a:r>
+                      <a:endParaRPr lang="en-US" sz="1500" dirty="0">
+                        <a:latin typeface="Calibri" charset="0"/>
+                        <a:ea typeface="Calibri" charset="0"/>
+                        <a:cs typeface="Calibri" charset="0"/>
+                      </a:endParaRPr>
+                    </a:p>
+                  </a:txBody>
+                  <a:tcPr marL="109728" marR="109728" marT="109728" marB="109728" anchor="ctr">
+                    <a:lnL w="9525" cap="flat" cmpd="sng" algn="ctr">
+                      <a:solidFill>
+                        <a:srgbClr val="E5E7EB"/>
+                      </a:solidFill>
+                      <a:prstDash val="solid"/>
+                      <a:round/>
+                      <a:headEnd type="none" w="med" len="med"/>
+                      <a:tailEnd type="none" w="med" len="med"/>
+                    </a:lnL>
+                    <a:lnR w="9525" cap="flat" cmpd="sng" algn="ctr">
+                      <a:solidFill>
+                        <a:srgbClr val="E5E7EB"/>
+                      </a:solidFill>
+                      <a:prstDash val="solid"/>
+                      <a:round/>
+                      <a:headEnd type="none" w="med" len="med"/>
+                      <a:tailEnd type="none" w="med" len="med"/>
+                    </a:lnR>
+                    <a:lnT w="9525" cap="flat" cmpd="sng" algn="ctr">
+                      <a:solidFill>
+                        <a:srgbClr val="E5E7EB"/>
+                      </a:solidFill>
+                      <a:prstDash val="solid"/>
+                      <a:round/>
+                      <a:headEnd type="none" w="med" len="med"/>
+                      <a:tailEnd type="none" w="med" len="med"/>
+                    </a:lnT>
+                    <a:lnB w="9525" cap="flat" cmpd="sng" algn="ctr">
+                      <a:solidFill>
+                        <a:srgbClr val="E5E7EB"/>
+                      </a:solidFill>
+                      <a:prstDash val="solid"/>
+                      <a:round/>
+                      <a:headEnd type="none" w="med" len="med"/>
+                      <a:tailEnd type="none" w="med" len="med"/>
+                    </a:lnB>
+                    <a:solidFill>
+                      <a:srgbClr val="F6F7F9"/>
+                    </a:solidFill>
+                  </a:tcPr>
+                </a:tc>
+                <a:tc>
+                  <a:txBody>
+                    <a:bodyPr/>
+                    <a:lstStyle/>
+                    <a:p>
+                      <a:pPr indent="0" marL="0">
+                        <a:buNone/>
+                      </a:pPr>
+                      <a:r>
+                        <a:rPr lang="en-US" sz="1500" b="1" dirty="0">
+                          <a:solidFill>
+                            <a:srgbClr val="1F2A37"/>
+                          </a:solidFill>
+                          <a:latin typeface="Calibri" pitchFamily="34" charset="0"/>
+                          <a:ea typeface="Calibri" pitchFamily="34" charset="-122"/>
+                          <a:cs typeface="Calibri" pitchFamily="34" charset="-120"/>
+                        </a:rPr>
+                        <a:t>Só com autorização escrita do Einstein</a:t>
+                      </a:r>
+                      <a:endParaRPr lang="en-US" sz="1500" dirty="0">
+                        <a:latin typeface="Calibri" charset="0"/>
+                        <a:ea typeface="Calibri" charset="0"/>
+                        <a:cs typeface="Calibri" charset="0"/>
+                      </a:endParaRPr>
+                    </a:p>
+                  </a:txBody>
+                  <a:tcPr marL="109728" marR="109728" marT="109728" marB="109728" anchor="ctr">
+                    <a:lnL w="9525" cap="flat" cmpd="sng" algn="ctr">
+                      <a:solidFill>
+                        <a:srgbClr val="E5E7EB"/>
+                      </a:solidFill>
+                      <a:prstDash val="solid"/>
+                      <a:round/>
+                      <a:headEnd type="none" w="med" len="med"/>
+                      <a:tailEnd type="none" w="med" len="med"/>
+                    </a:lnL>
+                    <a:lnR w="9525" cap="flat" cmpd="sng" algn="ctr">
+                      <a:solidFill>
+                        <a:srgbClr val="E5E7EB"/>
+                      </a:solidFill>
+                      <a:prstDash val="solid"/>
+                      <a:round/>
+                      <a:headEnd type="none" w="med" len="med"/>
+                      <a:tailEnd type="none" w="med" len="med"/>
+                    </a:lnR>
+                    <a:lnT w="9525" cap="flat" cmpd="sng" algn="ctr">
+                      <a:solidFill>
+                        <a:srgbClr val="E5E7EB"/>
+                      </a:solidFill>
+                      <a:prstDash val="solid"/>
+                      <a:round/>
+                      <a:headEnd type="none" w="med" len="med"/>
+                      <a:tailEnd type="none" w="med" len="med"/>
+                    </a:lnT>
+                    <a:lnB w="9525" cap="flat" cmpd="sng" algn="ctr">
+                      <a:solidFill>
+                        <a:srgbClr val="E5E7EB"/>
+                      </a:solidFill>
+                      <a:prstDash val="solid"/>
+                      <a:round/>
+                      <a:headEnd type="none" w="med" len="med"/>
+                      <a:tailEnd type="none" w="med" len="med"/>
+                    </a:lnB>
+                    <a:solidFill>
+                      <a:srgbClr val="EEF1F6"/>
+                    </a:solidFill>
+                  </a:tcPr>
+                </a:tc>
+                <a:tc>
+                  <a:txBody>
+                    <a:bodyPr/>
+                    <a:lstStyle/>
+                    <a:p>
+                      <a:pPr indent="0" marL="0">
+                        <a:buNone/>
+                      </a:pPr>
+                      <a:r>
+                        <a:rPr lang="en-US" sz="1500" dirty="0">
+                          <a:solidFill>
+                            <a:srgbClr val="5B6470"/>
+                          </a:solidFill>
+                          <a:latin typeface="Calibri" pitchFamily="34" charset="0"/>
+                          <a:ea typeface="Calibri" pitchFamily="34" charset="-122"/>
+                          <a:cs typeface="Calibri" pitchFamily="34" charset="-120"/>
+                        </a:rPr>
+                        <a:t>Depende de como a função for contratada</a:t>
+                      </a:r>
+                      <a:endParaRPr lang="en-US" sz="1500" dirty="0">
+                        <a:latin typeface="Calibri" charset="0"/>
+                        <a:ea typeface="Calibri" charset="0"/>
+                        <a:cs typeface="Calibri" charset="0"/>
+                      </a:endParaRPr>
+                    </a:p>
+                  </a:txBody>
+                  <a:tcPr marL="109728" marR="109728" marT="109728" marB="109728" anchor="ctr">
+                    <a:lnL w="9525" cap="flat" cmpd="sng" algn="ctr">
+                      <a:solidFill>
+                        <a:srgbClr val="E5E7EB"/>
+                      </a:solidFill>
+                      <a:prstDash val="solid"/>
+                      <a:round/>
+                      <a:headEnd type="none" w="med" len="med"/>
+                      <a:tailEnd type="none" w="med" len="med"/>
+                    </a:lnL>
+                    <a:lnR w="9525" cap="flat" cmpd="sng" algn="ctr">
+                      <a:solidFill>
+                        <a:srgbClr val="E5E7EB"/>
+                      </a:solidFill>
+                      <a:prstDash val="solid"/>
+                      <a:round/>
+                      <a:headEnd type="none" w="med" len="med"/>
+                      <a:tailEnd type="none" w="med" len="med"/>
+                    </a:lnR>
+                    <a:lnT w="9525" cap="flat" cmpd="sng" algn="ctr">
+                      <a:solidFill>
+                        <a:srgbClr val="E5E7EB"/>
+                      </a:solidFill>
+                      <a:prstDash val="solid"/>
+                      <a:round/>
+                      <a:headEnd type="none" w="med" len="med"/>
+                      <a:tailEnd type="none" w="med" len="med"/>
+                    </a:lnT>
+                    <a:lnB w="9525" cap="flat" cmpd="sng" algn="ctr">
+                      <a:solidFill>
+                        <a:srgbClr val="E5E7EB"/>
+                      </a:solidFill>
+                      <a:prstDash val="solid"/>
+                      <a:round/>
+                      <a:headEnd type="none" w="med" len="med"/>
+                      <a:tailEnd type="none" w="med" len="med"/>
+                    </a:lnB>
+                    <a:solidFill>
+                      <a:srgbClr val="F6F7F9"/>
+                    </a:solidFill>
+                  </a:tcPr>
+                </a:tc>
+              </a:tr>
+            </a:tbl>
+          </a:graphicData>
+        </a:graphic>
+      </p:graphicFrame>
+      <p:sp>
+        <p:nvSpPr>
+          <p:cNvPr id="5" name="nota-comparativo"/>
           <p:cNvSpPr/>
           <p:nvPr/>
         </p:nvSpPr>
         <p:spPr>
           <a:xfrm>
-            <a:off x="548640" y="1280160"/>
-            <a:ext cx="5394960" cy="2286000"/>
+            <a:off x="548640" y="5486400"/>
+            <a:ext cx="11109960" cy="713232"/>
           </a:xfrm>
           <a:prstGeom prst="roundRect">
             <a:avLst>
-              <a:gd name="adj" fmla="val 3200"/>
+              <a:gd name="adj" fmla="val 10256"/>
             </a:avLst>
           </a:prstGeom>
           <a:solidFill>
-            <a:srgbClr val="2F4162"/>
+            <a:srgbClr val="FAF8F3"/>
           </a:solidFill>
           <a:ln w="12700">
             <a:solidFill>
-              <a:srgbClr val="2F4162"/>
+              <a:srgbClr val="FAF8F3"/>
             </a:solidFill>
             <a:prstDash val="solid"/>
           </a:ln>
@@ -17195,63 +18465,14 @@
       </p:sp>
       <p:sp>
         <p:nvSpPr>
-          <p:cNvPr id="4" name="icone-fundo"/>
-          <p:cNvSpPr/>
-          <p:nvPr/>
-        </p:nvSpPr>
-        <p:spPr>
-          <a:xfrm>
-            <a:off x="868680" y="1783080"/>
-            <a:ext cx="685800" cy="685800"/>
-          </a:xfrm>
-          <a:prstGeom prst="ellipse">
-            <a:avLst/>
-          </a:prstGeom>
-          <a:solidFill>
-            <a:srgbClr val="B8934A"/>
-          </a:solidFill>
-          <a:ln w="12700">
-            <a:solidFill>
-              <a:srgbClr val="B8934A"/>
-            </a:solidFill>
-            <a:prstDash val="solid"/>
-          </a:ln>
-        </p:spPr>
-      </p:sp>
-      <p:pic>
-        <p:nvPicPr>
-          <p:cNvPr id="5" name="icone" descr="preencoded.png">    </p:cNvPr>
-          <p:cNvPicPr>
-            <a:picLocks noChangeAspect="1"/>
-          </p:cNvPicPr>
-          <p:nvPr/>
-        </p:nvPicPr>
-        <p:blipFill>
-          <a:blip r:embed="rId1"/>
-          <a:stretch>
-            <a:fillRect/>
-          </a:stretch>
-        </p:blipFill>
-        <p:spPr>
-          <a:xfrm>
-            <a:off x="1033272" y="1947672"/>
-            <a:ext cx="356616" cy="356616"/>
-          </a:xfrm>
-          <a:prstGeom prst="rect">
-            <a:avLst/>
-          </a:prstGeom>
-        </p:spPr>
-      </p:pic>
-      <p:sp>
-        <p:nvSpPr>
           <p:cNvPr id="6" name="Text 3"/>
           <p:cNvSpPr txBox="1"/>
           <p:nvPr/>
         </p:nvSpPr>
         <p:spPr>
           <a:xfrm>
-            <a:off x="1783080" y="1783080"/>
-            <a:ext cx="3931920" cy="502920"/>
+            <a:off x="777240" y="5513832"/>
+            <a:ext cx="10698480" cy="658368"/>
           </a:xfrm>
           <a:prstGeom prst="rect">
             <a:avLst/>
@@ -17267,494 +18488,14 @@
               <a:buNone/>
             </a:pPr>
             <a:r>
-              <a:rPr lang="en-US" sz="2100" b="1" dirty="0">
-                <a:solidFill>
-                  <a:srgbClr val="FFFFFF"/>
-                </a:solidFill>
-              </a:rPr>
-              <a:t>Independência</a:t>
-            </a:r>
-            <a:endParaRPr lang="en-US" sz="2100" dirty="0"/>
-          </a:p>
-        </p:txBody>
-      </p:sp>
-      <p:sp>
-        <p:nvSpPr>
-          <p:cNvPr id="7" name="Text 4"/>
-          <p:cNvSpPr txBox="1"/>
-          <p:nvPr/>
-        </p:nvSpPr>
-        <p:spPr>
-          <a:xfrm>
-            <a:off x="1783080" y="2331720"/>
-            <a:ext cx="3931920" cy="1097280"/>
-          </a:xfrm>
-          <a:prstGeom prst="rect">
-            <a:avLst/>
-          </a:prstGeom>
-          <a:noFill/>
-          <a:ln/>
-        </p:spPr>
-        <p:txBody>
-          <a:bodyPr wrap="square" lIns="0" tIns="0" rIns="0" bIns="0" rtlCol="0" anchor="t"/>
-          <a:lstStyle/>
-          <a:p>
-            <a:pPr indent="0" marL="0">
-              <a:buNone/>
-            </a:pPr>
-            <a:r>
-              <a:rPr lang="en-US" sz="1600" dirty="0">
-                <a:solidFill>
-                  <a:srgbClr val="FFFFFF"/>
-                </a:solidFill>
-              </a:rPr>
-              <a:t>Não somos administradora: fiscalizamos quem executa, em nome do Einstein</a:t>
-            </a:r>
-            <a:endParaRPr lang="en-US" sz="1600" dirty="0"/>
-          </a:p>
-        </p:txBody>
-      </p:sp>
-      <p:sp>
-        <p:nvSpPr>
-          <p:cNvPr id="8" name="porque-1"/>
-          <p:cNvSpPr/>
-          <p:nvPr/>
-        </p:nvSpPr>
-        <p:spPr>
-          <a:xfrm>
-            <a:off x="6172200" y="1280160"/>
-            <a:ext cx="5394960" cy="2286000"/>
-          </a:xfrm>
-          <a:prstGeom prst="roundRect">
-            <a:avLst>
-              <a:gd name="adj" fmla="val 3200"/>
-            </a:avLst>
-          </a:prstGeom>
-          <a:solidFill>
-            <a:srgbClr val="F3F4F6"/>
-          </a:solidFill>
-          <a:ln w="12700">
-            <a:solidFill>
-              <a:srgbClr val="F3F4F6"/>
-            </a:solidFill>
-            <a:prstDash val="solid"/>
-          </a:ln>
-        </p:spPr>
-      </p:sp>
-      <p:sp>
-        <p:nvSpPr>
-          <p:cNvPr id="9" name="icone-fundo"/>
-          <p:cNvSpPr/>
-          <p:nvPr/>
-        </p:nvSpPr>
-        <p:spPr>
-          <a:xfrm>
-            <a:off x="6492240" y="1783080"/>
-            <a:ext cx="685800" cy="685800"/>
-          </a:xfrm>
-          <a:prstGeom prst="ellipse">
-            <a:avLst/>
-          </a:prstGeom>
-          <a:solidFill>
-            <a:srgbClr val="2F4162"/>
-          </a:solidFill>
-          <a:ln w="12700">
-            <a:solidFill>
-              <a:srgbClr val="2F4162"/>
-            </a:solidFill>
-            <a:prstDash val="solid"/>
-          </a:ln>
-        </p:spPr>
-      </p:sp>
-      <p:pic>
-        <p:nvPicPr>
-          <p:cNvPr id="10" name="icone" descr="preencoded.png">    </p:cNvPr>
-          <p:cNvPicPr>
-            <a:picLocks noChangeAspect="1"/>
-          </p:cNvPicPr>
-          <p:nvPr/>
-        </p:nvPicPr>
-        <p:blipFill>
-          <a:blip r:embed="rId2"/>
-          <a:stretch>
-            <a:fillRect/>
-          </a:stretch>
-        </p:blipFill>
-        <p:spPr>
-          <a:xfrm>
-            <a:off x="6656832" y="1947672"/>
-            <a:ext cx="356616" cy="356616"/>
-          </a:xfrm>
-          <a:prstGeom prst="rect">
-            <a:avLst/>
-          </a:prstGeom>
-        </p:spPr>
-      </p:pic>
-      <p:sp>
-        <p:nvSpPr>
-          <p:cNvPr id="11" name="Text 7"/>
-          <p:cNvSpPr txBox="1"/>
-          <p:nvPr/>
-        </p:nvSpPr>
-        <p:spPr>
-          <a:xfrm>
-            <a:off x="7406640" y="1783080"/>
-            <a:ext cx="3931920" cy="502920"/>
-          </a:xfrm>
-          <a:prstGeom prst="rect">
-            <a:avLst/>
-          </a:prstGeom>
-          <a:noFill/>
-          <a:ln/>
-        </p:spPr>
-        <p:txBody>
-          <a:bodyPr wrap="square" lIns="0" tIns="0" rIns="0" bIns="0" rtlCol="0" anchor="ctr"/>
-          <a:lstStyle/>
-          <a:p>
-            <a:pPr indent="0" marL="0">
-              <a:buNone/>
-            </a:pPr>
-            <a:r>
-              <a:rPr lang="en-US" sz="2100" b="1" dirty="0">
-                <a:solidFill>
-                  <a:srgbClr val="2F4162"/>
-                </a:solidFill>
-              </a:rPr>
-              <a:t>Rateio é o nosso forte</a:t>
-            </a:r>
-            <a:endParaRPr lang="en-US" sz="2100" dirty="0"/>
-          </a:p>
-        </p:txBody>
-      </p:sp>
-      <p:sp>
-        <p:nvSpPr>
-          <p:cNvPr id="12" name="Text 8"/>
-          <p:cNvSpPr txBox="1"/>
-          <p:nvPr/>
-        </p:nvSpPr>
-        <p:spPr>
-          <a:xfrm>
-            <a:off x="7406640" y="2331720"/>
-            <a:ext cx="3931920" cy="1097280"/>
-          </a:xfrm>
-          <a:prstGeom prst="rect">
-            <a:avLst/>
-          </a:prstGeom>
-          <a:noFill/>
-          <a:ln/>
-        </p:spPr>
-        <p:txBody>
-          <a:bodyPr wrap="square" lIns="0" tIns="0" rIns="0" bIns="0" rtlCol="0" anchor="t"/>
-          <a:lstStyle/>
-          <a:p>
-            <a:pPr indent="0" marL="0">
-              <a:buNone/>
-            </a:pPr>
-            <a:r>
-              <a:rPr lang="en-US" sz="1600" dirty="0">
-                <a:solidFill>
-                  <a:srgbClr val="1F2A37"/>
-                </a:solidFill>
-              </a:rPr>
-              <a:t>Casos reais de subsídio cruzado corrigidos — inclusive por deliberação de assembleia</a:t>
-            </a:r>
-            <a:endParaRPr lang="en-US" sz="1600" dirty="0"/>
-          </a:p>
-        </p:txBody>
-      </p:sp>
-      <p:sp>
-        <p:nvSpPr>
-          <p:cNvPr id="13" name="porque-2"/>
-          <p:cNvSpPr/>
-          <p:nvPr/>
-        </p:nvSpPr>
-        <p:spPr>
-          <a:xfrm>
-            <a:off x="548640" y="3794760"/>
-            <a:ext cx="5394960" cy="2286000"/>
-          </a:xfrm>
-          <a:prstGeom prst="roundRect">
-            <a:avLst>
-              <a:gd name="adj" fmla="val 3200"/>
-            </a:avLst>
-          </a:prstGeom>
-          <a:solidFill>
-            <a:srgbClr val="F3F4F6"/>
-          </a:solidFill>
-          <a:ln w="12700">
-            <a:solidFill>
-              <a:srgbClr val="F3F4F6"/>
-            </a:solidFill>
-            <a:prstDash val="solid"/>
-          </a:ln>
-        </p:spPr>
-      </p:sp>
-      <p:sp>
-        <p:nvSpPr>
-          <p:cNvPr id="14" name="icone-fundo"/>
-          <p:cNvSpPr/>
-          <p:nvPr/>
-        </p:nvSpPr>
-        <p:spPr>
-          <a:xfrm>
-            <a:off x="868680" y="4297680"/>
-            <a:ext cx="685800" cy="685800"/>
-          </a:xfrm>
-          <a:prstGeom prst="ellipse">
-            <a:avLst/>
-          </a:prstGeom>
-          <a:solidFill>
-            <a:srgbClr val="2F4162"/>
-          </a:solidFill>
-          <a:ln w="12700">
-            <a:solidFill>
-              <a:srgbClr val="2F4162"/>
-            </a:solidFill>
-            <a:prstDash val="solid"/>
-          </a:ln>
-        </p:spPr>
-      </p:sp>
-      <p:pic>
-        <p:nvPicPr>
-          <p:cNvPr id="15" name="icone" descr="preencoded.png">    </p:cNvPr>
-          <p:cNvPicPr>
-            <a:picLocks noChangeAspect="1"/>
-          </p:cNvPicPr>
-          <p:nvPr/>
-        </p:nvPicPr>
-        <p:blipFill>
-          <a:blip r:embed="rId3"/>
-          <a:stretch>
-            <a:fillRect/>
-          </a:stretch>
-        </p:blipFill>
-        <p:spPr>
-          <a:xfrm>
-            <a:off x="1033272" y="4462272"/>
-            <a:ext cx="356616" cy="356616"/>
-          </a:xfrm>
-          <a:prstGeom prst="rect">
-            <a:avLst/>
-          </a:prstGeom>
-        </p:spPr>
-      </p:pic>
-      <p:sp>
-        <p:nvSpPr>
-          <p:cNvPr id="16" name="Text 11"/>
-          <p:cNvSpPr txBox="1"/>
-          <p:nvPr/>
-        </p:nvSpPr>
-        <p:spPr>
-          <a:xfrm>
-            <a:off x="1783080" y="4297680"/>
-            <a:ext cx="3931920" cy="502920"/>
-          </a:xfrm>
-          <a:prstGeom prst="rect">
-            <a:avLst/>
-          </a:prstGeom>
-          <a:noFill/>
-          <a:ln/>
-        </p:spPr>
-        <p:txBody>
-          <a:bodyPr wrap="square" lIns="0" tIns="0" rIns="0" bIns="0" rtlCol="0" anchor="ctr"/>
-          <a:lstStyle/>
-          <a:p>
-            <a:pPr indent="0" marL="0">
-              <a:buNone/>
-            </a:pPr>
-            <a:r>
-              <a:rPr lang="en-US" sz="2100" b="1" dirty="0">
-                <a:solidFill>
-                  <a:srgbClr val="2F4162"/>
-                </a:solidFill>
-              </a:rPr>
-              <a:t>Hospital em condomínio multiuso</a:t>
-            </a:r>
-            <a:endParaRPr lang="en-US" sz="2100" dirty="0"/>
-          </a:p>
-        </p:txBody>
-      </p:sp>
-      <p:sp>
-        <p:nvSpPr>
-          <p:cNvPr id="17" name="Text 12"/>
-          <p:cNvSpPr txBox="1"/>
-          <p:nvPr/>
-        </p:nvSpPr>
-        <p:spPr>
-          <a:xfrm>
-            <a:off x="1783080" y="4846320"/>
-            <a:ext cx="3931920" cy="1097280"/>
-          </a:xfrm>
-          <a:prstGeom prst="rect">
-            <a:avLst/>
-          </a:prstGeom>
-          <a:noFill/>
-          <a:ln/>
-        </p:spPr>
-        <p:txBody>
-          <a:bodyPr wrap="square" lIns="0" tIns="0" rIns="0" bIns="0" rtlCol="0" anchor="t"/>
-          <a:lstStyle/>
-          <a:p>
-            <a:pPr indent="0" marL="0">
-              <a:buNone/>
-            </a:pPr>
-            <a:r>
-              <a:rPr lang="en-US" sz="1600" dirty="0">
-                <a:solidFill>
-                  <a:srgbClr val="1F2A37"/>
-                </a:solidFill>
-              </a:rPr>
-              <a:t>Fazemos isso hoje no O Parque, com implantação em andamento</a:t>
-            </a:r>
-            <a:endParaRPr lang="en-US" sz="1600" dirty="0"/>
-          </a:p>
-        </p:txBody>
-      </p:sp>
-      <p:sp>
-        <p:nvSpPr>
-          <p:cNvPr id="18" name="porque-3"/>
-          <p:cNvSpPr/>
-          <p:nvPr/>
-        </p:nvSpPr>
-        <p:spPr>
-          <a:xfrm>
-            <a:off x="6172200" y="3794760"/>
-            <a:ext cx="5394960" cy="2286000"/>
-          </a:xfrm>
-          <a:prstGeom prst="roundRect">
-            <a:avLst>
-              <a:gd name="adj" fmla="val 3200"/>
-            </a:avLst>
-          </a:prstGeom>
-          <a:solidFill>
-            <a:srgbClr val="F3F4F6"/>
-          </a:solidFill>
-          <a:ln w="12700">
-            <a:solidFill>
-              <a:srgbClr val="F3F4F6"/>
-            </a:solidFill>
-            <a:prstDash val="solid"/>
-          </a:ln>
-        </p:spPr>
-      </p:sp>
-      <p:sp>
-        <p:nvSpPr>
-          <p:cNvPr id="19" name="icone-fundo"/>
-          <p:cNvSpPr/>
-          <p:nvPr/>
-        </p:nvSpPr>
-        <p:spPr>
-          <a:xfrm>
-            <a:off x="6492240" y="4297680"/>
-            <a:ext cx="685800" cy="685800"/>
-          </a:xfrm>
-          <a:prstGeom prst="ellipse">
-            <a:avLst/>
-          </a:prstGeom>
-          <a:solidFill>
-            <a:srgbClr val="2F4162"/>
-          </a:solidFill>
-          <a:ln w="12700">
-            <a:solidFill>
-              <a:srgbClr val="2F4162"/>
-            </a:solidFill>
-            <a:prstDash val="solid"/>
-          </a:ln>
-        </p:spPr>
-      </p:sp>
-      <p:pic>
-        <p:nvPicPr>
-          <p:cNvPr id="20" name="icone" descr="preencoded.png">    </p:cNvPr>
-          <p:cNvPicPr>
-            <a:picLocks noChangeAspect="1"/>
-          </p:cNvPicPr>
-          <p:nvPr/>
-        </p:nvPicPr>
-        <p:blipFill>
-          <a:blip r:embed="rId4"/>
-          <a:stretch>
-            <a:fillRect/>
-          </a:stretch>
-        </p:blipFill>
-        <p:spPr>
-          <a:xfrm>
-            <a:off x="6656832" y="4462272"/>
-            <a:ext cx="356616" cy="356616"/>
-          </a:xfrm>
-          <a:prstGeom prst="rect">
-            <a:avLst/>
-          </a:prstGeom>
-        </p:spPr>
-      </p:pic>
-      <p:sp>
-        <p:nvSpPr>
-          <p:cNvPr id="21" name="Text 15"/>
-          <p:cNvSpPr txBox="1"/>
-          <p:nvPr/>
-        </p:nvSpPr>
-        <p:spPr>
-          <a:xfrm>
-            <a:off x="7406640" y="4297680"/>
-            <a:ext cx="3931920" cy="502920"/>
-          </a:xfrm>
-          <a:prstGeom prst="rect">
-            <a:avLst/>
-          </a:prstGeom>
-          <a:noFill/>
-          <a:ln/>
-        </p:spPr>
-        <p:txBody>
-          <a:bodyPr wrap="square" lIns="0" tIns="0" rIns="0" bIns="0" rtlCol="0" anchor="ctr"/>
-          <a:lstStyle/>
-          <a:p>
-            <a:pPr indent="0" marL="0">
-              <a:buNone/>
-            </a:pPr>
-            <a:r>
-              <a:rPr lang="en-US" sz="2100" b="1" dirty="0">
-                <a:solidFill>
-                  <a:srgbClr val="2F4162"/>
-                </a:solidFill>
-              </a:rPr>
-              <a:t>Governança à prova de risco</a:t>
-            </a:r>
-            <a:endParaRPr lang="en-US" sz="2100" dirty="0"/>
-          </a:p>
-        </p:txBody>
-      </p:sp>
-      <p:sp>
-        <p:nvSpPr>
-          <p:cNvPr id="22" name="Text 16"/>
-          <p:cNvSpPr txBox="1"/>
-          <p:nvPr/>
-        </p:nvSpPr>
-        <p:spPr>
-          <a:xfrm>
-            <a:off x="7406640" y="4846320"/>
-            <a:ext cx="3931920" cy="1097280"/>
-          </a:xfrm>
-          <a:prstGeom prst="rect">
-            <a:avLst/>
-          </a:prstGeom>
-          <a:noFill/>
-          <a:ln/>
-        </p:spPr>
-        <p:txBody>
-          <a:bodyPr wrap="square" lIns="0" tIns="0" rIns="0" bIns="0" rtlCol="0" anchor="t"/>
-          <a:lstStyle/>
-          <a:p>
-            <a:pPr indent="0" marL="0">
-              <a:buNone/>
-            </a:pPr>
-            <a:r>
-              <a:rPr lang="en-US" sz="1600" dirty="0">
-                <a:solidFill>
-                  <a:srgbClr val="1F2A37"/>
-                </a:solidFill>
-              </a:rPr>
-              <a:t>Nenhum voto sem autorização escrita; SLAs iguais ou melhores que a referência</a:t>
-            </a:r>
-            <a:endParaRPr lang="en-US" sz="1600" dirty="0"/>
+              <a:rPr lang="en-US" sz="1350" i="1" dirty="0">
+                <a:solidFill>
+                  <a:schemeClr val="tx2"/>
+                </a:solidFill>
+              </a:rPr>
+              <a:t>Comparamos modelos de atuação, não empresas. A separação entre governança e operação é a premissa da própria RFP.</a:t>
+            </a:r>
+            <a:endParaRPr lang="en-US" sz="1350" dirty="0"/>
           </a:p>
         </p:txBody>
       </p:sp>
@@ -17830,14 +18571,16 @@
       </p:grpSpPr>
       <p:sp>
         <p:nvSpPr>
-          <p:cNvPr id="2" name="Text 0"/>
-          <p:cNvSpPr txBox="1"/>
-          <p:nvPr/>
-        </p:nvSpPr>
-        <p:spPr>
-          <a:xfrm>
-            <a:off x="731520" y="2103120"/>
-            <a:ext cx="10058400" cy="914400"/>
+          <p:cNvPr id="2" name="Text 1"/>
+          <p:cNvSpPr/>
+          <p:nvPr>
+            <p:ph idx="102" type="title" hasCustomPrompt="1"/>
+          </p:nvPr>
+        </p:nvSpPr>
+        <p:spPr>
+          <a:xfrm>
+            <a:off x="548640" y="320040"/>
+            <a:ext cx="10241280" cy="685800"/>
           </a:xfrm>
           <a:prstGeom prst="rect">
             <a:avLst/>
@@ -17849,31 +18592,426 @@
           <a:bodyPr wrap="square" lIns="0" tIns="0" rIns="0" bIns="0" rtlCol="0" anchor="ctr"/>
           <a:lstStyle/>
           <a:p>
-            <a:pPr indent="0" marL="0">
-              <a:buNone/>
-            </a:pPr>
-            <a:r>
-              <a:rPr lang="en-US" sz="4800" b="1" dirty="0">
+            <a:pPr algn="l" indent="0" marL="0">
+              <a:buNone/>
+            </a:pPr>
+            <a:r>
+              <a:rPr lang="en-US" sz="3000" b="1" dirty="0">
+                <a:solidFill>
+                  <a:schemeClr val="tx2"/>
+                </a:solidFill>
+              </a:rPr>
+              <a:t>Três unidades, três respostas — com prova</a:t>
+            </a:r>
+            <a:endParaRPr lang="en-US" sz="3000" dirty="0"/>
+          </a:p>
+        </p:txBody>
+      </p:sp>
+      <p:sp>
+        <p:nvSpPr>
+          <p:cNvPr id="3" name="subtitulo"/>
+          <p:cNvSpPr txBox="1"/>
+          <p:nvPr/>
+        </p:nvSpPr>
+        <p:spPr>
+          <a:xfrm>
+            <a:off x="548640" y="1024128"/>
+            <a:ext cx="10515600" cy="365760"/>
+          </a:xfrm>
+          <a:prstGeom prst="rect">
+            <a:avLst/>
+          </a:prstGeom>
+          <a:noFill/>
+          <a:ln/>
+        </p:spPr>
+        <p:txBody>
+          <a:bodyPr wrap="square" lIns="0" tIns="0" rIns="0" bIns="0" rtlCol="0" anchor="ctr"/>
+          <a:lstStyle/>
+          <a:p>
+            <a:pPr indent="0" marL="0">
+              <a:buNone/>
+            </a:pPr>
+            <a:r>
+              <a:rPr lang="en-US" sz="1500" dirty="0">
+                <a:solidFill>
+                  <a:schemeClr val="accent3"/>
+                </a:solidFill>
+              </a:rPr>
+              <a:t>Para cada desafio que identificamos, uma resposta que a DF já entregou em outro empreendimento</a:t>
+            </a:r>
+            <a:endParaRPr lang="en-US" sz="1500" dirty="0"/>
+          </a:p>
+        </p:txBody>
+      </p:sp>
+      <p:sp>
+        <p:nvSpPr>
+          <p:cNvPr id="4" name="resposta-0"/>
+          <p:cNvSpPr/>
+          <p:nvPr/>
+        </p:nvSpPr>
+        <p:spPr>
+          <a:xfrm>
+            <a:off x="548640" y="1600200"/>
+            <a:ext cx="3520440" cy="3017520"/>
+          </a:xfrm>
+          <a:prstGeom prst="roundRect">
+            <a:avLst>
+              <a:gd name="adj" fmla="val 2424"/>
+            </a:avLst>
+          </a:prstGeom>
+          <a:solidFill>
+            <a:srgbClr val="F3F4F6"/>
+          </a:solidFill>
+          <a:ln w="12700">
+            <a:solidFill>
+              <a:srgbClr val="F3F4F6"/>
+            </a:solidFill>
+            <a:prstDash val="solid"/>
+          </a:ln>
+        </p:spPr>
+      </p:sp>
+      <p:sp>
+        <p:nvSpPr>
+          <p:cNvPr id="5" name="icone-fundo"/>
+          <p:cNvSpPr/>
+          <p:nvPr/>
+        </p:nvSpPr>
+        <p:spPr>
+          <a:xfrm>
+            <a:off x="822960" y="1874520"/>
+            <a:ext cx="548640" cy="548640"/>
+          </a:xfrm>
+          <a:prstGeom prst="ellipse">
+            <a:avLst/>
+          </a:prstGeom>
+          <a:solidFill>
+            <a:schemeClr val="accent1"/>
+          </a:solidFill>
+          <a:ln w="12700">
+            <a:solidFill>
+              <a:schemeClr val="accent1"/>
+            </a:solidFill>
+            <a:prstDash val="solid"/>
+          </a:ln>
+        </p:spPr>
+      </p:sp>
+      <p:pic>
+        <p:nvPicPr>
+          <p:cNvPr id="6" name="icone" descr="preencoded.png">    </p:cNvPr>
+          <p:cNvPicPr>
+            <a:picLocks noChangeAspect="1"/>
+          </p:cNvPicPr>
+          <p:nvPr/>
+        </p:nvPicPr>
+        <p:blipFill>
+          <a:blip r:embed="rId1"/>
+          <a:stretch>
+            <a:fillRect/>
+          </a:stretch>
+        </p:blipFill>
+        <p:spPr>
+          <a:xfrm>
+            <a:off x="954634" y="2006194"/>
+            <a:ext cx="285293" cy="285293"/>
+          </a:xfrm>
+          <a:prstGeom prst="rect">
+            <a:avLst/>
+          </a:prstGeom>
+        </p:spPr>
+      </p:pic>
+      <p:sp>
+        <p:nvSpPr>
+          <p:cNvPr id="7" name="Text 4"/>
+          <p:cNvSpPr txBox="1"/>
+          <p:nvPr/>
+        </p:nvSpPr>
+        <p:spPr>
+          <a:xfrm>
+            <a:off x="1508760" y="1874520"/>
+            <a:ext cx="2423160" cy="548640"/>
+          </a:xfrm>
+          <a:prstGeom prst="rect">
+            <a:avLst/>
+          </a:prstGeom>
+          <a:noFill/>
+          <a:ln/>
+        </p:spPr>
+        <p:txBody>
+          <a:bodyPr wrap="square" lIns="0" tIns="0" rIns="0" bIns="0" rtlCol="0" anchor="ctr"/>
+          <a:lstStyle/>
+          <a:p>
+            <a:pPr indent="0" marL="0">
+              <a:buNone/>
+            </a:pPr>
+            <a:r>
+              <a:rPr lang="en-US" sz="1700" b="1" dirty="0">
+                <a:solidFill>
+                  <a:schemeClr val="tx2"/>
+                </a:solidFill>
+              </a:rPr>
+              <a:t>Parque Global</a:t>
+            </a:r>
+            <a:endParaRPr lang="en-US" sz="1700" dirty="0"/>
+          </a:p>
+        </p:txBody>
+      </p:sp>
+      <p:sp>
+        <p:nvSpPr>
+          <p:cNvPr id="8" name="Text 5"/>
+          <p:cNvSpPr txBox="1"/>
+          <p:nvPr/>
+        </p:nvSpPr>
+        <p:spPr>
+          <a:xfrm>
+            <a:off x="822960" y="2606040"/>
+            <a:ext cx="3017520" cy="457200"/>
+          </a:xfrm>
+          <a:prstGeom prst="rect">
+            <a:avLst/>
+          </a:prstGeom>
+          <a:noFill/>
+          <a:ln/>
+        </p:spPr>
+        <p:txBody>
+          <a:bodyPr wrap="square" lIns="0" tIns="0" rIns="0" bIns="0" rtlCol="0" anchor="t"/>
+          <a:lstStyle/>
+          <a:p>
+            <a:pPr indent="0" marL="0">
+              <a:buNone/>
+            </a:pPr>
+            <a:r>
+              <a:rPr lang="en-US" sz="1100" b="1" spc="100" kern="0" dirty="0">
+                <a:solidFill>
+                  <a:schemeClr val="accent3"/>
+                </a:solidFill>
+              </a:rPr>
+              <a:t>GOVERNANÇA SETORIAL E SEGREGAÇÃO DE DESPESAS</a:t>
+            </a:r>
+            <a:endParaRPr lang="en-US" sz="1100" dirty="0"/>
+          </a:p>
+        </p:txBody>
+      </p:sp>
+      <p:sp>
+        <p:nvSpPr>
+          <p:cNvPr id="9" name="Text 6"/>
+          <p:cNvSpPr txBox="1"/>
+          <p:nvPr/>
+        </p:nvSpPr>
+        <p:spPr>
+          <a:xfrm>
+            <a:off x="822960" y="3108960"/>
+            <a:ext cx="3017520" cy="1371600"/>
+          </a:xfrm>
+          <a:prstGeom prst="rect">
+            <a:avLst/>
+          </a:prstGeom>
+          <a:noFill/>
+          <a:ln/>
+        </p:spPr>
+        <p:txBody>
+          <a:bodyPr wrap="square" lIns="0" tIns="0" rIns="0" bIns="0" rtlCol="0" anchor="t"/>
+          <a:lstStyle/>
+          <a:p>
+            <a:pPr indent="0" marL="0">
+              <a:buNone/>
+            </a:pPr>
+            <a:r>
+              <a:rPr lang="en-US" sz="1400" dirty="0">
+                <a:solidFill>
+                  <a:schemeClr val="tx1"/>
+                </a:solidFill>
+              </a:rPr>
+              <a:t>Rateio por subcondomínio e setor, com despesas comuns e específicas separadas</a:t>
+            </a:r>
+            <a:endParaRPr lang="en-US" sz="1400" dirty="0"/>
+          </a:p>
+        </p:txBody>
+      </p:sp>
+      <p:sp>
+        <p:nvSpPr>
+          <p:cNvPr id="10" name="prova-0"/>
+          <p:cNvSpPr/>
+          <p:nvPr/>
+        </p:nvSpPr>
+        <p:spPr>
+          <a:xfrm>
+            <a:off x="548640" y="4754880"/>
+            <a:ext cx="3520440" cy="1417320"/>
+          </a:xfrm>
+          <a:prstGeom prst="roundRect">
+            <a:avLst>
+              <a:gd name="adj" fmla="val 5161"/>
+            </a:avLst>
+          </a:prstGeom>
+          <a:solidFill>
+            <a:srgbClr val="2F4162"/>
+          </a:solidFill>
+          <a:ln w="12700">
+            <a:solidFill>
+              <a:srgbClr val="2F4162"/>
+            </a:solidFill>
+            <a:prstDash val="solid"/>
+          </a:ln>
+        </p:spPr>
+      </p:sp>
+      <p:sp>
+        <p:nvSpPr>
+          <p:cNvPr id="11" name="Text 8"/>
+          <p:cNvSpPr txBox="1"/>
+          <p:nvPr/>
+        </p:nvSpPr>
+        <p:spPr>
+          <a:xfrm>
+            <a:off x="822960" y="4864608"/>
+            <a:ext cx="3017520" cy="292608"/>
+          </a:xfrm>
+          <a:prstGeom prst="rect">
+            <a:avLst/>
+          </a:prstGeom>
+          <a:noFill/>
+          <a:ln/>
+        </p:spPr>
+        <p:txBody>
+          <a:bodyPr wrap="square" lIns="0" tIns="0" rIns="0" bIns="0" rtlCol="0" anchor="ctr"/>
+          <a:lstStyle/>
+          <a:p>
+            <a:pPr indent="0" marL="0">
+              <a:buNone/>
+            </a:pPr>
+            <a:r>
+              <a:rPr lang="en-US" sz="1150" b="1" spc="100" kern="0" dirty="0">
+                <a:solidFill>
+                  <a:schemeClr val="accent2"/>
+                </a:solidFill>
+              </a:rPr>
+              <a:t>PROVA: SPHQ I</a:t>
+            </a:r>
+            <a:endParaRPr lang="en-US" sz="1150" dirty="0"/>
+          </a:p>
+        </p:txBody>
+      </p:sp>
+      <p:sp>
+        <p:nvSpPr>
+          <p:cNvPr id="12" name="Text 9"/>
+          <p:cNvSpPr txBox="1"/>
+          <p:nvPr/>
+        </p:nvSpPr>
+        <p:spPr>
+          <a:xfrm>
+            <a:off x="822960" y="5175504"/>
+            <a:ext cx="3017520" cy="914400"/>
+          </a:xfrm>
+          <a:prstGeom prst="rect">
+            <a:avLst/>
+          </a:prstGeom>
+          <a:noFill/>
+          <a:ln/>
+        </p:spPr>
+        <p:txBody>
+          <a:bodyPr wrap="square" lIns="0" tIns="0" rIns="0" bIns="0" rtlCol="0" anchor="t"/>
+          <a:lstStyle/>
+          <a:p>
+            <a:pPr indent="0" marL="0">
+              <a:buNone/>
+            </a:pPr>
+            <a:r>
+              <a:rPr lang="en-US" sz="1300" dirty="0">
                 <a:solidFill>
                   <a:srgbClr val="FFFFFF"/>
                 </a:solidFill>
               </a:rPr>
-              <a:t>Obrigado</a:t>
-            </a:r>
-            <a:endParaRPr lang="en-US" sz="4800" dirty="0"/>
-          </a:p>
-        </p:txBody>
-      </p:sp>
-      <p:sp>
-        <p:nvSpPr>
-          <p:cNvPr id="3" name="Text 1"/>
-          <p:cNvSpPr txBox="1"/>
-          <p:nvPr/>
-        </p:nvSpPr>
-        <p:spPr>
-          <a:xfrm>
-            <a:off x="731520" y="3017520"/>
-            <a:ext cx="10058400" cy="457200"/>
+              <a:t>Coeficiente de Rateio de Despesas aprovado em assembleia — cada subcondomínio paga só o que é seu</a:t>
+            </a:r>
+            <a:endParaRPr lang="en-US" sz="1300" dirty="0"/>
+          </a:p>
+        </p:txBody>
+      </p:sp>
+      <p:sp>
+        <p:nvSpPr>
+          <p:cNvPr id="13" name="resposta-1"/>
+          <p:cNvSpPr/>
+          <p:nvPr/>
+        </p:nvSpPr>
+        <p:spPr>
+          <a:xfrm>
+            <a:off x="4297680" y="1600200"/>
+            <a:ext cx="3520440" cy="3017520"/>
+          </a:xfrm>
+          <a:prstGeom prst="roundRect">
+            <a:avLst>
+              <a:gd name="adj" fmla="val 2424"/>
+            </a:avLst>
+          </a:prstGeom>
+          <a:solidFill>
+            <a:srgbClr val="F3F4F6"/>
+          </a:solidFill>
+          <a:ln w="12700">
+            <a:solidFill>
+              <a:srgbClr val="F3F4F6"/>
+            </a:solidFill>
+            <a:prstDash val="solid"/>
+          </a:ln>
+        </p:spPr>
+      </p:sp>
+      <p:sp>
+        <p:nvSpPr>
+          <p:cNvPr id="14" name="icone-fundo"/>
+          <p:cNvSpPr/>
+          <p:nvPr/>
+        </p:nvSpPr>
+        <p:spPr>
+          <a:xfrm>
+            <a:off x="4572000" y="1874520"/>
+            <a:ext cx="548640" cy="548640"/>
+          </a:xfrm>
+          <a:prstGeom prst="ellipse">
+            <a:avLst/>
+          </a:prstGeom>
+          <a:solidFill>
+            <a:schemeClr val="accent1"/>
+          </a:solidFill>
+          <a:ln w="12700">
+            <a:solidFill>
+              <a:schemeClr val="accent1"/>
+            </a:solidFill>
+            <a:prstDash val="solid"/>
+          </a:ln>
+        </p:spPr>
+      </p:sp>
+      <p:pic>
+        <p:nvPicPr>
+          <p:cNvPr id="15" name="icone" descr="preencoded.png">    </p:cNvPr>
+          <p:cNvPicPr>
+            <a:picLocks noChangeAspect="1"/>
+          </p:cNvPicPr>
+          <p:nvPr/>
+        </p:nvPicPr>
+        <p:blipFill>
+          <a:blip r:embed="rId2"/>
+          <a:stretch>
+            <a:fillRect/>
+          </a:stretch>
+        </p:blipFill>
+        <p:spPr>
+          <a:xfrm>
+            <a:off x="4703674" y="2006194"/>
+            <a:ext cx="285293" cy="285293"/>
+          </a:xfrm>
+          <a:prstGeom prst="rect">
+            <a:avLst/>
+          </a:prstGeom>
+        </p:spPr>
+      </p:pic>
+      <p:sp>
+        <p:nvSpPr>
+          <p:cNvPr id="16" name="Text 12"/>
+          <p:cNvSpPr txBox="1"/>
+          <p:nvPr/>
+        </p:nvSpPr>
+        <p:spPr>
+          <a:xfrm>
+            <a:off x="5257800" y="1874520"/>
+            <a:ext cx="2423160" cy="548640"/>
           </a:xfrm>
           <a:prstGeom prst="rect">
             <a:avLst/>
@@ -17889,27 +19027,27 @@
               <a:buNone/>
             </a:pPr>
             <a:r>
-              <a:rPr lang="en-US" sz="2000" dirty="0">
-                <a:solidFill>
-                  <a:srgbClr val="CBD5E4"/>
-                </a:solidFill>
-              </a:rPr>
-              <a:t>Estamos à disposição para as dúvidas do Einstein</a:t>
-            </a:r>
-            <a:endParaRPr lang="en-US" sz="2000" dirty="0"/>
-          </a:p>
-        </p:txBody>
-      </p:sp>
-      <p:sp>
-        <p:nvSpPr>
-          <p:cNvPr id="4" name="Text 2"/>
-          <p:cNvSpPr txBox="1"/>
-          <p:nvPr/>
-        </p:nvSpPr>
-        <p:spPr>
-          <a:xfrm>
-            <a:off x="731520" y="3931920"/>
-            <a:ext cx="6583680" cy="1645920"/>
+              <a:rPr lang="en-US" sz="1700" b="1" dirty="0">
+                <a:solidFill>
+                  <a:schemeClr val="tx2"/>
+                </a:solidFill>
+              </a:rPr>
+              <a:t>Unidade Hospitalar Pinheiros</a:t>
+            </a:r>
+            <a:endParaRPr lang="en-US" sz="1700" dirty="0"/>
+          </a:p>
+        </p:txBody>
+      </p:sp>
+      <p:sp>
+        <p:nvSpPr>
+          <p:cNvPr id="17" name="Text 13"/>
+          <p:cNvSpPr txBox="1"/>
+          <p:nvPr/>
+        </p:nvSpPr>
+        <p:spPr>
+          <a:xfrm>
+            <a:off x="4572000" y="2606040"/>
+            <a:ext cx="3017520" cy="457200"/>
           </a:xfrm>
           <a:prstGeom prst="rect">
             <a:avLst/>
@@ -17922,166 +19060,480 @@
           <a:lstStyle/>
           <a:p>
             <a:pPr indent="0" marL="0">
-              <a:spcAft>
-                <a:spcPts val="400"/>
-              </a:spcAft>
-              <a:buNone/>
-            </a:pPr>
-            <a:r>
-              <a:rPr lang="en-US" sz="1500" b="1" dirty="0">
-                <a:solidFill>
-                  <a:srgbClr val="B8934A"/>
-                </a:solidFill>
-              </a:rPr>
-              <a:t>PRÓXIMOS PASSOS</a:t>
-            </a:r>
-            <a:endParaRPr lang="en-US" sz="1500" dirty="0"/>
-          </a:p>
-          <a:p>
-            <a:pPr marL="342900" indent="-342900">
-              <a:spcAft>
-                <a:spcPts val="400"/>
-              </a:spcAft>
-              <a:buSzPct val="100000"/>
-              <a:buChar char="•"/>
-            </a:pPr>
-            <a:r>
-              <a:rPr lang="en-US" sz="1500" dirty="0">
+              <a:buNone/>
+            </a:pPr>
+            <a:r>
+              <a:rPr lang="en-US" sz="1100" b="1" spc="100" kern="0" dirty="0">
+                <a:solidFill>
+                  <a:schemeClr val="accent3"/>
+                </a:solidFill>
+              </a:rPr>
+              <a:t>SISTEMAS CRÍTICOS E IMPLANTAÇÃO</a:t>
+            </a:r>
+            <a:endParaRPr lang="en-US" sz="1100" dirty="0"/>
+          </a:p>
+        </p:txBody>
+      </p:sp>
+      <p:sp>
+        <p:nvSpPr>
+          <p:cNvPr id="18" name="Text 14"/>
+          <p:cNvSpPr txBox="1"/>
+          <p:nvPr/>
+        </p:nvSpPr>
+        <p:spPr>
+          <a:xfrm>
+            <a:off x="4572000" y="3108960"/>
+            <a:ext cx="3017520" cy="1371600"/>
+          </a:xfrm>
+          <a:prstGeom prst="rect">
+            <a:avLst/>
+          </a:prstGeom>
+          <a:noFill/>
+          <a:ln/>
+        </p:spPr>
+        <p:txBody>
+          <a:bodyPr wrap="square" lIns="0" tIns="0" rIns="0" bIns="0" rtlCol="0" anchor="t"/>
+          <a:lstStyle/>
+          <a:p>
+            <a:pPr indent="0" marL="0">
+              <a:buNone/>
+            </a:pPr>
+            <a:r>
+              <a:rPr lang="en-US" sz="1400" dirty="0">
+                <a:solidFill>
+                  <a:schemeClr val="tx1"/>
+                </a:solidFill>
+              </a:rPr>
+              <a:t>Critério para os sistemas que o Einstein opera e que atendem outros setores; acompanhamento da implantação</a:t>
+            </a:r>
+            <a:endParaRPr lang="en-US" sz="1400" dirty="0"/>
+          </a:p>
+        </p:txBody>
+      </p:sp>
+      <p:sp>
+        <p:nvSpPr>
+          <p:cNvPr id="19" name="prova-1"/>
+          <p:cNvSpPr/>
+          <p:nvPr/>
+        </p:nvSpPr>
+        <p:spPr>
+          <a:xfrm>
+            <a:off x="4297680" y="4754880"/>
+            <a:ext cx="3520440" cy="1417320"/>
+          </a:xfrm>
+          <a:prstGeom prst="roundRect">
+            <a:avLst>
+              <a:gd name="adj" fmla="val 5161"/>
+            </a:avLst>
+          </a:prstGeom>
+          <a:solidFill>
+            <a:srgbClr val="2F4162"/>
+          </a:solidFill>
+          <a:ln w="12700">
+            <a:solidFill>
+              <a:srgbClr val="2F4162"/>
+            </a:solidFill>
+            <a:prstDash val="solid"/>
+          </a:ln>
+        </p:spPr>
+      </p:sp>
+      <p:sp>
+        <p:nvSpPr>
+          <p:cNvPr id="20" name="Text 16"/>
+          <p:cNvSpPr txBox="1"/>
+          <p:nvPr/>
+        </p:nvSpPr>
+        <p:spPr>
+          <a:xfrm>
+            <a:off x="4572000" y="4864608"/>
+            <a:ext cx="3017520" cy="292608"/>
+          </a:xfrm>
+          <a:prstGeom prst="rect">
+            <a:avLst/>
+          </a:prstGeom>
+          <a:noFill/>
+          <a:ln/>
+        </p:spPr>
+        <p:txBody>
+          <a:bodyPr wrap="square" lIns="0" tIns="0" rIns="0" bIns="0" rtlCol="0" anchor="ctr"/>
+          <a:lstStyle/>
+          <a:p>
+            <a:pPr indent="0" marL="0">
+              <a:buNone/>
+            </a:pPr>
+            <a:r>
+              <a:rPr lang="en-US" sz="1150" b="1" spc="100" kern="0" dirty="0">
+                <a:solidFill>
+                  <a:schemeClr val="accent2"/>
+                </a:solidFill>
+              </a:rPr>
+              <a:t>PROVA: 17007 NAÇÕES + O PARQUE</a:t>
+            </a:r>
+            <a:endParaRPr lang="en-US" sz="1150" dirty="0"/>
+          </a:p>
+        </p:txBody>
+      </p:sp>
+      <p:sp>
+        <p:nvSpPr>
+          <p:cNvPr id="21" name="Text 17"/>
+          <p:cNvSpPr txBox="1"/>
+          <p:nvPr/>
+        </p:nvSpPr>
+        <p:spPr>
+          <a:xfrm>
+            <a:off x="4572000" y="5175504"/>
+            <a:ext cx="3017520" cy="914400"/>
+          </a:xfrm>
+          <a:prstGeom prst="rect">
+            <a:avLst/>
+          </a:prstGeom>
+          <a:noFill/>
+          <a:ln/>
+        </p:spPr>
+        <p:txBody>
+          <a:bodyPr wrap="square" lIns="0" tIns="0" rIns="0" bIns="0" rtlCol="0" anchor="t"/>
+          <a:lstStyle/>
+          <a:p>
+            <a:pPr indent="0" marL="0">
+              <a:buNone/>
+            </a:pPr>
+            <a:r>
+              <a:rPr lang="en-US" sz="1300" dirty="0">
                 <a:solidFill>
                   <a:srgbClr val="FFFFFF"/>
                 </a:solidFill>
               </a:rPr>
-              <a:t>Formalizamos por escrito os ajustes de SLA apresentados</a:t>
-            </a:r>
-            <a:endParaRPr lang="en-US" sz="1500" dirty="0"/>
-          </a:p>
-          <a:p>
-            <a:pPr marL="342900" indent="-342900">
-              <a:spcAft>
-                <a:spcPts val="400"/>
-              </a:spcAft>
-              <a:buSzPct val="100000"/>
-              <a:buChar char="•"/>
-            </a:pPr>
-            <a:r>
-              <a:rPr lang="en-US" sz="1500" dirty="0">
+              <a:t>Garagem deixou de subsidiar as torres; implantação de hospital em complexo multiuso</a:t>
+            </a:r>
+            <a:endParaRPr lang="en-US" sz="1300" dirty="0"/>
+          </a:p>
+        </p:txBody>
+      </p:sp>
+      <p:sp>
+        <p:nvSpPr>
+          <p:cNvPr id="22" name="resposta-2"/>
+          <p:cNvSpPr/>
+          <p:nvPr/>
+        </p:nvSpPr>
+        <p:spPr>
+          <a:xfrm>
+            <a:off x="8046720" y="1600200"/>
+            <a:ext cx="3520440" cy="3017520"/>
+          </a:xfrm>
+          <a:prstGeom prst="roundRect">
+            <a:avLst>
+              <a:gd name="adj" fmla="val 2424"/>
+            </a:avLst>
+          </a:prstGeom>
+          <a:solidFill>
+            <a:srgbClr val="F3F4F6"/>
+          </a:solidFill>
+          <a:ln w="12700">
+            <a:solidFill>
+              <a:srgbClr val="F3F4F6"/>
+            </a:solidFill>
+            <a:prstDash val="solid"/>
+          </a:ln>
+        </p:spPr>
+      </p:sp>
+      <p:sp>
+        <p:nvSpPr>
+          <p:cNvPr id="23" name="icone-fundo"/>
+          <p:cNvSpPr/>
+          <p:nvPr/>
+        </p:nvSpPr>
+        <p:spPr>
+          <a:xfrm>
+            <a:off x="8321040" y="1874520"/>
+            <a:ext cx="548640" cy="548640"/>
+          </a:xfrm>
+          <a:prstGeom prst="ellipse">
+            <a:avLst/>
+          </a:prstGeom>
+          <a:solidFill>
+            <a:schemeClr val="accent1"/>
+          </a:solidFill>
+          <a:ln w="12700">
+            <a:solidFill>
+              <a:schemeClr val="accent1"/>
+            </a:solidFill>
+            <a:prstDash val="solid"/>
+          </a:ln>
+        </p:spPr>
+      </p:sp>
+      <p:pic>
+        <p:nvPicPr>
+          <p:cNvPr id="24" name="icone" descr="preencoded.png">    </p:cNvPr>
+          <p:cNvPicPr>
+            <a:picLocks noChangeAspect="1"/>
+          </p:cNvPicPr>
+          <p:nvPr/>
+        </p:nvPicPr>
+        <p:blipFill>
+          <a:blip r:embed="rId3"/>
+          <a:stretch>
+            <a:fillRect/>
+          </a:stretch>
+        </p:blipFill>
+        <p:spPr>
+          <a:xfrm>
+            <a:off x="8452714" y="2006194"/>
+            <a:ext cx="285293" cy="285293"/>
+          </a:xfrm>
+          <a:prstGeom prst="rect">
+            <a:avLst/>
+          </a:prstGeom>
+        </p:spPr>
+      </p:pic>
+      <p:sp>
+        <p:nvSpPr>
+          <p:cNvPr id="25" name="Text 20"/>
+          <p:cNvSpPr txBox="1"/>
+          <p:nvPr/>
+        </p:nvSpPr>
+        <p:spPr>
+          <a:xfrm>
+            <a:off x="9006840" y="1874520"/>
+            <a:ext cx="2423160" cy="548640"/>
+          </a:xfrm>
+          <a:prstGeom prst="rect">
+            <a:avLst/>
+          </a:prstGeom>
+          <a:noFill/>
+          <a:ln/>
+        </p:spPr>
+        <p:txBody>
+          <a:bodyPr wrap="square" lIns="0" tIns="0" rIns="0" bIns="0" rtlCol="0" anchor="ctr"/>
+          <a:lstStyle/>
+          <a:p>
+            <a:pPr indent="0" marL="0">
+              <a:buNone/>
+            </a:pPr>
+            <a:r>
+              <a:rPr lang="en-US" sz="1700" b="1" dirty="0">
+                <a:solidFill>
+                  <a:schemeClr val="tx2"/>
+                </a:solidFill>
+              </a:rPr>
+              <a:t>Artur de Azevedo</a:t>
+            </a:r>
+            <a:endParaRPr lang="en-US" sz="1700" dirty="0"/>
+          </a:p>
+        </p:txBody>
+      </p:sp>
+      <p:sp>
+        <p:nvSpPr>
+          <p:cNvPr id="26" name="Text 21"/>
+          <p:cNvSpPr txBox="1"/>
+          <p:nvPr/>
+        </p:nvSpPr>
+        <p:spPr>
+          <a:xfrm>
+            <a:off x="8321040" y="2606040"/>
+            <a:ext cx="3017520" cy="457200"/>
+          </a:xfrm>
+          <a:prstGeom prst="rect">
+            <a:avLst/>
+          </a:prstGeom>
+          <a:noFill/>
+          <a:ln/>
+        </p:spPr>
+        <p:txBody>
+          <a:bodyPr wrap="square" lIns="0" tIns="0" rIns="0" bIns="0" rtlCol="0" anchor="t"/>
+          <a:lstStyle/>
+          <a:p>
+            <a:pPr indent="0" marL="0">
+              <a:buNone/>
+            </a:pPr>
+            <a:r>
+              <a:rPr lang="en-US" sz="1100" b="1" spc="100" kern="0" dirty="0">
+                <a:solidFill>
+                  <a:schemeClr val="accent3"/>
+                </a:solidFill>
+              </a:rPr>
+              <a:t>CONDÔMINO MINORITÁRIO</a:t>
+            </a:r>
+            <a:endParaRPr lang="en-US" sz="1100" dirty="0"/>
+          </a:p>
+        </p:txBody>
+      </p:sp>
+      <p:sp>
+        <p:nvSpPr>
+          <p:cNvPr id="27" name="Text 22"/>
+          <p:cNvSpPr txBox="1"/>
+          <p:nvPr/>
+        </p:nvSpPr>
+        <p:spPr>
+          <a:xfrm>
+            <a:off x="8321040" y="3108960"/>
+            <a:ext cx="3017520" cy="1371600"/>
+          </a:xfrm>
+          <a:prstGeom prst="rect">
+            <a:avLst/>
+          </a:prstGeom>
+          <a:noFill/>
+          <a:ln/>
+        </p:spPr>
+        <p:txBody>
+          <a:bodyPr wrap="square" lIns="0" tIns="0" rIns="0" bIns="0" rtlCol="0" anchor="t"/>
+          <a:lstStyle/>
+          <a:p>
+            <a:pPr indent="0" marL="0">
+              <a:buNone/>
+            </a:pPr>
+            <a:r>
+              <a:rPr lang="en-US" sz="1400" dirty="0">
+                <a:solidFill>
+                  <a:schemeClr val="tx1"/>
+                </a:solidFill>
+              </a:rPr>
+              <a:t>Matriz de critérios e conferência mensal para que o Einstein pague só o que lhe cabe</a:t>
+            </a:r>
+            <a:endParaRPr lang="en-US" sz="1400" dirty="0"/>
+          </a:p>
+        </p:txBody>
+      </p:sp>
+      <p:sp>
+        <p:nvSpPr>
+          <p:cNvPr id="28" name="prova-2"/>
+          <p:cNvSpPr/>
+          <p:nvPr/>
+        </p:nvSpPr>
+        <p:spPr>
+          <a:xfrm>
+            <a:off x="8046720" y="4754880"/>
+            <a:ext cx="3520440" cy="1417320"/>
+          </a:xfrm>
+          <a:prstGeom prst="roundRect">
+            <a:avLst>
+              <a:gd name="adj" fmla="val 5161"/>
+            </a:avLst>
+          </a:prstGeom>
+          <a:solidFill>
+            <a:srgbClr val="2F4162"/>
+          </a:solidFill>
+          <a:ln w="12700">
+            <a:solidFill>
+              <a:srgbClr val="2F4162"/>
+            </a:solidFill>
+            <a:prstDash val="solid"/>
+          </a:ln>
+        </p:spPr>
+      </p:sp>
+      <p:sp>
+        <p:nvSpPr>
+          <p:cNvPr id="29" name="Text 24"/>
+          <p:cNvSpPr txBox="1"/>
+          <p:nvPr/>
+        </p:nvSpPr>
+        <p:spPr>
+          <a:xfrm>
+            <a:off x="8321040" y="4864608"/>
+            <a:ext cx="3017520" cy="292608"/>
+          </a:xfrm>
+          <a:prstGeom prst="rect">
+            <a:avLst/>
+          </a:prstGeom>
+          <a:noFill/>
+          <a:ln/>
+        </p:spPr>
+        <p:txBody>
+          <a:bodyPr wrap="square" lIns="0" tIns="0" rIns="0" bIns="0" rtlCol="0" anchor="ctr"/>
+          <a:lstStyle/>
+          <a:p>
+            <a:pPr indent="0" marL="0">
+              <a:buNone/>
+            </a:pPr>
+            <a:r>
+              <a:rPr lang="en-US" sz="1150" b="1" spc="100" kern="0" dirty="0">
+                <a:solidFill>
+                  <a:schemeClr val="accent2"/>
+                </a:solidFill>
+              </a:rPr>
+              <a:t>PROVA: METODOLOGIA DF</a:t>
+            </a:r>
+            <a:endParaRPr lang="en-US" sz="1150" dirty="0"/>
+          </a:p>
+        </p:txBody>
+      </p:sp>
+      <p:sp>
+        <p:nvSpPr>
+          <p:cNvPr id="30" name="Text 25"/>
+          <p:cNvSpPr txBox="1"/>
+          <p:nvPr/>
+        </p:nvSpPr>
+        <p:spPr>
+          <a:xfrm>
+            <a:off x="8321040" y="5175504"/>
+            <a:ext cx="3017520" cy="914400"/>
+          </a:xfrm>
+          <a:prstGeom prst="rect">
+            <a:avLst/>
+          </a:prstGeom>
+          <a:noFill/>
+          <a:ln/>
+        </p:spPr>
+        <p:txBody>
+          <a:bodyPr wrap="square" lIns="0" tIns="0" rIns="0" bIns="0" rtlCol="0" anchor="t"/>
+          <a:lstStyle/>
+          <a:p>
+            <a:pPr indent="0" marL="0">
+              <a:buNone/>
+            </a:pPr>
+            <a:r>
+              <a:rPr lang="en-US" sz="1300" dirty="0">
                 <a:solidFill>
                   <a:srgbClr val="FFFFFF"/>
                 </a:solidFill>
               </a:rPr>
-              <a:t>Enviamos o relatório executivo da apresentação</a:t>
-            </a:r>
-            <a:endParaRPr lang="en-US" sz="1500" dirty="0"/>
-          </a:p>
-          <a:p>
-            <a:pPr marL="342900" indent="-342900">
-              <a:spcAft>
-                <a:spcPts val="400"/>
-              </a:spcAft>
-              <a:buSzPct val="100000"/>
-              <a:buChar char="•"/>
-            </a:pPr>
-            <a:r>
-              <a:rPr lang="en-US" sz="1500" dirty="0">
-                <a:solidFill>
-                  <a:srgbClr val="FFFFFF"/>
-                </a:solidFill>
-              </a:rPr>
-              <a:t>Kick-off em até 5 dias úteis após a contratação</a:t>
-            </a:r>
-            <a:endParaRPr lang="en-US" sz="1500" dirty="0"/>
-          </a:p>
-        </p:txBody>
-      </p:sp>
-      <p:sp>
-        <p:nvSpPr>
-          <p:cNvPr id="5" name="Text 3"/>
-          <p:cNvSpPr txBox="1"/>
-          <p:nvPr/>
-        </p:nvSpPr>
-        <p:spPr>
-          <a:xfrm>
-            <a:off x="7589520" y="3931920"/>
-            <a:ext cx="4023360" cy="1737360"/>
-          </a:xfrm>
-          <a:prstGeom prst="rect">
-            <a:avLst/>
-          </a:prstGeom>
-          <a:noFill/>
-          <a:ln/>
-        </p:spPr>
-        <p:txBody>
-          <a:bodyPr wrap="square" lIns="0" tIns="0" rIns="0" bIns="0" rtlCol="0" anchor="t"/>
-          <a:lstStyle/>
-          <a:p>
-            <a:pPr indent="0" marL="0">
-              <a:buNone/>
-            </a:pPr>
-            <a:r>
-              <a:rPr lang="en-US" sz="1350" b="1" dirty="0">
-                <a:solidFill>
-                  <a:srgbClr val="FFFFFF"/>
-                </a:solidFill>
-              </a:rPr>
-              <a:t>Denise Ferreira</a:t>
-            </a:r>
-            <a:endParaRPr lang="en-US" sz="1350" dirty="0"/>
-          </a:p>
-          <a:p>
-            <a:pPr indent="0" marL="0">
-              <a:buNone/>
-            </a:pPr>
-            <a:r>
-              <a:rPr lang="en-US" sz="1350" dirty="0">
-                <a:solidFill>
-                  <a:srgbClr val="FFFFFF"/>
-                </a:solidFill>
-              </a:rPr>
-              <a:t>denise@dfsindicos.com.br · +55 11 97322-5115</a:t>
-            </a:r>
-            <a:endParaRPr lang="en-US" sz="1350" dirty="0"/>
-          </a:p>
-          <a:p>
-            <a:pPr indent="0" marL="0">
-              <a:buNone/>
-            </a:pPr>
-            <a:r>
-              <a:rPr lang="en-US" sz="1350" b="1" dirty="0">
-                <a:solidFill>
-                  <a:srgbClr val="FFFFFF"/>
-                </a:solidFill>
-              </a:rPr>
-              <a:t>Caio Gavioli</a:t>
-            </a:r>
-            <a:endParaRPr lang="en-US" sz="1350" dirty="0"/>
-          </a:p>
-          <a:p>
-            <a:pPr indent="0" marL="0">
-              <a:buNone/>
-            </a:pPr>
-            <a:r>
-              <a:rPr lang="en-US" sz="1350" dirty="0">
-                <a:solidFill>
-                  <a:srgbClr val="FFFFFF"/>
-                </a:solidFill>
-              </a:rPr>
-              <a:t>caio@dfsindicos.com.br · +55 11 98323-1173</a:t>
-            </a:r>
-            <a:endParaRPr lang="en-US" sz="1350" dirty="0"/>
-          </a:p>
-          <a:p>
-            <a:pPr indent="0" marL="0">
-              <a:buNone/>
-            </a:pPr>
-            <a:r>
-              <a:rPr lang="en-US" sz="1350" dirty="0">
-                <a:solidFill>
-                  <a:srgbClr val="B8934A"/>
-                </a:solidFill>
-              </a:rPr>
-              <a:t>www.dfsindicos.com.br</a:t>
-            </a:r>
-            <a:endParaRPr lang="en-US" sz="1350" dirty="0"/>
+              <a:t>Gatilho de ±5% e parecer a cada desvio relevante</a:t>
+            </a:r>
+            <a:endParaRPr lang="en-US" sz="1300" dirty="0"/>
+          </a:p>
+        </p:txBody>
+      </p:sp>
+      <p:sp>
+        <p:nvSpPr>
+          <p:cNvPr id="25" name="Slide Number Placeholder 0"/>
+          <p:cNvSpPr>
+            <a:spLocks noGrp="1"/>
+          </p:cNvSpPr>
+          <p:nvPr>
+            <p:ph type="sldNum" sz="quarter" idx="4294967295"/>
+          </p:nvPr>
+        </p:nvSpPr>
+        <p:spPr>
+          <a:xfrm>
+            <a:off x="11155680" y="6400800"/>
+            <a:ext cx="457200" cy="274320"/>
+          </a:xfrm>
+          <a:prstGeom prst="rect">
+            <a:avLst/>
+          </a:prstGeom>
+          <a:extLst>
+            <a:ext uri="{C572A759-6A51-4108-AA02-DFA0A04FC94B}">
+              <ma14:wrappingTextBoxFlag xmlns:ma14="http://schemas.microsoft.com/office/mac/drawingml/2011/main" val="0"/>
+            </a:ext>
+          </a:extLst>
+        </p:spPr>
+        <p:txBody>
+          <a:bodyPr/>
+          <a:lstStyle>
+            <a:lvl1pPr>
+              <a:defRPr sz="900">
+                <a:solidFill>
+                  <a:schemeClr val="tx2"/>
+                </a:solidFill>
+              </a:defRPr>
+            </a:lvl1pPr>
+          </a:lstStyle>
+          <a:p>
+            <a:pPr algn="r"/>
+            <a:fld id="{F7021451-1387-4CA6-816F-3879F97B5CBC}" type="slidenum">
+              <a:rPr b="0" lang="en-US"/>
+              <a:t>21</a:t>
+            </a:fld>
+            <a:endParaRPr lang="en-US"/>
           </a:p>
         </p:txBody>
       </p:sp>
@@ -18094,7 +19546,7 @@
 </file>
 
 <file path=ppt/slides/slide22.xml><?xml version="1.0" encoding="utf-8"?>
-<p:sld xmlns:a="http://schemas.openxmlformats.org/drawingml/2006/main" xmlns:r="http://schemas.openxmlformats.org/officeDocument/2006/relationships" xmlns:p="http://schemas.openxmlformats.org/presentationml/2006/main" show="0">
+<p:sld xmlns:a="http://schemas.openxmlformats.org/drawingml/2006/main" xmlns:r="http://schemas.openxmlformats.org/officeDocument/2006/relationships" xmlns:p="http://schemas.openxmlformats.org/presentationml/2006/main">
   <p:cSld name="Slide 22">
     <p:spTree>
       <p:nvGrpSpPr>
@@ -18142,6 +19594,1177 @@
                   <a:schemeClr val="tx2"/>
                 </a:solidFill>
               </a:rPr>
+              <a:t>O que o Einstein ganha nos primeiros 90 dias</a:t>
+            </a:r>
+            <a:endParaRPr lang="en-US" sz="3000" dirty="0"/>
+          </a:p>
+        </p:txBody>
+      </p:sp>
+      <p:sp>
+        <p:nvSpPr>
+          <p:cNvPr id="3" name="subtitulo"/>
+          <p:cNvSpPr txBox="1"/>
+          <p:nvPr/>
+        </p:nvSpPr>
+        <p:spPr>
+          <a:xfrm>
+            <a:off x="548640" y="1024128"/>
+            <a:ext cx="10515600" cy="365760"/>
+          </a:xfrm>
+          <a:prstGeom prst="rect">
+            <a:avLst/>
+          </a:prstGeom>
+          <a:noFill/>
+          <a:ln/>
+        </p:spPr>
+        <p:txBody>
+          <a:bodyPr wrap="square" lIns="0" tIns="0" rIns="0" bIns="0" rtlCol="0" anchor="ctr"/>
+          <a:lstStyle/>
+          <a:p>
+            <a:pPr indent="0" marL="0">
+              <a:buNone/>
+            </a:pPr>
+            <a:r>
+              <a:rPr lang="en-US" sz="1500" dirty="0">
+                <a:solidFill>
+                  <a:schemeClr val="accent3"/>
+                </a:solidFill>
+              </a:rPr>
+              <a:t>Resultados concretos, com data, desde o primeiro mês de contrato</a:t>
+            </a:r>
+            <a:endParaRPr lang="en-US" sz="1500" dirty="0"/>
+          </a:p>
+        </p:txBody>
+      </p:sp>
+      <p:sp>
+        <p:nvSpPr>
+          <p:cNvPr id="4" name="linha-ganhos"/>
+          <p:cNvSpPr/>
+          <p:nvPr/>
+        </p:nvSpPr>
+        <p:spPr>
+          <a:xfrm>
+            <a:off x="914400" y="2057400"/>
+            <a:ext cx="10332720" cy="0"/>
+          </a:xfrm>
+          <a:prstGeom prst="line">
+            <a:avLst/>
+          </a:prstGeom>
+          <a:noFill/>
+          <a:ln w="25400">
+            <a:solidFill>
+              <a:srgbClr val="CBD5E4"/>
+            </a:solidFill>
+            <a:prstDash val="solid"/>
+          </a:ln>
+        </p:spPr>
+      </p:sp>
+      <p:sp>
+        <p:nvSpPr>
+          <p:cNvPr id="5" name="marco-ganho-0"/>
+          <p:cNvSpPr/>
+          <p:nvPr/>
+        </p:nvSpPr>
+        <p:spPr>
+          <a:xfrm>
+            <a:off x="685800" y="1783080"/>
+            <a:ext cx="548640" cy="548640"/>
+          </a:xfrm>
+          <a:prstGeom prst="ellipse">
+            <a:avLst/>
+          </a:prstGeom>
+          <a:solidFill>
+            <a:srgbClr val="B8934A"/>
+          </a:solidFill>
+          <a:ln w="25400">
+            <a:solidFill>
+              <a:srgbClr val="FFFFFF"/>
+            </a:solidFill>
+            <a:prstDash val="solid"/>
+          </a:ln>
+        </p:spPr>
+      </p:sp>
+      <p:sp>
+        <p:nvSpPr>
+          <p:cNvPr id="6" name="Text 4"/>
+          <p:cNvSpPr txBox="1"/>
+          <p:nvPr/>
+        </p:nvSpPr>
+        <p:spPr>
+          <a:xfrm>
+            <a:off x="1325880" y="1783080"/>
+            <a:ext cx="914400" cy="548640"/>
+          </a:xfrm>
+          <a:prstGeom prst="rect">
+            <a:avLst/>
+          </a:prstGeom>
+          <a:solidFill>
+            <a:srgbClr val="FFFFFF"/>
+          </a:solidFill>
+          <a:ln/>
+        </p:spPr>
+        <p:txBody>
+          <a:bodyPr wrap="square" lIns="0" tIns="0" rIns="0" bIns="0" rtlCol="0" anchor="ctr"/>
+          <a:lstStyle/>
+          <a:p>
+            <a:pPr algn="ctr" indent="0" marL="0">
+              <a:buNone/>
+            </a:pPr>
+            <a:r>
+              <a:rPr lang="en-US" sz="2000" b="1" dirty="0">
+                <a:solidFill>
+                  <a:schemeClr val="accent2"/>
+                </a:solidFill>
+              </a:rPr>
+              <a:t>Início</a:t>
+            </a:r>
+            <a:endParaRPr lang="en-US" sz="2000" dirty="0"/>
+          </a:p>
+        </p:txBody>
+      </p:sp>
+      <p:sp>
+        <p:nvSpPr>
+          <p:cNvPr id="7" name="ganho-0"/>
+          <p:cNvSpPr/>
+          <p:nvPr/>
+        </p:nvSpPr>
+        <p:spPr>
+          <a:xfrm>
+            <a:off x="548640" y="2606040"/>
+            <a:ext cx="2606040" cy="2743200"/>
+          </a:xfrm>
+          <a:prstGeom prst="roundRect">
+            <a:avLst>
+              <a:gd name="adj" fmla="val 2807"/>
+            </a:avLst>
+          </a:prstGeom>
+          <a:solidFill>
+            <a:srgbClr val="F3F4F6"/>
+          </a:solidFill>
+          <a:ln w="12700">
+            <a:solidFill>
+              <a:srgbClr val="F3F4F6"/>
+            </a:solidFill>
+            <a:prstDash val="solid"/>
+          </a:ln>
+        </p:spPr>
+      </p:sp>
+      <p:sp>
+        <p:nvSpPr>
+          <p:cNvPr id="8" name="Text 6"/>
+          <p:cNvSpPr txBox="1"/>
+          <p:nvPr/>
+        </p:nvSpPr>
+        <p:spPr>
+          <a:xfrm>
+            <a:off x="777240" y="2788920"/>
+            <a:ext cx="2194560" cy="731520"/>
+          </a:xfrm>
+          <a:prstGeom prst="rect">
+            <a:avLst/>
+          </a:prstGeom>
+          <a:noFill/>
+          <a:ln/>
+        </p:spPr>
+        <p:txBody>
+          <a:bodyPr wrap="square" lIns="0" tIns="0" rIns="0" bIns="0" rtlCol="0" anchor="t"/>
+          <a:lstStyle/>
+          <a:p>
+            <a:pPr indent="0" marL="0">
+              <a:buNone/>
+            </a:pPr>
+            <a:r>
+              <a:rPr lang="en-US" sz="1700" b="1" dirty="0">
+                <a:solidFill>
+                  <a:schemeClr val="tx2"/>
+                </a:solidFill>
+              </a:rPr>
+              <a:t>Previsão Orçamentária 2027</a:t>
+            </a:r>
+            <a:endParaRPr lang="en-US" sz="1700" dirty="0"/>
+          </a:p>
+        </p:txBody>
+      </p:sp>
+      <p:sp>
+        <p:nvSpPr>
+          <p:cNvPr id="9" name="Text 7"/>
+          <p:cNvSpPr txBox="1"/>
+          <p:nvPr/>
+        </p:nvSpPr>
+        <p:spPr>
+          <a:xfrm>
+            <a:off x="777240" y="3566160"/>
+            <a:ext cx="2194560" cy="1691640"/>
+          </a:xfrm>
+          <a:prstGeom prst="rect">
+            <a:avLst/>
+          </a:prstGeom>
+          <a:noFill/>
+          <a:ln/>
+        </p:spPr>
+        <p:txBody>
+          <a:bodyPr wrap="square" lIns="0" tIns="0" rIns="0" bIns="0" rtlCol="0" anchor="t"/>
+          <a:lstStyle/>
+          <a:p>
+            <a:pPr indent="0" marL="0">
+              <a:buNone/>
+            </a:pPr>
+            <a:r>
+              <a:rPr lang="en-US" sz="1350" dirty="0">
+                <a:solidFill>
+                  <a:schemeClr val="tx1"/>
+                </a:solidFill>
+              </a:rPr>
+              <a:t>Revisada com prioridade, se ainda não aprovada em assembleia — o primeiro posicionamento técnico do Einstein</a:t>
+            </a:r>
+            <a:endParaRPr lang="en-US" sz="1350" dirty="0"/>
+          </a:p>
+        </p:txBody>
+      </p:sp>
+      <p:sp>
+        <p:nvSpPr>
+          <p:cNvPr id="10" name="marco-ganho-1"/>
+          <p:cNvSpPr/>
+          <p:nvPr/>
+        </p:nvSpPr>
+        <p:spPr>
+          <a:xfrm>
+            <a:off x="3502152" y="1783080"/>
+            <a:ext cx="548640" cy="548640"/>
+          </a:xfrm>
+          <a:prstGeom prst="ellipse">
+            <a:avLst/>
+          </a:prstGeom>
+          <a:solidFill>
+            <a:srgbClr val="2F4162"/>
+          </a:solidFill>
+          <a:ln w="25400">
+            <a:solidFill>
+              <a:srgbClr val="FFFFFF"/>
+            </a:solidFill>
+            <a:prstDash val="solid"/>
+          </a:ln>
+        </p:spPr>
+      </p:sp>
+      <p:sp>
+        <p:nvSpPr>
+          <p:cNvPr id="11" name="Text 9"/>
+          <p:cNvSpPr txBox="1"/>
+          <p:nvPr/>
+        </p:nvSpPr>
+        <p:spPr>
+          <a:xfrm>
+            <a:off x="4142232" y="1783080"/>
+            <a:ext cx="868680" cy="548640"/>
+          </a:xfrm>
+          <a:prstGeom prst="rect">
+            <a:avLst/>
+          </a:prstGeom>
+          <a:solidFill>
+            <a:srgbClr val="FFFFFF"/>
+          </a:solidFill>
+          <a:ln/>
+        </p:spPr>
+        <p:txBody>
+          <a:bodyPr wrap="square" lIns="0" tIns="0" rIns="0" bIns="0" rtlCol="0" anchor="ctr"/>
+          <a:lstStyle/>
+          <a:p>
+            <a:pPr algn="ctr" indent="0" marL="0">
+              <a:buNone/>
+            </a:pPr>
+            <a:r>
+              <a:rPr lang="en-US" sz="2000" b="1" dirty="0">
+                <a:solidFill>
+                  <a:schemeClr val="tx2"/>
+                </a:solidFill>
+              </a:rPr>
+              <a:t>D+30</a:t>
+            </a:r>
+            <a:endParaRPr lang="en-US" sz="2000" dirty="0"/>
+          </a:p>
+        </p:txBody>
+      </p:sp>
+      <p:sp>
+        <p:nvSpPr>
+          <p:cNvPr id="12" name="ganho-1"/>
+          <p:cNvSpPr/>
+          <p:nvPr/>
+        </p:nvSpPr>
+        <p:spPr>
+          <a:xfrm>
+            <a:off x="3364992" y="2606040"/>
+            <a:ext cx="2606040" cy="2743200"/>
+          </a:xfrm>
+          <a:prstGeom prst="roundRect">
+            <a:avLst>
+              <a:gd name="adj" fmla="val 2807"/>
+            </a:avLst>
+          </a:prstGeom>
+          <a:solidFill>
+            <a:srgbClr val="F3F4F6"/>
+          </a:solidFill>
+          <a:ln w="12700">
+            <a:solidFill>
+              <a:srgbClr val="F3F4F6"/>
+            </a:solidFill>
+            <a:prstDash val="solid"/>
+          </a:ln>
+        </p:spPr>
+      </p:sp>
+      <p:sp>
+        <p:nvSpPr>
+          <p:cNvPr id="13" name="Text 11"/>
+          <p:cNvSpPr txBox="1"/>
+          <p:nvPr/>
+        </p:nvSpPr>
+        <p:spPr>
+          <a:xfrm>
+            <a:off x="3593592" y="2788920"/>
+            <a:ext cx="2194560" cy="731520"/>
+          </a:xfrm>
+          <a:prstGeom prst="rect">
+            <a:avLst/>
+          </a:prstGeom>
+          <a:noFill/>
+          <a:ln/>
+        </p:spPr>
+        <p:txBody>
+          <a:bodyPr wrap="square" lIns="0" tIns="0" rIns="0" bIns="0" rtlCol="0" anchor="t"/>
+          <a:lstStyle/>
+          <a:p>
+            <a:pPr indent="0" marL="0">
+              <a:buNone/>
+            </a:pPr>
+            <a:r>
+              <a:rPr lang="en-US" sz="1700" b="1" dirty="0">
+                <a:solidFill>
+                  <a:schemeClr val="tx2"/>
+                </a:solidFill>
+              </a:rPr>
+              <a:t>Primeiro relatório executivo</a:t>
+            </a:r>
+            <a:endParaRPr lang="en-US" sz="1700" dirty="0"/>
+          </a:p>
+        </p:txBody>
+      </p:sp>
+      <p:sp>
+        <p:nvSpPr>
+          <p:cNvPr id="14" name="Text 12"/>
+          <p:cNvSpPr txBox="1"/>
+          <p:nvPr/>
+        </p:nvSpPr>
+        <p:spPr>
+          <a:xfrm>
+            <a:off x="3593592" y="3566160"/>
+            <a:ext cx="2194560" cy="1691640"/>
+          </a:xfrm>
+          <a:prstGeom prst="rect">
+            <a:avLst/>
+          </a:prstGeom>
+          <a:noFill/>
+          <a:ln/>
+        </p:spPr>
+        <p:txBody>
+          <a:bodyPr wrap="square" lIns="0" tIns="0" rIns="0" bIns="0" rtlCol="0" anchor="t"/>
+          <a:lstStyle/>
+          <a:p>
+            <a:pPr indent="0" marL="0">
+              <a:buNone/>
+            </a:pPr>
+            <a:r>
+              <a:rPr lang="en-US" sz="1350" dirty="0">
+                <a:solidFill>
+                  <a:schemeClr val="tx1"/>
+                </a:solidFill>
+              </a:rPr>
+              <a:t>Situação financeira, rateio e riscos de cada unidade, na mesa do Einstein</a:t>
+            </a:r>
+            <a:endParaRPr lang="en-US" sz="1350" dirty="0"/>
+          </a:p>
+        </p:txBody>
+      </p:sp>
+      <p:sp>
+        <p:nvSpPr>
+          <p:cNvPr id="15" name="marco-ganho-2"/>
+          <p:cNvSpPr/>
+          <p:nvPr/>
+        </p:nvSpPr>
+        <p:spPr>
+          <a:xfrm>
+            <a:off x="6318504" y="1783080"/>
+            <a:ext cx="548640" cy="548640"/>
+          </a:xfrm>
+          <a:prstGeom prst="ellipse">
+            <a:avLst/>
+          </a:prstGeom>
+          <a:solidFill>
+            <a:srgbClr val="2F4162"/>
+          </a:solidFill>
+          <a:ln w="25400">
+            <a:solidFill>
+              <a:srgbClr val="FFFFFF"/>
+            </a:solidFill>
+            <a:prstDash val="solid"/>
+          </a:ln>
+        </p:spPr>
+      </p:sp>
+      <p:sp>
+        <p:nvSpPr>
+          <p:cNvPr id="16" name="Text 14"/>
+          <p:cNvSpPr txBox="1"/>
+          <p:nvPr/>
+        </p:nvSpPr>
+        <p:spPr>
+          <a:xfrm>
+            <a:off x="6958584" y="1783080"/>
+            <a:ext cx="868680" cy="548640"/>
+          </a:xfrm>
+          <a:prstGeom prst="rect">
+            <a:avLst/>
+          </a:prstGeom>
+          <a:solidFill>
+            <a:srgbClr val="FFFFFF"/>
+          </a:solidFill>
+          <a:ln/>
+        </p:spPr>
+        <p:txBody>
+          <a:bodyPr wrap="square" lIns="0" tIns="0" rIns="0" bIns="0" rtlCol="0" anchor="ctr"/>
+          <a:lstStyle/>
+          <a:p>
+            <a:pPr algn="ctr" indent="0" marL="0">
+              <a:buNone/>
+            </a:pPr>
+            <a:r>
+              <a:rPr lang="en-US" sz="2000" b="1" dirty="0">
+                <a:solidFill>
+                  <a:schemeClr val="tx2"/>
+                </a:solidFill>
+              </a:rPr>
+              <a:t>D+60</a:t>
+            </a:r>
+            <a:endParaRPr lang="en-US" sz="2000" dirty="0"/>
+          </a:p>
+        </p:txBody>
+      </p:sp>
+      <p:sp>
+        <p:nvSpPr>
+          <p:cNvPr id="17" name="ganho-2"/>
+          <p:cNvSpPr/>
+          <p:nvPr/>
+        </p:nvSpPr>
+        <p:spPr>
+          <a:xfrm>
+            <a:off x="6181344" y="2606040"/>
+            <a:ext cx="2606040" cy="2743200"/>
+          </a:xfrm>
+          <a:prstGeom prst="roundRect">
+            <a:avLst>
+              <a:gd name="adj" fmla="val 2807"/>
+            </a:avLst>
+          </a:prstGeom>
+          <a:solidFill>
+            <a:srgbClr val="F3F4F6"/>
+          </a:solidFill>
+          <a:ln w="12700">
+            <a:solidFill>
+              <a:srgbClr val="F3F4F6"/>
+            </a:solidFill>
+            <a:prstDash val="solid"/>
+          </a:ln>
+        </p:spPr>
+      </p:sp>
+      <p:sp>
+        <p:nvSpPr>
+          <p:cNvPr id="18" name="Text 16"/>
+          <p:cNvSpPr txBox="1"/>
+          <p:nvPr/>
+        </p:nvSpPr>
+        <p:spPr>
+          <a:xfrm>
+            <a:off x="6409944" y="2788920"/>
+            <a:ext cx="2194560" cy="731520"/>
+          </a:xfrm>
+          <a:prstGeom prst="rect">
+            <a:avLst/>
+          </a:prstGeom>
+          <a:noFill/>
+          <a:ln/>
+        </p:spPr>
+        <p:txBody>
+          <a:bodyPr wrap="square" lIns="0" tIns="0" rIns="0" bIns="0" rtlCol="0" anchor="t"/>
+          <a:lstStyle/>
+          <a:p>
+            <a:pPr indent="0" marL="0">
+              <a:buNone/>
+            </a:pPr>
+            <a:r>
+              <a:rPr lang="en-US" sz="1700" b="1" dirty="0">
+                <a:solidFill>
+                  <a:schemeClr val="tx2"/>
+                </a:solidFill>
+              </a:rPr>
+              <a:t>Diagnóstico do rateio</a:t>
+            </a:r>
+            <a:endParaRPr lang="en-US" sz="1700" dirty="0"/>
+          </a:p>
+        </p:txBody>
+      </p:sp>
+      <p:sp>
+        <p:nvSpPr>
+          <p:cNvPr id="19" name="Text 17"/>
+          <p:cNvSpPr txBox="1"/>
+          <p:nvPr/>
+        </p:nvSpPr>
+        <p:spPr>
+          <a:xfrm>
+            <a:off x="6409944" y="3566160"/>
+            <a:ext cx="2194560" cy="1691640"/>
+          </a:xfrm>
+          <a:prstGeom prst="rect">
+            <a:avLst/>
+          </a:prstGeom>
+          <a:noFill/>
+          <a:ln/>
+        </p:spPr>
+        <p:txBody>
+          <a:bodyPr wrap="square" lIns="0" tIns="0" rIns="0" bIns="0" rtlCol="0" anchor="t"/>
+          <a:lstStyle/>
+          <a:p>
+            <a:pPr indent="0" marL="0">
+              <a:buNone/>
+            </a:pPr>
+            <a:r>
+              <a:rPr lang="en-US" sz="1350" dirty="0">
+                <a:solidFill>
+                  <a:schemeClr val="tx1"/>
+                </a:solidFill>
+              </a:rPr>
+              <a:t>Situação atual × situação correta, subsídios cruzados identificados, matriz de riscos e plano de ação</a:t>
+            </a:r>
+            <a:endParaRPr lang="en-US" sz="1350" dirty="0"/>
+          </a:p>
+        </p:txBody>
+      </p:sp>
+      <p:sp>
+        <p:nvSpPr>
+          <p:cNvPr id="20" name="marco-ganho-3"/>
+          <p:cNvSpPr/>
+          <p:nvPr/>
+        </p:nvSpPr>
+        <p:spPr>
+          <a:xfrm>
+            <a:off x="9134856" y="1783080"/>
+            <a:ext cx="548640" cy="548640"/>
+          </a:xfrm>
+          <a:prstGeom prst="ellipse">
+            <a:avLst/>
+          </a:prstGeom>
+          <a:solidFill>
+            <a:srgbClr val="2F4162"/>
+          </a:solidFill>
+          <a:ln w="25400">
+            <a:solidFill>
+              <a:srgbClr val="FFFFFF"/>
+            </a:solidFill>
+            <a:prstDash val="solid"/>
+          </a:ln>
+        </p:spPr>
+      </p:sp>
+      <p:sp>
+        <p:nvSpPr>
+          <p:cNvPr id="21" name="Text 19"/>
+          <p:cNvSpPr txBox="1"/>
+          <p:nvPr/>
+        </p:nvSpPr>
+        <p:spPr>
+          <a:xfrm>
+            <a:off x="9774936" y="1783080"/>
+            <a:ext cx="868680" cy="548640"/>
+          </a:xfrm>
+          <a:prstGeom prst="rect">
+            <a:avLst/>
+          </a:prstGeom>
+          <a:solidFill>
+            <a:srgbClr val="FFFFFF"/>
+          </a:solidFill>
+          <a:ln/>
+        </p:spPr>
+        <p:txBody>
+          <a:bodyPr wrap="square" lIns="0" tIns="0" rIns="0" bIns="0" rtlCol="0" anchor="ctr"/>
+          <a:lstStyle/>
+          <a:p>
+            <a:pPr algn="ctr" indent="0" marL="0">
+              <a:buNone/>
+            </a:pPr>
+            <a:r>
+              <a:rPr lang="en-US" sz="2000" b="1" dirty="0">
+                <a:solidFill>
+                  <a:schemeClr val="tx2"/>
+                </a:solidFill>
+              </a:rPr>
+              <a:t>D+90</a:t>
+            </a:r>
+            <a:endParaRPr lang="en-US" sz="2000" dirty="0"/>
+          </a:p>
+        </p:txBody>
+      </p:sp>
+      <p:sp>
+        <p:nvSpPr>
+          <p:cNvPr id="22" name="ganho-3"/>
+          <p:cNvSpPr/>
+          <p:nvPr/>
+        </p:nvSpPr>
+        <p:spPr>
+          <a:xfrm>
+            <a:off x="8997696" y="2606040"/>
+            <a:ext cx="2606040" cy="2743200"/>
+          </a:xfrm>
+          <a:prstGeom prst="roundRect">
+            <a:avLst>
+              <a:gd name="adj" fmla="val 2807"/>
+            </a:avLst>
+          </a:prstGeom>
+          <a:solidFill>
+            <a:srgbClr val="F3F4F6"/>
+          </a:solidFill>
+          <a:ln w="12700">
+            <a:solidFill>
+              <a:srgbClr val="F3F4F6"/>
+            </a:solidFill>
+            <a:prstDash val="solid"/>
+          </a:ln>
+        </p:spPr>
+      </p:sp>
+      <p:sp>
+        <p:nvSpPr>
+          <p:cNvPr id="23" name="Text 21"/>
+          <p:cNvSpPr txBox="1"/>
+          <p:nvPr/>
+        </p:nvSpPr>
+        <p:spPr>
+          <a:xfrm>
+            <a:off x="9226296" y="2788920"/>
+            <a:ext cx="2194560" cy="731520"/>
+          </a:xfrm>
+          <a:prstGeom prst="rect">
+            <a:avLst/>
+          </a:prstGeom>
+          <a:noFill/>
+          <a:ln/>
+        </p:spPr>
+        <p:txBody>
+          <a:bodyPr wrap="square" lIns="0" tIns="0" rIns="0" bIns="0" rtlCol="0" anchor="t"/>
+          <a:lstStyle/>
+          <a:p>
+            <a:pPr indent="0" marL="0">
+              <a:buNone/>
+            </a:pPr>
+            <a:r>
+              <a:rPr lang="en-US" sz="1700" b="1" dirty="0">
+                <a:solidFill>
+                  <a:schemeClr val="tx2"/>
+                </a:solidFill>
+              </a:rPr>
+              <a:t>Controle mensal completo</a:t>
+            </a:r>
+            <a:endParaRPr lang="en-US" sz="1700" dirty="0"/>
+          </a:p>
+        </p:txBody>
+      </p:sp>
+      <p:sp>
+        <p:nvSpPr>
+          <p:cNvPr id="24" name="Text 22"/>
+          <p:cNvSpPr txBox="1"/>
+          <p:nvPr/>
+        </p:nvSpPr>
+        <p:spPr>
+          <a:xfrm>
+            <a:off x="9226296" y="3566160"/>
+            <a:ext cx="2194560" cy="1691640"/>
+          </a:xfrm>
+          <a:prstGeom prst="rect">
+            <a:avLst/>
+          </a:prstGeom>
+          <a:noFill/>
+          <a:ln/>
+        </p:spPr>
+        <p:txBody>
+          <a:bodyPr wrap="square" lIns="0" tIns="0" rIns="0" bIns="0" rtlCol="0" anchor="t"/>
+          <a:lstStyle/>
+          <a:p>
+            <a:pPr indent="0" marL="0">
+              <a:buNone/>
+            </a:pPr>
+            <a:r>
+              <a:rPr lang="en-US" sz="1350" dirty="0">
+                <a:solidFill>
+                  <a:schemeClr val="tx1"/>
+                </a:solidFill>
+              </a:rPr>
+              <a:t>Dashboard em relatório mensal e rotina de conferência rodando nas três unidades</a:t>
+            </a:r>
+            <a:endParaRPr lang="en-US" sz="1350" dirty="0"/>
+          </a:p>
+        </p:txBody>
+      </p:sp>
+      <p:sp>
+        <p:nvSpPr>
+          <p:cNvPr id="25" name="fecho-ganhos"/>
+          <p:cNvSpPr/>
+          <p:nvPr/>
+        </p:nvSpPr>
+        <p:spPr>
+          <a:xfrm>
+            <a:off x="548640" y="5532120"/>
+            <a:ext cx="11109960" cy="658368"/>
+          </a:xfrm>
+          <a:prstGeom prst="roundRect">
+            <a:avLst>
+              <a:gd name="adj" fmla="val 11111"/>
+            </a:avLst>
+          </a:prstGeom>
+          <a:solidFill>
+            <a:srgbClr val="2F4162"/>
+          </a:solidFill>
+          <a:ln w="12700">
+            <a:solidFill>
+              <a:srgbClr val="2F4162"/>
+            </a:solidFill>
+            <a:prstDash val="solid"/>
+          </a:ln>
+        </p:spPr>
+      </p:sp>
+      <p:sp>
+        <p:nvSpPr>
+          <p:cNvPr id="26" name="Text 24"/>
+          <p:cNvSpPr txBox="1"/>
+          <p:nvPr/>
+        </p:nvSpPr>
+        <p:spPr>
+          <a:xfrm>
+            <a:off x="777240" y="5559552"/>
+            <a:ext cx="10698480" cy="603504"/>
+          </a:xfrm>
+          <a:prstGeom prst="rect">
+            <a:avLst/>
+          </a:prstGeom>
+          <a:noFill/>
+          <a:ln/>
+        </p:spPr>
+        <p:txBody>
+          <a:bodyPr wrap="square" lIns="0" tIns="0" rIns="0" bIns="0" rtlCol="0" anchor="ctr"/>
+          <a:lstStyle/>
+          <a:p>
+            <a:pPr indent="0" marL="0">
+              <a:buNone/>
+            </a:pPr>
+            <a:r>
+              <a:rPr lang="en-US" sz="1600" b="1" dirty="0">
+                <a:solidFill>
+                  <a:srgbClr val="FFFFFF"/>
+                </a:solidFill>
+              </a:rPr>
+              <a:t>Em 90 dias, o Einstein sabe exatamente quanto paga, por quê, e o que corrigir</a:t>
+            </a:r>
+            <a:pPr indent="0" marL="0">
+              <a:buNone/>
+            </a:pPr>
+            <a:r>
+              <a:rPr lang="en-US" sz="1600" b="1" dirty="0">
+                <a:solidFill>
+                  <a:srgbClr val="B8934A"/>
+                </a:solidFill>
+              </a:rPr>
+              <a:t> — nas três unidades.</a:t>
+            </a:r>
+            <a:endParaRPr lang="en-US" sz="1600" dirty="0"/>
+          </a:p>
+        </p:txBody>
+      </p:sp>
+      <p:sp>
+        <p:nvSpPr>
+          <p:cNvPr id="25" name="Slide Number Placeholder 0"/>
+          <p:cNvSpPr>
+            <a:spLocks noGrp="1"/>
+          </p:cNvSpPr>
+          <p:nvPr>
+            <p:ph type="sldNum" sz="quarter" idx="4294967295"/>
+          </p:nvPr>
+        </p:nvSpPr>
+        <p:spPr>
+          <a:xfrm>
+            <a:off x="11155680" y="6400800"/>
+            <a:ext cx="457200" cy="274320"/>
+          </a:xfrm>
+          <a:prstGeom prst="rect">
+            <a:avLst/>
+          </a:prstGeom>
+          <a:extLst>
+            <a:ext uri="{C572A759-6A51-4108-AA02-DFA0A04FC94B}">
+              <ma14:wrappingTextBoxFlag xmlns:ma14="http://schemas.microsoft.com/office/mac/drawingml/2011/main" val="0"/>
+            </a:ext>
+          </a:extLst>
+        </p:spPr>
+        <p:txBody>
+          <a:bodyPr/>
+          <a:lstStyle>
+            <a:lvl1pPr>
+              <a:defRPr sz="900">
+                <a:solidFill>
+                  <a:schemeClr val="tx2"/>
+                </a:solidFill>
+              </a:defRPr>
+            </a:lvl1pPr>
+          </a:lstStyle>
+          <a:p>
+            <a:pPr algn="r"/>
+            <a:fld id="{F7021451-1387-4CA6-816F-3879F97B5CBC}" type="slidenum">
+              <a:rPr b="0" lang="en-US"/>
+              <a:t>22</a:t>
+            </a:fld>
+            <a:endParaRPr lang="en-US"/>
+          </a:p>
+        </p:txBody>
+      </p:sp>
+    </p:spTree>
+  </p:cSld>
+  <p:clrMapOvr>
+    <a:masterClrMapping/>
+  </p:clrMapOvr>
+</p:sld>
+</file>
+
+<file path=ppt/slides/slide23.xml><?xml version="1.0" encoding="utf-8"?>
+<p:sld xmlns:a="http://schemas.openxmlformats.org/drawingml/2006/main" xmlns:r="http://schemas.openxmlformats.org/officeDocument/2006/relationships" xmlns:p="http://schemas.openxmlformats.org/presentationml/2006/main">
+  <p:cSld name="Slide 23">
+    <p:spTree>
+      <p:nvGrpSpPr>
+        <p:cNvPr id="1" name=""/>
+        <p:cNvGrpSpPr/>
+        <p:nvPr/>
+      </p:nvGrpSpPr>
+      <p:grpSpPr>
+        <a:xfrm>
+          <a:off x="0" y="0"/>
+          <a:ext cx="0" cy="0"/>
+          <a:chOff x="0" y="0"/>
+          <a:chExt cx="0" cy="0"/>
+        </a:xfrm>
+      </p:grpSpPr>
+      <p:sp>
+        <p:nvSpPr>
+          <p:cNvPr id="2" name="Text 0"/>
+          <p:cNvSpPr txBox="1"/>
+          <p:nvPr/>
+        </p:nvSpPr>
+        <p:spPr>
+          <a:xfrm>
+            <a:off x="731520" y="2103120"/>
+            <a:ext cx="10058400" cy="914400"/>
+          </a:xfrm>
+          <a:prstGeom prst="rect">
+            <a:avLst/>
+          </a:prstGeom>
+          <a:noFill/>
+          <a:ln/>
+        </p:spPr>
+        <p:txBody>
+          <a:bodyPr wrap="square" lIns="0" tIns="0" rIns="0" bIns="0" rtlCol="0" anchor="ctr"/>
+          <a:lstStyle/>
+          <a:p>
+            <a:pPr indent="0" marL="0">
+              <a:buNone/>
+            </a:pPr>
+            <a:r>
+              <a:rPr lang="en-US" sz="4800" b="1" dirty="0">
+                <a:solidFill>
+                  <a:srgbClr val="FFFFFF"/>
+                </a:solidFill>
+              </a:rPr>
+              <a:t>Obrigado</a:t>
+            </a:r>
+            <a:endParaRPr lang="en-US" sz="4800" dirty="0"/>
+          </a:p>
+        </p:txBody>
+      </p:sp>
+      <p:sp>
+        <p:nvSpPr>
+          <p:cNvPr id="3" name="Text 1"/>
+          <p:cNvSpPr txBox="1"/>
+          <p:nvPr/>
+        </p:nvSpPr>
+        <p:spPr>
+          <a:xfrm>
+            <a:off x="731520" y="3017520"/>
+            <a:ext cx="10058400" cy="457200"/>
+          </a:xfrm>
+          <a:prstGeom prst="rect">
+            <a:avLst/>
+          </a:prstGeom>
+          <a:noFill/>
+          <a:ln/>
+        </p:spPr>
+        <p:txBody>
+          <a:bodyPr wrap="square" lIns="0" tIns="0" rIns="0" bIns="0" rtlCol="0" anchor="ctr"/>
+          <a:lstStyle/>
+          <a:p>
+            <a:pPr indent="0" marL="0">
+              <a:buNone/>
+            </a:pPr>
+            <a:r>
+              <a:rPr lang="en-US" sz="2000" dirty="0">
+                <a:solidFill>
+                  <a:srgbClr val="CBD5E4"/>
+                </a:solidFill>
+              </a:rPr>
+              <a:t>Estamos à disposição para as dúvidas do Einstein</a:t>
+            </a:r>
+            <a:endParaRPr lang="en-US" sz="2000" dirty="0"/>
+          </a:p>
+        </p:txBody>
+      </p:sp>
+      <p:sp>
+        <p:nvSpPr>
+          <p:cNvPr id="4" name="Text 2"/>
+          <p:cNvSpPr txBox="1"/>
+          <p:nvPr/>
+        </p:nvSpPr>
+        <p:spPr>
+          <a:xfrm>
+            <a:off x="731520" y="3931920"/>
+            <a:ext cx="6583680" cy="1645920"/>
+          </a:xfrm>
+          <a:prstGeom prst="rect">
+            <a:avLst/>
+          </a:prstGeom>
+          <a:noFill/>
+          <a:ln/>
+        </p:spPr>
+        <p:txBody>
+          <a:bodyPr wrap="square" lIns="0" tIns="0" rIns="0" bIns="0" rtlCol="0" anchor="t"/>
+          <a:lstStyle/>
+          <a:p>
+            <a:pPr indent="0" marL="0">
+              <a:spcAft>
+                <a:spcPts val="400"/>
+              </a:spcAft>
+              <a:buNone/>
+            </a:pPr>
+            <a:r>
+              <a:rPr lang="en-US" sz="1500" b="1" dirty="0">
+                <a:solidFill>
+                  <a:srgbClr val="B8934A"/>
+                </a:solidFill>
+              </a:rPr>
+              <a:t>PRÓXIMOS PASSOS</a:t>
+            </a:r>
+            <a:endParaRPr lang="en-US" sz="1500" dirty="0"/>
+          </a:p>
+          <a:p>
+            <a:pPr marL="342900" indent="-342900">
+              <a:spcAft>
+                <a:spcPts val="400"/>
+              </a:spcAft>
+              <a:buSzPct val="100000"/>
+              <a:buChar char="•"/>
+            </a:pPr>
+            <a:r>
+              <a:rPr lang="en-US" sz="1500" dirty="0">
+                <a:solidFill>
+                  <a:srgbClr val="FFFFFF"/>
+                </a:solidFill>
+              </a:rPr>
+              <a:t>Formalizamos por escrito os ajustes de SLA apresentados</a:t>
+            </a:r>
+            <a:endParaRPr lang="en-US" sz="1500" dirty="0"/>
+          </a:p>
+          <a:p>
+            <a:pPr marL="342900" indent="-342900">
+              <a:spcAft>
+                <a:spcPts val="400"/>
+              </a:spcAft>
+              <a:buSzPct val="100000"/>
+              <a:buChar char="•"/>
+            </a:pPr>
+            <a:r>
+              <a:rPr lang="en-US" sz="1500" dirty="0">
+                <a:solidFill>
+                  <a:srgbClr val="FFFFFF"/>
+                </a:solidFill>
+              </a:rPr>
+              <a:t>Enviamos o relatório executivo da apresentação</a:t>
+            </a:r>
+            <a:endParaRPr lang="en-US" sz="1500" dirty="0"/>
+          </a:p>
+          <a:p>
+            <a:pPr marL="342900" indent="-342900">
+              <a:spcAft>
+                <a:spcPts val="400"/>
+              </a:spcAft>
+              <a:buSzPct val="100000"/>
+              <a:buChar char="•"/>
+            </a:pPr>
+            <a:r>
+              <a:rPr lang="en-US" sz="1500" dirty="0">
+                <a:solidFill>
+                  <a:srgbClr val="FFFFFF"/>
+                </a:solidFill>
+              </a:rPr>
+              <a:t>Kick-off em até 5 dias úteis após a contratação</a:t>
+            </a:r>
+            <a:endParaRPr lang="en-US" sz="1500" dirty="0"/>
+          </a:p>
+        </p:txBody>
+      </p:sp>
+      <p:sp>
+        <p:nvSpPr>
+          <p:cNvPr id="5" name="Text 3"/>
+          <p:cNvSpPr txBox="1"/>
+          <p:nvPr/>
+        </p:nvSpPr>
+        <p:spPr>
+          <a:xfrm>
+            <a:off x="7589520" y="3931920"/>
+            <a:ext cx="4023360" cy="1737360"/>
+          </a:xfrm>
+          <a:prstGeom prst="rect">
+            <a:avLst/>
+          </a:prstGeom>
+          <a:noFill/>
+          <a:ln/>
+        </p:spPr>
+        <p:txBody>
+          <a:bodyPr wrap="square" lIns="0" tIns="0" rIns="0" bIns="0" rtlCol="0" anchor="t"/>
+          <a:lstStyle/>
+          <a:p>
+            <a:pPr indent="0" marL="0">
+              <a:buNone/>
+            </a:pPr>
+            <a:r>
+              <a:rPr lang="en-US" sz="1350" b="1" dirty="0">
+                <a:solidFill>
+                  <a:srgbClr val="FFFFFF"/>
+                </a:solidFill>
+              </a:rPr>
+              <a:t>Denise Ferreira</a:t>
+            </a:r>
+            <a:endParaRPr lang="en-US" sz="1350" dirty="0"/>
+          </a:p>
+          <a:p>
+            <a:pPr indent="0" marL="0">
+              <a:buNone/>
+            </a:pPr>
+            <a:r>
+              <a:rPr lang="en-US" sz="1350" dirty="0">
+                <a:solidFill>
+                  <a:srgbClr val="FFFFFF"/>
+                </a:solidFill>
+              </a:rPr>
+              <a:t>denise@dfsindicos.com.br · +55 11 97322-5115</a:t>
+            </a:r>
+            <a:endParaRPr lang="en-US" sz="1350" dirty="0"/>
+          </a:p>
+          <a:p>
+            <a:pPr indent="0" marL="0">
+              <a:buNone/>
+            </a:pPr>
+            <a:r>
+              <a:rPr lang="en-US" sz="1350" b="1" dirty="0">
+                <a:solidFill>
+                  <a:srgbClr val="FFFFFF"/>
+                </a:solidFill>
+              </a:rPr>
+              <a:t>Caio Gavioli</a:t>
+            </a:r>
+            <a:endParaRPr lang="en-US" sz="1350" dirty="0"/>
+          </a:p>
+          <a:p>
+            <a:pPr indent="0" marL="0">
+              <a:buNone/>
+            </a:pPr>
+            <a:r>
+              <a:rPr lang="en-US" sz="1350" dirty="0">
+                <a:solidFill>
+                  <a:srgbClr val="FFFFFF"/>
+                </a:solidFill>
+              </a:rPr>
+              <a:t>caio@dfsindicos.com.br · +55 11 98323-1173</a:t>
+            </a:r>
+            <a:endParaRPr lang="en-US" sz="1350" dirty="0"/>
+          </a:p>
+          <a:p>
+            <a:pPr indent="0" marL="0">
+              <a:buNone/>
+            </a:pPr>
+            <a:r>
+              <a:rPr lang="en-US" sz="1350" dirty="0">
+                <a:solidFill>
+                  <a:srgbClr val="B8934A"/>
+                </a:solidFill>
+              </a:rPr>
+              <a:t>www.dfsindicos.com.br</a:t>
+            </a:r>
+            <a:endParaRPr lang="en-US" sz="1350" dirty="0"/>
+          </a:p>
+        </p:txBody>
+      </p:sp>
+    </p:spTree>
+  </p:cSld>
+  <p:clrMapOvr>
+    <a:masterClrMapping/>
+  </p:clrMapOvr>
+</p:sld>
+</file>
+
+<file path=ppt/slides/slide24.xml><?xml version="1.0" encoding="utf-8"?>
+<p:sld xmlns:a="http://schemas.openxmlformats.org/drawingml/2006/main" xmlns:r="http://schemas.openxmlformats.org/officeDocument/2006/relationships" xmlns:p="http://schemas.openxmlformats.org/presentationml/2006/main" show="0">
+  <p:cSld name="Slide 24">
+    <p:spTree>
+      <p:nvGrpSpPr>
+        <p:cNvPr id="1" name=""/>
+        <p:cNvGrpSpPr/>
+        <p:nvPr/>
+      </p:nvGrpSpPr>
+      <p:grpSpPr>
+        <a:xfrm>
+          <a:off x="0" y="0"/>
+          <a:ext cx="0" cy="0"/>
+          <a:chOff x="0" y="0"/>
+          <a:chExt cx="0" cy="0"/>
+        </a:xfrm>
+      </p:grpSpPr>
+      <p:sp>
+        <p:nvSpPr>
+          <p:cNvPr id="2" name="Text 1"/>
+          <p:cNvSpPr/>
+          <p:nvPr>
+            <p:ph idx="102" type="title" hasCustomPrompt="1"/>
+          </p:nvPr>
+        </p:nvSpPr>
+        <p:spPr>
+          <a:xfrm>
+            <a:off x="548640" y="320040"/>
+            <a:ext cx="10241280" cy="685800"/>
+          </a:xfrm>
+          <a:prstGeom prst="rect">
+            <a:avLst/>
+          </a:prstGeom>
+          <a:noFill/>
+          <a:ln/>
+        </p:spPr>
+        <p:txBody>
+          <a:bodyPr wrap="square" lIns="0" tIns="0" rIns="0" bIns="0" rtlCol="0" anchor="ctr"/>
+          <a:lstStyle/>
+          <a:p>
+            <a:pPr algn="l" indent="0" marL="0">
+              <a:buNone/>
+            </a:pPr>
+            <a:r>
+              <a:rPr lang="en-US" sz="3000" b="1" dirty="0">
+                <a:solidFill>
+                  <a:schemeClr val="tx2"/>
+                </a:solidFill>
+              </a:rPr>
               <a:t>Apoio: critérios de criticidade do Einstein</a:t>
             </a:r>
             <a:endParaRPr lang="en-US" sz="3000" dirty="0"/>
@@ -18150,7 +20773,7 @@
       </p:sp>
       <p:graphicFrame>
         <p:nvGraphicFramePr>
-          <p:cNvPr id="23" name="tabela-criticidade"/>
+          <p:cNvPr id="25" name="tabela-criticidade"/>
           <p:cNvGraphicFramePr>
             <a:graphicFrameLocks noGrp="1"/>
           </p:cNvGraphicFramePr>
@@ -19248,7 +21871,7 @@
             <a:pPr algn="r"/>
             <a:fld id="{F7021451-1387-4CA6-816F-3879F97B5CBC}" type="slidenum">
               <a:rPr b="0" lang="en-US"/>
-              <a:t>22</a:t>
+              <a:t>24</a:t>
             </a:fld>
             <a:endParaRPr lang="en-US"/>
           </a:p>
@@ -19262,9 +21885,9 @@
 </p:sld>
 </file>
 
-<file path=ppt/slides/slide23.xml><?xml version="1.0" encoding="utf-8"?>
+<file path=ppt/slides/slide25.xml><?xml version="1.0" encoding="utf-8"?>
 <p:sld xmlns:a="http://schemas.openxmlformats.org/drawingml/2006/main" xmlns:r="http://schemas.openxmlformats.org/officeDocument/2006/relationships" xmlns:p="http://schemas.openxmlformats.org/presentationml/2006/main" show="0">
-  <p:cSld name="Slide 23">
+  <p:cSld name="Slide 25">
     <p:spTree>
       <p:nvGrpSpPr>
         <p:cNvPr id="1" name=""/>
@@ -20244,7 +22867,7 @@
             <a:pPr algn="r"/>
             <a:fld id="{F7021451-1387-4CA6-816F-3879F97B5CBC}" type="slidenum">
               <a:rPr b="0" lang="en-US"/>
-              <a:t>23</a:t>
+              <a:t>25</a:t>
             </a:fld>
             <a:endParaRPr lang="en-US"/>
           </a:p>

</xml_diff>